<commit_message>
Day 2 deck round 8: variance slides Jan-Sep YTD, advisor 50/50 explained, tire balance gray marks in review
Co-Authored-By: Claude Opus 5.5 <noreply@anthropic.com>
Claude-Session: https://claude.ai/code/session_01Xa4nFVxuQGXmHARGph9WhS
</commit_message>
<xml_diff>
--- a/day2-deck/decks/Op Code Missed Opportunity - Review.pptx
+++ b/day2-deck/decks/Op Code Missed Opportunity - Review.pptx
@@ -595,39 +595,39 @@
           <a:p>
             <a:r>
               <a:rPr lang="en-US" dirty="0"/>
-              <a:t>Source: Qlik - Closed Repair Orders. Customer pay, Jan-Sep 2026 by close date, op code report basis. Same-store, INEOS excluded (opened 2026). Services short = benchmark x the store's CP ROs, minus the services it sold. Each service valued at the store's own labor + parts gross per service sold (group average where the store sold fewer than 30), capped at twice the group average because some flagged lines carry other work bundled on them. A year = Jan-Sep x 12 / 9. Stores at or above the benchmark are not shown and do not offset anyone. Alignment, tire balance, brake fluid and fuel system service added together, every store: gross a year above (+) or below (-) the four benchmarks, at the store's own gross per service. Below-benchmark services count against above-benchmark ones here.TOYOTA SPOKANE: −$541K a year against the four benchmarks; under 4 of 4
-CHEVY LV: −$475K a year against the four benchmarks; under 4 of 4
-TOYOTA FLAGSTAFF: −$356K a year against the four benchmarks; under 4 of 4
-TOYOTA HENDERSON: −$302K a year against the four benchmarks; under 3 of 4
-KIA LV: −$247K a year against the four benchmarks; under 4 of 4
-CDJR POST FALLS: −$245K a year against the four benchmarks; under 4 of 4
-TOYOTA PRESCOTT: −$233K a year against the four benchmarks; under 4 of 4
-AUDI RENO: −$216K a year against the four benchmarks; under 4 of 4
-HONDA FLAGSTAFF: −$200K a year against the four benchmarks; under 4 of 4
-NISSAN: −$200K a year against the four benchmarks; under 3 of 4
-HONDA SPOKANE: −$186K a year against the four benchmarks; under 3 of 4
-LEXUS: −$141K a year against the four benchmarks; under 4 of 4
-VW HENDERSON: −$140K a year against the four benchmarks; under 4 of 4
-CHEVY GMC BULLHEAD: −$133K a year against the four benchmarks; under 4 of 4
-CADILLAC: −$126K a year against the four benchmarks; under 4 of 4
-VW ST GEORGE: −$88K a year against the four benchmarks; under 4 of 4
-HYUNDAI ST GEORGE: −$81K a year against the four benchmarks; under 4 of 4
-GMC PRESCOTT: −$80K a year against the four benchmarks; under 4 of 4
-SUBARU LV: −$79K a year against the four benchmarks; under 3 of 4
-KIA ST GEORGE: −$70K a year against the four benchmarks; under 3 of 4
-LINCOLN: −$64K a year against the four benchmarks; under 3 of 4
-SUBARU ST GEORGE: −$55K a year against the four benchmarks; under 2 of 4
-LR RENO: −$43K a year against the four benchmarks; under 3 of 4
-VOLVO: −$38K a year against the four benchmarks; under 3 of 4
-MAZDA: −$38K a year against the four benchmarks; under 3 of 4
-AUDI HENDERSON: −$30K a year against the four benchmarks; under 3 of 4
-HYUNDAI PRESCOTT: +$31K a year against the four benchmarks; under 3 of 4
-ACURA: +$45K a year against the four benchmarks; under 1 of 4
-SUBARU PRESCOTT: +$55K a year against the four benchmarks; under 2 of 4
-HONDA NORTH: +$60K a year against the four benchmarks; under 1 of 4
-LR HENDERSON: +$72K a year against the four benchmarks; under 1 of 4
-LR LV: +$201K a year against the four benchmarks; under 1 of 4
-HONDA HENDERSON: +$743K a year against the four benchmarks; under 0 of 4</a:t>
+              <a:t>Source: Qlik - Closed Repair Orders. Customer pay, Jan-Sep 2026 by close date, op code report basis. Same-store, INEOS excluded (opened 2026). Services short = benchmark x the store's CP ROs, minus the services it sold. Each service valued at the store's own labor + parts gross per service sold (group average where the store sold fewer than 30), capped at twice the group average because some flagged lines carry other work bundled on them. Alignment, tire balance, brake fluid and fuel system service added together, every store: gross Jan-Sep 2026 above (+) or below (-) the four benchmarks, at the store's own gross per service. Below-benchmark services count against above-benchmark ones here.TOYOTA SPOKANE: −$406K Jan-Sep against the four benchmarks; under 4 of 4
+CHEVY LV: −$356K Jan-Sep against the four benchmarks; under 4 of 4
+TOYOTA FLAGSTAFF: −$267K Jan-Sep against the four benchmarks; under 4 of 4
+TOYOTA HENDERSON: −$227K Jan-Sep against the four benchmarks; under 3 of 4
+KIA LV: −$185K Jan-Sep against the four benchmarks; under 4 of 4
+CDJR POST FALLS: −$184K Jan-Sep against the four benchmarks; under 4 of 4
+TOYOTA PRESCOTT: −$175K Jan-Sep against the four benchmarks; under 4 of 4
+AUDI RENO: −$162K Jan-Sep against the four benchmarks; under 4 of 4
+HONDA FLAGSTAFF: −$150K Jan-Sep against the four benchmarks; under 4 of 4
+NISSAN: −$150K Jan-Sep against the four benchmarks; under 3 of 4
+HONDA SPOKANE: −$140K Jan-Sep against the four benchmarks; under 3 of 4
+LEXUS: −$105K Jan-Sep against the four benchmarks; under 4 of 4
+VW HENDERSON: −$105K Jan-Sep against the four benchmarks; under 4 of 4
+CHEVY GMC BULLHEAD: −$100K Jan-Sep against the four benchmarks; under 4 of 4
+CADILLAC: −$94K Jan-Sep against the four benchmarks; under 4 of 4
+VW ST GEORGE: −$66K Jan-Sep against the four benchmarks; under 4 of 4
+HYUNDAI ST GEORGE: −$61K Jan-Sep against the four benchmarks; under 4 of 4
+GMC PRESCOTT: −$60K Jan-Sep against the four benchmarks; under 4 of 4
+SUBARU LV: −$59K Jan-Sep against the four benchmarks; under 3 of 4
+KIA ST GEORGE: −$53K Jan-Sep against the four benchmarks; under 3 of 4
+LINCOLN: −$48K Jan-Sep against the four benchmarks; under 3 of 4
+SUBARU ST GEORGE: −$41K Jan-Sep against the four benchmarks; under 2 of 4
+LR RENO: −$32K Jan-Sep against the four benchmarks; under 3 of 4
+VOLVO: −$29K Jan-Sep against the four benchmarks; under 3 of 4
+MAZDA: −$28K Jan-Sep against the four benchmarks; under 3 of 4
+AUDI HENDERSON: −$22K Jan-Sep against the four benchmarks; under 3 of 4
+HYUNDAI PRESCOTT: +$23K Jan-Sep against the four benchmarks; under 3 of 4
+ACURA: +$33K Jan-Sep against the four benchmarks; under 1 of 4
+SUBARU PRESCOTT: +$41K Jan-Sep against the four benchmarks; under 2 of 4
+HONDA NORTH: +$45K Jan-Sep against the four benchmarks; under 1 of 4
+LR HENDERSON: +$54K Jan-Sep against the four benchmarks; under 1 of 4
+LR LV: +$151K Jan-Sep against the four benchmarks; under 1 of 4
+HONDA HENDERSON: +$557K Jan-Sep against the four benchmarks; under 0 of 4</a:t>
             </a:r>
             <a:endParaRPr lang="en-US" dirty="0"/>
           </a:p>
@@ -715,40 +715,40 @@
           <a:p>
             <a:r>
               <a:rPr lang="en-US" dirty="0"/>
-              <a:t>Source: Qlik - Closed Repair Orders. Customer pay, Jan-Sep 2026 by close date, op code report basis. Same-store, INEOS excluded (opened 2026). Services short = benchmark x the store's CP ROs, minus the services it sold. Each service valued at the store's own labor + parts gross per service sold (group average where the store sold fewer than 30), capped at twice the group average because some flagged lines carry other work bundled on them. A year = Jan-Sep x 12 / 9. Stores at or above the benchmark are not shown and do not offset anyone. Alignment: every store, gross a year above (+) or below (-) the benchmark at the store's own gross per service; group gross per service $129. Rate = Jan-Sep closing %.Near-zero stores are included on purpose (Noah, Oct 19 2026): some stores sell little of a service by OEM recommendation or local habit (e.g. Spokane customers swap seasonal tires, so fewer balances), but not every customer fits that pattern, so the opportunity is real. A store with a high RO count can show more opportunity than one selling at zero.
-TOYOTA SPOKANE: 4.2%, −$225K a year at $90/service
-TOYOTA FLAGSTAFF: 9.7%, −$90K a year at $84/service
-NISSAN: 7.4%, −$83K a year at $119/service
-KIA LV: 9.7%, −$77K a year at $135/service
-CHEVY LV: 12.8%, −$75K a year at $136/service
-CDJR POST FALLS: 4.2%, −$57K a year at $74/service
-TOYOTA PRESCOTT: 12.3%, −$49K a year at $103/service
-KIA ST GEORGE: 8.0%, −$38K a year at $105/service
-HONDA SPOKANE: 12.5%, −$36K a year at $124/service
-AUDI RENO: 11.8%, −$34K a year at $230/service
-TOYOTA HENDERSON: 14.5%, −$33K a year at $102/service
-LEXUS: 11.3%, −$33K a year at $147/service
-LINCOLN: 8.4%, −$26K a year at $114/service
-CHEVY GMC BULLHEAD: 11.1%, −$25K a year at $78/service
-VW HENDERSON: 13.6%, −$23K a year at $245/service
-SUBARU ST GEORGE: 11.0%, −$23K a year at $78/service
-HONDA FLAGSTAFF: 11.0%, −$21K a year at $100/service
-VW ST GEORGE: 5.6%, −$18K a year at $74/service
-SUBARU PRESCOTT: 12.5%, −$12K a year at $73/service
-GMC PRESCOTT: 11.7%, −$11K a year at $85/service
-LR RENO: 12.8%, −$10K a year at $259/service (capped; raw $715/service)
-SUBARU LV: 14.5%, −$10K a year at $117/service
-CADILLAC: 13.8%, −$9K a year at $115/service
-VOLVO: 13.8%, −$7K a year at $142/service
-HYUNDAI ST GEORGE: 14.8%, −$865 a year at $121/service
-ACURA: 17.5%, +$14K a year at $117/service
-MAZDA: 16.6%, +$17K a year at $132/service
-LR LV: 17.3%, +$23K a year at $210/service
-HONDA NORTH: 16.1%, +$27K a year at $112/service
-LR HENDERSON: 24.4%, +$41K a year at $209/service
-HYUNDAI PRESCOTT: 21.7%, +$42K a year at $228/service
-AUDI HENDERSON: 27.5%, +$163K a year at $259/service (capped; raw $390/service)
-HONDA HENDERSON: 21.3%, +$229K a year at $121/service</a:t>
+              <a:t>Source: Qlik - Closed Repair Orders. Customer pay, Jan-Sep 2026 by close date, op code report basis. Same-store, INEOS excluded (opened 2026). Services short = benchmark x the store's CP ROs, minus the services it sold. Each service valued at the store's own labor + parts gross per service sold (group average where the store sold fewer than 30), capped at twice the group average because some flagged lines carry other work bundled on them. Alignment: every store, gross Jan-Sep 2026 above (+) or below (-) the benchmark at the store's own gross per service; group gross per service $129. Rate = Jan-Sep closing %.Near-zero stores are included on purpose (Noah, Oct 19 2026): some stores sell little of a service by OEM recommendation or local habit (e.g. Spokane customers swap seasonal tires, so fewer balances), but not every customer fits that pattern, so the opportunity is real. A store with a high RO count can show more opportunity than one selling at zero.
+TOYOTA SPOKANE: 4.2%, −$169K Jan-Sep at $90/service
+TOYOTA FLAGSTAFF: 9.7%, −$67K Jan-Sep at $84/service
+NISSAN: 7.4%, −$62K Jan-Sep at $119/service
+KIA LV: 9.7%, −$58K Jan-Sep at $135/service
+CHEVY LV: 12.8%, −$57K Jan-Sep at $136/service
+CDJR POST FALLS: 4.2%, −$43K Jan-Sep at $74/service
+TOYOTA PRESCOTT: 12.3%, −$37K Jan-Sep at $103/service
+KIA ST GEORGE: 8.0%, −$29K Jan-Sep at $105/service
+HONDA SPOKANE: 12.5%, −$27K Jan-Sep at $124/service
+AUDI RENO: 11.8%, −$26K Jan-Sep at $230/service
+TOYOTA HENDERSON: 14.5%, −$25K Jan-Sep at $102/service
+LEXUS: 11.3%, −$24K Jan-Sep at $147/service
+LINCOLN: 8.4%, −$20K Jan-Sep at $114/service
+CHEVY GMC BULLHEAD: 11.1%, −$19K Jan-Sep at $78/service
+VW HENDERSON: 13.6%, −$18K Jan-Sep at $245/service
+SUBARU ST GEORGE: 11.0%, −$17K Jan-Sep at $78/service
+HONDA FLAGSTAFF: 11.0%, −$16K Jan-Sep at $100/service
+VW ST GEORGE: 5.6%, −$13K Jan-Sep at $74/service
+SUBARU PRESCOTT: 12.5%, −$9K Jan-Sep at $73/service
+GMC PRESCOTT: 11.7%, −$9K Jan-Sep at $85/service
+LR RENO: 12.8%, −$8K Jan-Sep at $259/service (capped; raw $715/service)
+SUBARU LV: 14.5%, −$7K Jan-Sep at $117/service
+CADILLAC: 13.8%, −$7K Jan-Sep at $115/service
+VOLVO: 13.8%, −$5K Jan-Sep at $142/service
+HYUNDAI ST GEORGE: 14.8%, −$649 Jan-Sep at $121/service
+ACURA: 17.5%, +$11K Jan-Sep at $117/service
+MAZDA: 16.6%, +$13K Jan-Sep at $132/service
+LR LV: 17.3%, +$18K Jan-Sep at $210/service
+HONDA NORTH: 16.1%, +$20K Jan-Sep at $112/service
+LR HENDERSON: 24.4%, +$31K Jan-Sep at $209/service
+HYUNDAI PRESCOTT: 21.7%, +$31K Jan-Sep at $228/service
+AUDI HENDERSON: 27.5%, +$123K Jan-Sep at $259/service (capped; raw $390/service)
+HONDA HENDERSON: 21.3%, +$171K Jan-Sep at $121/service</a:t>
             </a:r>
             <a:endParaRPr lang="en-US" dirty="0"/>
           </a:p>
@@ -836,40 +836,40 @@
           <a:p>
             <a:r>
               <a:rPr lang="en-US" dirty="0"/>
-              <a:t>Source: Qlik - Closed Repair Orders. Customer pay, Jan-Sep 2026 by close date, op code report basis. Same-store, INEOS excluded (opened 2026). Services short = benchmark x the store's CP ROs, minus the services it sold. Each service valued at the store's own labor + parts gross per service sold (group average where the store sold fewer than 30), capped at twice the group average because some flagged lines carry other work bundled on them. A year = Jan-Sep x 12 / 9. Stores at or above the benchmark are not shown and do not offset anyone. Tire Balance: every store, gross a year above (+) or below (-) the benchmark at the store's own gross per service; group gross per service $75. Rate = Jan-Sep closing %.Near-zero stores are included on purpose (Noah, Oct 19 2026): some stores sell little of a service by OEM recommendation or local habit (e.g. Spokane customers swap seasonal tires, so fewer balances), but not every customer fits that pattern, so the opportunity is real. A store with a high RO count can show more opportunity than one selling at zero.
-TOYOTA SPOKANE: 0.4%, −$180K a year at $53/service
-TOYOTA HENDERSON: 11.2%, −$147K a year at $55/service
-TOYOTA PRESCOTT: 6.1%, −$132K a year at $83/service
-SUBARU ST GEORGE: 3.6%, −$125K a year at $149/service (capped; raw $247/service)
-TOYOTA FLAGSTAFF: 4.9%, −$109K a year at $54/service
-CHEVY LV: 7.3%, −$106K a year at $53/service
-HONDA SPOKANE: 2.1%, −$80K a year at $52/service
-NISSAN: 1.0%, −$77K a year at $59/service
-CDJR POST FALLS: 1.2%, −$73K a year at $75/service
-KIA LV: 5.2%, −$72K a year at $68/service
-LEXUS: 0.0%, −$68K a year at $75/service (group avg)
-SUBARU LV: 10.2%, −$68K a year at $75/service
-AUDI HENDERSON: 0.0%, −$56K a year at $75/service (group avg)
-AUDI RENO: 0.1%, −$52K a year at $75/service (group avg)
-HONDA FLAGSTAFF: 1.3%, −$52K a year at $70/service
-HONDA NORTH: 12.0%, −$38K a year at $64/service
-HYUNDAI ST GEORGE: 1.2%, −$36K a year at $58/service
-LINCOLN: 1.6%, −$31K a year at $66/service
-VW ST GEORGE: 0.4%, −$28K a year at $75/service (group avg)
-VW HENDERSON: 8.2%, −$27K a year at $60/service
-GMC PRESCOTT: 7.7%, −$27K a year at $90/service
-CHEVY GMC BULLHEAD: 9.0%, −$21K a year at $42/service
-KIA ST GEORGE: 7.7%, −$18K a year at $48/service
-CADILLAC: 5.9%, −$14K a year at $22/service
-MAZDA: 13.1%, −$11K a year at $79/service
-VOLVO: 11.7%, −$8K a year at $51/service
-HYUNDAI PRESCOTT: 13.5%, −$6K a year at $149/service (capped; raw $311/service)
-ACURA: 14.1%, −$3K a year at $64/service
-SUBARU PRESCOTT: 14.9%, −$34 a year at $34/service
-LR RENO: 16.9%, +$6K a year at $149/service (capped; raw $647/service)
-LR LV: 16.9%, +$14K a year at $149/service
-LR HENDERSON: 27.0%, +$31K a year at $122/service
-HONDA HENDERSON: 18.4%, +$70K a year at $68/service</a:t>
+              <a:t>Source: Qlik - Closed Repair Orders. Customer pay, Jan-Sep 2026 by close date, op code report basis. Same-store, INEOS excluded (opened 2026). Services short = benchmark x the store's CP ROs, minus the services it sold. Each service valued at the store's own labor + parts gross per service sold (group average where the store sold fewer than 30), capped at twice the group average because some flagged lines carry other work bundled on them. Tire Balance: every store, gross Jan-Sep 2026 above (+) or below (-) the benchmark at the store's own gross per service; group gross per service $75. Rate = Jan-Sep closing %.Near-zero stores are included on purpose (Noah, Oct 19 2026): some stores sell little of a service by OEM recommendation or local habit (e.g. Spokane customers swap seasonal tires, so fewer balances), but not every customer fits that pattern, so the opportunity is real. A store with a high RO count can show more opportunity than one selling at zero.
+TOYOTA SPOKANE: 0.4%, −$135K Jan-Sep at $53/service
+TOYOTA HENDERSON: 11.2%, −$111K Jan-Sep at $55/service
+TOYOTA PRESCOTT: 6.1%, −$99K Jan-Sep at $83/service
+SUBARU ST GEORGE: 3.6%, −$94K Jan-Sep at $149/service (capped; raw $247/service)
+TOYOTA FLAGSTAFF: 4.9%, −$82K Jan-Sep at $54/service
+CHEVY LV: 7.3%, −$80K Jan-Sep at $53/service
+HONDA SPOKANE: 2.1%, −$60K Jan-Sep at $52/service
+NISSAN: 1.0%, −$58K Jan-Sep at $59/service
+CDJR POST FALLS: 1.2%, −$55K Jan-Sep at $75/service
+KIA LV: 5.2%, −$54K Jan-Sep at $68/service
+LEXUS: 0.0%, −$51K Jan-Sep at $75/service (group avg)
+SUBARU LV: 10.2%, −$51K Jan-Sep at $75/service
+AUDI HENDERSON: 0.0%, −$42K Jan-Sep at $75/service (group avg)
+AUDI RENO: 0.1%, −$39K Jan-Sep at $75/service (group avg)
+HONDA FLAGSTAFF: 1.3%, −$39K Jan-Sep at $70/service
+HONDA NORTH: 12.0%, −$29K Jan-Sep at $64/service
+HYUNDAI ST GEORGE: 1.2%, −$27K Jan-Sep at $58/service
+LINCOLN: 1.6%, −$23K Jan-Sep at $66/service
+VW ST GEORGE: 0.4%, −$21K Jan-Sep at $75/service (group avg)
+VW HENDERSON: 8.2%, −$21K Jan-Sep at $60/service
+GMC PRESCOTT: 7.7%, −$20K Jan-Sep at $90/service
+CHEVY GMC BULLHEAD: 9.0%, −$16K Jan-Sep at $42/service
+KIA ST GEORGE: 7.7%, −$14K Jan-Sep at $48/service
+CADILLAC: 5.9%, −$11K Jan-Sep at $22/service
+MAZDA: 13.1%, −$8K Jan-Sep at $79/service
+VOLVO: 11.7%, −$6K Jan-Sep at $51/service
+HYUNDAI PRESCOTT: 13.5%, −$4K Jan-Sep at $149/service (capped; raw $311/service)
+ACURA: 14.1%, −$2K Jan-Sep at $64/service
+SUBARU PRESCOTT: 14.9%, −$26 Jan-Sep at $34/service
+LR RENO: 16.9%, +$4K Jan-Sep at $149/service (capped; raw $647/service)
+LR LV: 16.9%, +$10K Jan-Sep at $149/service
+LR HENDERSON: 27.0%, +$23K Jan-Sep at $122/service
+HONDA HENDERSON: 18.4%, +$52K Jan-Sep at $68/service</a:t>
             </a:r>
             <a:endParaRPr lang="en-US" dirty="0"/>
           </a:p>
@@ -957,40 +957,40 @@
           <a:p>
             <a:r>
               <a:rPr lang="en-US" dirty="0"/>
-              <a:t>Source: Qlik - Closed Repair Orders. Customer pay, Jan-Sep 2026 by close date, op code report basis. Same-store, INEOS excluded (opened 2026). Services short = benchmark x the store's CP ROs, minus the services it sold. Each service valued at the store's own labor + parts gross per service sold (group average where the store sold fewer than 30), capped at twice the group average because some flagged lines carry other work bundled on them. A year = Jan-Sep x 12 / 9. Stores at or above the benchmark are not shown and do not offset anyone. Brake Fluid: every store, gross a year above (+) or below (-) the benchmark at the store's own gross per service; group gross per service $189. Rate = Jan-Sep closing %.Near-zero stores are included on purpose (Noah, Oct 19 2026): some stores sell little of a service by OEM recommendation or local habit (e.g. Spokane customers swap seasonal tires, so fewer balances), but not every customer fits that pattern, so the opportunity is real. A store with a high RO count can show more opportunity than one selling at zero.
-CHEVY LV: 5.7%, −$151K a year at $138/service
-TOYOTA SPOKANE: 7.0%, −$80K a year at $117/service
-AUDI RENO: 1.9%, −$78K a year at $206/service
-AUDI HENDERSON: 2.4%, −$74K a year at $196/service
-HONDA FLAGSTAFF: 3.1%, −$67K a year at $184/service
-CADILLAC: 4.6%, −$57K a year at $150/service
-CDJR POST FALLS: 4.2%, −$53K a year at $128/service
-TOYOTA FLAGSTAFF: 8.0%, −$48K a year at $123/service
-TOYOTA PRESCOTT: 8.4%, −$32K a year at $112/service
-HYUNDAI ST GEORGE: 4.7%, −$32K a year at $134/service
-KIA ST GEORGE: 5.9%, −$25K a year at $119/service
-KIA LV: 8.2%, −$22K a year at $120/service
-CHEVY GMC BULLHEAD: 7.0%, −$21K a year at $87/service
-GMC PRESCOTT: 6.0%, −$21K a year at $127/service
-LR RENO: 7.2%, −$20K a year at $377/service (capped; raw $1,380/service)
-MAZDA: 8.4%, −$18K a year at $154/service
-LEXUS: 8.3%, −$15K a year at $154/service
-VW ST GEORGE: 5.4%, −$13K a year at $111/service
-LINCOLN: 7.5%, −$11K a year at $126/service
-VW HENDERSON: 9.5%, −$4K a year at $134/service
-HYUNDAI PRESCOTT: 9.6%, −$3K a year at $354/service
-HONDA SPOKANE: 10.3%, +$5K a year at $126/service
-TOYOTA HENDERSON: 10.0%, +$7K a year at $141/service
-SUBARU LV: 10.1%, +$9K a year at $333/service
-SUBARU PRESCOTT: 10.6%, +$16K a year at $377/service (capped; raw $380/service)
-ACURA: 12.7%, +$20K a year at $147/service
-SUBARU ST GEORGE: 10.7%, +$21K a year at $377/service (capped; raw $489/service)
-NISSAN: 11.6%, +$24K a year at $155/service
-VOLVO: 11.9%, +$33K a year at $377/service (capped; raw $538/service)
-LR HENDERSON: 14.3%, +$34K a year at $377/service (capped; raw $709/service)
-HONDA NORTH: 12.1%, +$67K a year at $160/service
-LR LV: 20.6%, +$187K a year at $377/service (capped; raw $424/service)
-HONDA HENDERSON: 15.5%, +$260K a year at $155/service</a:t>
+              <a:t>Source: Qlik - Closed Repair Orders. Customer pay, Jan-Sep 2026 by close date, op code report basis. Same-store, INEOS excluded (opened 2026). Services short = benchmark x the store's CP ROs, minus the services it sold. Each service valued at the store's own labor + parts gross per service sold (group average where the store sold fewer than 30), capped at twice the group average because some flagged lines carry other work bundled on them. Brake Fluid: every store, gross Jan-Sep 2026 above (+) or below (-) the benchmark at the store's own gross per service; group gross per service $189. Rate = Jan-Sep closing %.Near-zero stores are included on purpose (Noah, Oct 19 2026): some stores sell little of a service by OEM recommendation or local habit (e.g. Spokane customers swap seasonal tires, so fewer balances), but not every customer fits that pattern, so the opportunity is real. A store with a high RO count can show more opportunity than one selling at zero.
+CHEVY LV: 5.7%, −$113K Jan-Sep at $138/service
+TOYOTA SPOKANE: 7.0%, −$60K Jan-Sep at $117/service
+AUDI RENO: 1.9%, −$58K Jan-Sep at $206/service
+AUDI HENDERSON: 2.4%, −$56K Jan-Sep at $196/service
+HONDA FLAGSTAFF: 3.1%, −$51K Jan-Sep at $184/service
+CADILLAC: 4.6%, −$43K Jan-Sep at $150/service
+CDJR POST FALLS: 4.2%, −$39K Jan-Sep at $128/service
+TOYOTA FLAGSTAFF: 8.0%, −$36K Jan-Sep at $123/service
+TOYOTA PRESCOTT: 8.4%, −$24K Jan-Sep at $112/service
+HYUNDAI ST GEORGE: 4.7%, −$24K Jan-Sep at $134/service
+KIA ST GEORGE: 5.9%, −$19K Jan-Sep at $119/service
+KIA LV: 8.2%, −$17K Jan-Sep at $120/service
+CHEVY GMC BULLHEAD: 7.0%, −$16K Jan-Sep at $87/service
+GMC PRESCOTT: 6.0%, −$15K Jan-Sep at $127/service
+LR RENO: 7.2%, −$15K Jan-Sep at $377/service (capped; raw $1,380/service)
+MAZDA: 8.4%, −$13K Jan-Sep at $154/service
+LEXUS: 8.3%, −$11K Jan-Sep at $154/service
+VW ST GEORGE: 5.4%, −$10K Jan-Sep at $111/service
+LINCOLN: 7.5%, −$8K Jan-Sep at $126/service
+VW HENDERSON: 9.5%, −$3K Jan-Sep at $134/service
+HYUNDAI PRESCOTT: 9.6%, −$2K Jan-Sep at $354/service
+HONDA SPOKANE: 10.3%, +$4K Jan-Sep at $126/service
+TOYOTA HENDERSON: 10.0%, +$5K Jan-Sep at $141/service
+SUBARU LV: 10.1%, +$7K Jan-Sep at $333/service
+SUBARU PRESCOTT: 10.6%, +$12K Jan-Sep at $377/service (capped; raw $380/service)
+ACURA: 12.7%, +$15K Jan-Sep at $147/service
+SUBARU ST GEORGE: 10.7%, +$16K Jan-Sep at $377/service (capped; raw $489/service)
+NISSAN: 11.6%, +$18K Jan-Sep at $155/service
+VOLVO: 11.9%, +$24K Jan-Sep at $377/service (capped; raw $538/service)
+LR HENDERSON: 14.3%, +$25K Jan-Sep at $377/service (capped; raw $709/service)
+HONDA NORTH: 12.1%, +$51K Jan-Sep at $160/service
+LR LV: 20.6%, +$141K Jan-Sep at $377/service (capped; raw $424/service)
+HONDA HENDERSON: 15.5%, +$195K Jan-Sep at $155/service</a:t>
             </a:r>
             <a:endParaRPr lang="en-US" dirty="0"/>
           </a:p>
@@ -1078,40 +1078,40 @@
           <a:p>
             <a:r>
               <a:rPr lang="en-US" dirty="0"/>
-              <a:t>Source: Qlik - Closed Repair Orders. Customer pay, Jan-Sep 2026 by close date, op code report basis. Same-store, INEOS excluded (opened 2026). Services short = benchmark x the store's CP ROs, minus the services it sold. Each service valued at the store's own labor + parts gross per service sold (group average where the store sold fewer than 30), capped at twice the group average because some flagged lines carry other work bundled on them. A year = Jan-Sep x 12 / 9. Stores at or above the benchmark are not shown and do not offset anyone. Fuel System Service: every store, gross a year above (+) or below (-) the benchmark at the store's own gross per service; group gross per service $165. Rate = Jan-Sep closing %.Near-zero stores are included on purpose (Noah, Oct 19 2026): some stores sell little of a service by OEM recommendation or local habit (e.g. Spokane customers swap seasonal tires, so fewer balances), but not every customer fits that pattern, so the opportunity is real. A store with a high RO count can show more opportunity than one selling at zero.
-CHEVY LV: 5.2%, −$142K a year at $243/service
-TOYOTA HENDERSON: 6.0%, −$129K a year at $122/service
-TOYOTA FLAGSTAFF: 1.6%, −$109K a year at $93/service
-VW HENDERSON: 0.0%, −$85K a year at $165/service (group avg)
-KIA LV: 3.2%, −$76K a year at $163/service
-HONDA SPOKANE: 3.2%, −$75K a year at $147/service
-CHEVY GMC BULLHEAD: 2.7%, −$65K a year at $163/service
-NISSAN: 4.1%, −$64K a year at $206/service
-AUDI HENDERSON: 0.0%, −$62K a year at $165/service (group avg)
-CDJR POST FALLS: 3.0%, −$62K a year at $192/service
-HONDA FLAGSTAFF: 0.7%, −$60K a year at $165/service (group avg)
-TOYOTA SPOKANE: 5.8%, −$56K a year at $145/service
-VOLVO: 0.0%, −$56K a year at $165/service (group avg)
-AUDI RENO: 0.8%, −$51K a year at $165/service (group avg)
-CADILLAC: 5.1%, −$46K a year at $269/service
-LR HENDERSON: 2.5%, −$34K a year at $329/service (capped; raw $774/service)
-VW ST GEORGE: 2.7%, −$29K a year at $236/service
-MAZDA: 5.2%, −$26K a year at $150/service
-LEXUS: 4.2%, −$25K a year at $128/service
-LR LV: 5.5%, −$24K a year at $258/service
-GMC PRESCOTT: 3.6%, −$21K a year at $133/service
-TOYOTA PRESCOTT: 6.4%, −$19K a year at $101/service
-LR RENO: 4.5%, −$18K a year at $329/service (capped; raw $1,631/service)
-HYUNDAI ST GEORGE: 5.8%, −$13K a year at $176/service
-SUBARU LV: 7.0%, −$10K a year at $130/service
-HYUNDAI PRESCOTT: 7.3%, −$1K a year at $329/service (capped; raw $459/service)
-HONDA NORTH: 7.6%, +$4K a year at $118/service
-LINCOLN: 8.2%, +$4K a year at $175/service
-KIA ST GEORGE: 8.9%, +$12K a year at $154/service
-ACURA: 9.3%, +$13K a year at $145/service
-SUBARU PRESCOTT: 9.7%, +$51K a year at $329/service (capped; raw $406/service)
-SUBARU ST GEORGE: 13.8%, +$72K a year at $153/service
-HONDA HENDERSON: 12.0%, +$185K a year at $135/service</a:t>
+              <a:t>Source: Qlik - Closed Repair Orders. Customer pay, Jan-Sep 2026 by close date, op code report basis. Same-store, INEOS excluded (opened 2026). Services short = benchmark x the store's CP ROs, minus the services it sold. Each service valued at the store's own labor + parts gross per service sold (group average where the store sold fewer than 30), capped at twice the group average because some flagged lines carry other work bundled on them. Fuel System Service: every store, gross Jan-Sep 2026 above (+) or below (-) the benchmark at the store's own gross per service; group gross per service $165. Rate = Jan-Sep closing %.Near-zero stores are included on purpose (Noah, Oct 19 2026): some stores sell little of a service by OEM recommendation or local habit (e.g. Spokane customers swap seasonal tires, so fewer balances), but not every customer fits that pattern, so the opportunity is real. A store with a high RO count can show more opportunity than one selling at zero.
+CHEVY LV: 5.2%, −$107K Jan-Sep at $243/service
+TOYOTA HENDERSON: 6.0%, −$96K Jan-Sep at $122/service
+TOYOTA FLAGSTAFF: 1.6%, −$82K Jan-Sep at $93/service
+VW HENDERSON: 0.0%, −$63K Jan-Sep at $165/service (group avg)
+KIA LV: 3.2%, −$57K Jan-Sep at $163/service
+HONDA SPOKANE: 3.2%, −$56K Jan-Sep at $147/service
+CHEVY GMC BULLHEAD: 2.7%, −$49K Jan-Sep at $163/service
+NISSAN: 4.1%, −$48K Jan-Sep at $206/service
+AUDI HENDERSON: 0.0%, −$47K Jan-Sep at $165/service (group avg)
+CDJR POST FALLS: 3.0%, −$46K Jan-Sep at $192/service
+HONDA FLAGSTAFF: 0.7%, −$45K Jan-Sep at $165/service (group avg)
+TOYOTA SPOKANE: 5.8%, −$42K Jan-Sep at $145/service
+VOLVO: 0.0%, −$42K Jan-Sep at $165/service (group avg)
+AUDI RENO: 0.8%, −$39K Jan-Sep at $165/service (group avg)
+CADILLAC: 5.1%, −$34K Jan-Sep at $269/service
+LR HENDERSON: 2.5%, −$25K Jan-Sep at $329/service (capped; raw $774/service)
+VW ST GEORGE: 2.7%, −$22K Jan-Sep at $236/service
+MAZDA: 5.2%, −$20K Jan-Sep at $150/service
+LEXUS: 4.2%, −$19K Jan-Sep at $128/service
+LR LV: 5.5%, −$18K Jan-Sep at $258/service
+GMC PRESCOTT: 3.6%, −$16K Jan-Sep at $133/service
+TOYOTA PRESCOTT: 6.4%, −$14K Jan-Sep at $101/service
+LR RENO: 4.5%, −$14K Jan-Sep at $329/service (capped; raw $1,631/service)
+HYUNDAI ST GEORGE: 5.8%, −$10K Jan-Sep at $176/service
+SUBARU LV: 7.0%, −$8K Jan-Sep at $130/service
+HYUNDAI PRESCOTT: 7.3%, −$905 Jan-Sep at $329/service (capped; raw $459/service)
+HONDA NORTH: 7.6%, +$3K Jan-Sep at $118/service
+LINCOLN: 8.2%, +$3K Jan-Sep at $175/service
+KIA ST GEORGE: 8.9%, +$9K Jan-Sep at $154/service
+ACURA: 9.3%, +$10K Jan-Sep at $145/service
+SUBARU PRESCOTT: 9.7%, +$39K Jan-Sep at $329/service (capped; raw $406/service)
+SUBARU ST GEORGE: 13.8%, +$54K Jan-Sep at $153/service
+HONDA HENDERSON: 12.0%, +$138K Jan-Sep at $135/service</a:t>
             </a:r>
             <a:endParaRPr lang="en-US" dirty="0"/>
           </a:p>
@@ -2491,7 +2491,7 @@
                 <a:ea typeface="Inter" pitchFamily="34" charset="-122"/>
                 <a:cs typeface="Inter" pitchFamily="34" charset="-120"/>
               </a:rPr>
-              <a:t>OPCODES · JAN–SEP 2026, ANNUALIZED</a:t>
+              <a:t>OPCODES · JAN–SEP 2026 YTD</a:t>
             </a:r>
             <a:endParaRPr lang="en-US" sz="1400" dirty="0"/>
           </a:p>
@@ -2805,7 +2805,7 @@
                 <a:ea typeface="Inter" pitchFamily="34" charset="-122"/>
                 <a:cs typeface="Inter" pitchFamily="34" charset="-120"/>
               </a:rPr>
-              <a:t>+$743K</a:t>
+              <a:t>+$557K</a:t>
             </a:r>
             <a:endParaRPr lang="en-US" sz="1300" dirty="0"/>
           </a:p>
@@ -2942,7 +2942,7 @@
                 <a:ea typeface="Inter" pitchFamily="34" charset="-122"/>
                 <a:cs typeface="Inter" pitchFamily="34" charset="-120"/>
               </a:rPr>
-              <a:t>+$201K</a:t>
+              <a:t>+$151K</a:t>
             </a:r>
             <a:endParaRPr lang="en-US" sz="1300" dirty="0"/>
           </a:p>
@@ -3079,7 +3079,7 @@
                 <a:ea typeface="Inter" pitchFamily="34" charset="-122"/>
                 <a:cs typeface="Inter" pitchFamily="34" charset="-120"/>
               </a:rPr>
-              <a:t>+$72K</a:t>
+              <a:t>+$54K</a:t>
             </a:r>
             <a:endParaRPr lang="en-US" sz="1300" dirty="0"/>
           </a:p>
@@ -3216,7 +3216,7 @@
                 <a:ea typeface="Inter" pitchFamily="34" charset="-122"/>
                 <a:cs typeface="Inter" pitchFamily="34" charset="-120"/>
               </a:rPr>
-              <a:t>+$60K</a:t>
+              <a:t>+$45K</a:t>
             </a:r>
             <a:endParaRPr lang="en-US" sz="1300" dirty="0"/>
           </a:p>
@@ -3353,7 +3353,7 @@
                 <a:ea typeface="Inter" pitchFamily="34" charset="-122"/>
                 <a:cs typeface="Inter" pitchFamily="34" charset="-120"/>
               </a:rPr>
-              <a:t>+$55K</a:t>
+              <a:t>+$41K</a:t>
             </a:r>
             <a:endParaRPr lang="en-US" sz="1300" dirty="0"/>
           </a:p>
@@ -3490,7 +3490,7 @@
                 <a:ea typeface="Inter" pitchFamily="34" charset="-122"/>
                 <a:cs typeface="Inter" pitchFamily="34" charset="-120"/>
               </a:rPr>
-              <a:t>+$45K</a:t>
+              <a:t>+$33K</a:t>
             </a:r>
             <a:endParaRPr lang="en-US" sz="1300" dirty="0"/>
           </a:p>
@@ -3627,7 +3627,7 @@
                 <a:ea typeface="Inter" pitchFamily="34" charset="-122"/>
                 <a:cs typeface="Inter" pitchFamily="34" charset="-120"/>
               </a:rPr>
-              <a:t>+$31K</a:t>
+              <a:t>+$23K</a:t>
             </a:r>
             <a:endParaRPr lang="en-US" sz="1300" dirty="0"/>
           </a:p>
@@ -3764,7 +3764,7 @@
                 <a:ea typeface="Inter" pitchFamily="34" charset="-122"/>
                 <a:cs typeface="Inter" pitchFamily="34" charset="-120"/>
               </a:rPr>
-              <a:t>−$30K</a:t>
+              <a:t>−$22K</a:t>
             </a:r>
             <a:endParaRPr lang="en-US" sz="1300" dirty="0"/>
           </a:p>
@@ -3901,7 +3901,7 @@
                 <a:ea typeface="Inter" pitchFamily="34" charset="-122"/>
                 <a:cs typeface="Inter" pitchFamily="34" charset="-120"/>
               </a:rPr>
-              <a:t>−$38K</a:t>
+              <a:t>−$28K</a:t>
             </a:r>
             <a:endParaRPr lang="en-US" sz="1300" dirty="0"/>
           </a:p>
@@ -4038,7 +4038,7 @@
                 <a:ea typeface="Inter" pitchFamily="34" charset="-122"/>
                 <a:cs typeface="Inter" pitchFamily="34" charset="-120"/>
               </a:rPr>
-              <a:t>−$38K</a:t>
+              <a:t>−$29K</a:t>
             </a:r>
             <a:endParaRPr lang="en-US" sz="1300" dirty="0"/>
           </a:p>
@@ -4175,7 +4175,7 @@
                 <a:ea typeface="Inter" pitchFamily="34" charset="-122"/>
                 <a:cs typeface="Inter" pitchFamily="34" charset="-120"/>
               </a:rPr>
-              <a:t>−$43K</a:t>
+              <a:t>−$32K</a:t>
             </a:r>
             <a:endParaRPr lang="en-US" sz="1300" dirty="0"/>
           </a:p>
@@ -4312,7 +4312,7 @@
                 <a:ea typeface="Inter" pitchFamily="34" charset="-122"/>
                 <a:cs typeface="Inter" pitchFamily="34" charset="-120"/>
               </a:rPr>
-              <a:t>−$55K</a:t>
+              <a:t>−$41K</a:t>
             </a:r>
             <a:endParaRPr lang="en-US" sz="1300" dirty="0"/>
           </a:p>
@@ -4449,7 +4449,7 @@
                 <a:ea typeface="Inter" pitchFamily="34" charset="-122"/>
                 <a:cs typeface="Inter" pitchFamily="34" charset="-120"/>
               </a:rPr>
-              <a:t>−$64K</a:t>
+              <a:t>−$48K</a:t>
             </a:r>
             <a:endParaRPr lang="en-US" sz="1300" dirty="0"/>
           </a:p>
@@ -4586,7 +4586,7 @@
                 <a:ea typeface="Inter" pitchFamily="34" charset="-122"/>
                 <a:cs typeface="Inter" pitchFamily="34" charset="-120"/>
               </a:rPr>
-              <a:t>−$70K</a:t>
+              <a:t>−$53K</a:t>
             </a:r>
             <a:endParaRPr lang="en-US" sz="1300" dirty="0"/>
           </a:p>
@@ -4723,7 +4723,7 @@
                 <a:ea typeface="Inter" pitchFamily="34" charset="-122"/>
                 <a:cs typeface="Inter" pitchFamily="34" charset="-120"/>
               </a:rPr>
-              <a:t>−$79K</a:t>
+              <a:t>−$59K</a:t>
             </a:r>
             <a:endParaRPr lang="en-US" sz="1300" dirty="0"/>
           </a:p>
@@ -4860,7 +4860,7 @@
                 <a:ea typeface="Inter" pitchFamily="34" charset="-122"/>
                 <a:cs typeface="Inter" pitchFamily="34" charset="-120"/>
               </a:rPr>
-              <a:t>−$80K</a:t>
+              <a:t>−$60K</a:t>
             </a:r>
             <a:endParaRPr lang="en-US" sz="1300" dirty="0"/>
           </a:p>
@@ -4997,7 +4997,7 @@
                 <a:ea typeface="Inter" pitchFamily="34" charset="-122"/>
                 <a:cs typeface="Inter" pitchFamily="34" charset="-120"/>
               </a:rPr>
-              <a:t>−$81K</a:t>
+              <a:t>−$61K</a:t>
             </a:r>
             <a:endParaRPr lang="en-US" sz="1300" dirty="0"/>
           </a:p>
@@ -5134,7 +5134,7 @@
                 <a:ea typeface="Inter" pitchFamily="34" charset="-122"/>
                 <a:cs typeface="Inter" pitchFamily="34" charset="-120"/>
               </a:rPr>
-              <a:t>−$88K</a:t>
+              <a:t>−$66K</a:t>
             </a:r>
             <a:endParaRPr lang="en-US" sz="1300" dirty="0"/>
           </a:p>
@@ -5271,7 +5271,7 @@
                 <a:ea typeface="Inter" pitchFamily="34" charset="-122"/>
                 <a:cs typeface="Inter" pitchFamily="34" charset="-120"/>
               </a:rPr>
-              <a:t>−$126K</a:t>
+              <a:t>−$94K</a:t>
             </a:r>
             <a:endParaRPr lang="en-US" sz="1300" dirty="0"/>
           </a:p>
@@ -5408,7 +5408,7 @@
                 <a:ea typeface="Inter" pitchFamily="34" charset="-122"/>
                 <a:cs typeface="Inter" pitchFamily="34" charset="-120"/>
               </a:rPr>
-              <a:t>−$133K</a:t>
+              <a:t>−$100K</a:t>
             </a:r>
             <a:endParaRPr lang="en-US" sz="1300" dirty="0"/>
           </a:p>
@@ -5545,7 +5545,7 @@
                 <a:ea typeface="Inter" pitchFamily="34" charset="-122"/>
                 <a:cs typeface="Inter" pitchFamily="34" charset="-120"/>
               </a:rPr>
-              <a:t>−$140K</a:t>
+              <a:t>−$105K</a:t>
             </a:r>
             <a:endParaRPr lang="en-US" sz="1300" dirty="0"/>
           </a:p>
@@ -5682,7 +5682,7 @@
                 <a:ea typeface="Inter" pitchFamily="34" charset="-122"/>
                 <a:cs typeface="Inter" pitchFamily="34" charset="-120"/>
               </a:rPr>
-              <a:t>−$141K</a:t>
+              <a:t>−$105K</a:t>
             </a:r>
             <a:endParaRPr lang="en-US" sz="1300" dirty="0"/>
           </a:p>
@@ -5819,7 +5819,7 @@
                 <a:ea typeface="Inter" pitchFamily="34" charset="-122"/>
                 <a:cs typeface="Inter" pitchFamily="34" charset="-120"/>
               </a:rPr>
-              <a:t>−$186K</a:t>
+              <a:t>−$140K</a:t>
             </a:r>
             <a:endParaRPr lang="en-US" sz="1300" dirty="0"/>
           </a:p>
@@ -5956,7 +5956,7 @@
                 <a:ea typeface="Inter" pitchFamily="34" charset="-122"/>
                 <a:cs typeface="Inter" pitchFamily="34" charset="-120"/>
               </a:rPr>
-              <a:t>−$200K</a:t>
+              <a:t>−$150K</a:t>
             </a:r>
             <a:endParaRPr lang="en-US" sz="1300" dirty="0"/>
           </a:p>
@@ -6093,7 +6093,7 @@
                 <a:ea typeface="Inter" pitchFamily="34" charset="-122"/>
                 <a:cs typeface="Inter" pitchFamily="34" charset="-120"/>
               </a:rPr>
-              <a:t>−$200K</a:t>
+              <a:t>−$150K</a:t>
             </a:r>
             <a:endParaRPr lang="en-US" sz="1300" dirty="0"/>
           </a:p>
@@ -6230,7 +6230,7 @@
                 <a:ea typeface="Inter" pitchFamily="34" charset="-122"/>
                 <a:cs typeface="Inter" pitchFamily="34" charset="-120"/>
               </a:rPr>
-              <a:t>−$216K</a:t>
+              <a:t>−$162K</a:t>
             </a:r>
             <a:endParaRPr lang="en-US" sz="1300" dirty="0"/>
           </a:p>
@@ -6367,7 +6367,7 @@
                 <a:ea typeface="Inter" pitchFamily="34" charset="-122"/>
                 <a:cs typeface="Inter" pitchFamily="34" charset="-120"/>
               </a:rPr>
-              <a:t>−$233K</a:t>
+              <a:t>−$175K</a:t>
             </a:r>
             <a:endParaRPr lang="en-US" sz="1300" dirty="0"/>
           </a:p>
@@ -6504,7 +6504,7 @@
                 <a:ea typeface="Inter" pitchFamily="34" charset="-122"/>
                 <a:cs typeface="Inter" pitchFamily="34" charset="-120"/>
               </a:rPr>
-              <a:t>−$245K</a:t>
+              <a:t>−$184K</a:t>
             </a:r>
             <a:endParaRPr lang="en-US" sz="1300" dirty="0"/>
           </a:p>
@@ -6641,7 +6641,7 @@
                 <a:ea typeface="Inter" pitchFamily="34" charset="-122"/>
                 <a:cs typeface="Inter" pitchFamily="34" charset="-120"/>
               </a:rPr>
-              <a:t>−$247K</a:t>
+              <a:t>−$185K</a:t>
             </a:r>
             <a:endParaRPr lang="en-US" sz="1300" dirty="0"/>
           </a:p>
@@ -6778,7 +6778,7 @@
                 <a:ea typeface="Inter" pitchFamily="34" charset="-122"/>
                 <a:cs typeface="Inter" pitchFamily="34" charset="-120"/>
               </a:rPr>
-              <a:t>−$302K</a:t>
+              <a:t>−$227K</a:t>
             </a:r>
             <a:endParaRPr lang="en-US" sz="1300" dirty="0"/>
           </a:p>
@@ -6915,7 +6915,7 @@
                 <a:ea typeface="Inter" pitchFamily="34" charset="-122"/>
                 <a:cs typeface="Inter" pitchFamily="34" charset="-120"/>
               </a:rPr>
-              <a:t>−$356K</a:t>
+              <a:t>−$267K</a:t>
             </a:r>
             <a:endParaRPr lang="en-US" sz="1300" dirty="0"/>
           </a:p>
@@ -7052,7 +7052,7 @@
                 <a:ea typeface="Inter" pitchFamily="34" charset="-122"/>
                 <a:cs typeface="Inter" pitchFamily="34" charset="-120"/>
               </a:rPr>
-              <a:t>−$475K</a:t>
+              <a:t>−$356K</a:t>
             </a:r>
             <a:endParaRPr lang="en-US" sz="1300" dirty="0"/>
           </a:p>
@@ -7189,7 +7189,7 @@
                 <a:ea typeface="Inter" pitchFamily="34" charset="-122"/>
                 <a:cs typeface="Inter" pitchFamily="34" charset="-120"/>
               </a:rPr>
-              <a:t>−$541K</a:t>
+              <a:t>−$406K</a:t>
             </a:r>
             <a:endParaRPr lang="en-US" sz="1300" dirty="0"/>
           </a:p>
@@ -7268,7 +7268,7 @@
                 <a:ea typeface="Inter" pitchFamily="34" charset="-122"/>
                 <a:cs typeface="Inter" pitchFamily="34" charset="-120"/>
               </a:rPr>
-              <a:t>Toyota Spokane is furthest below at −$541K a year; 7 of 33 stores are ahead of benchmark across the four services. 15 stores are under all four.</a:t>
+              <a:t>Toyota Spokane is furthest below at −$406K so far this year; 7 of 33 stores are ahead of benchmark across the four services. 15 stores are under all four.</a:t>
             </a:r>
             <a:endParaRPr lang="en-US" sz="1600" dirty="0"/>
           </a:p>
@@ -7359,7 +7359,7 @@
                 <a:ea typeface="Inter" pitchFamily="34" charset="-122"/>
                 <a:cs typeface="Inter" pitchFamily="34" charset="-120"/>
               </a:rPr>
-              <a:t>OPCODES · JAN–SEP 2026, ANNUALIZED</a:t>
+              <a:t>OPCODES · JAN–SEP 2026 YTD</a:t>
             </a:r>
             <a:endParaRPr lang="en-US" sz="1400" dirty="0"/>
           </a:p>
@@ -7751,7 +7751,7 @@
                 <a:ea typeface="Inter" pitchFamily="34" charset="-122"/>
                 <a:cs typeface="Inter" pitchFamily="34" charset="-120"/>
               </a:rPr>
-              <a:t>+$229K</a:t>
+              <a:t>+$171K</a:t>
             </a:r>
             <a:endParaRPr lang="en-US" sz="1300" dirty="0"/>
           </a:p>
@@ -7927,7 +7927,7 @@
                 <a:ea typeface="Inter" pitchFamily="34" charset="-122"/>
                 <a:cs typeface="Inter" pitchFamily="34" charset="-120"/>
               </a:rPr>
-              <a:t>+$163K</a:t>
+              <a:t>+$123K</a:t>
             </a:r>
             <a:endParaRPr lang="en-US" sz="1300" dirty="0"/>
           </a:p>
@@ -8103,7 +8103,7 @@
                 <a:ea typeface="Inter" pitchFamily="34" charset="-122"/>
                 <a:cs typeface="Inter" pitchFamily="34" charset="-120"/>
               </a:rPr>
-              <a:t>+$42K</a:t>
+              <a:t>+$31K</a:t>
             </a:r>
             <a:endParaRPr lang="en-US" sz="1300" dirty="0"/>
           </a:p>
@@ -8279,7 +8279,7 @@
                 <a:ea typeface="Inter" pitchFamily="34" charset="-122"/>
                 <a:cs typeface="Inter" pitchFamily="34" charset="-120"/>
               </a:rPr>
-              <a:t>+$41K</a:t>
+              <a:t>+$31K</a:t>
             </a:r>
             <a:endParaRPr lang="en-US" sz="1300" dirty="0"/>
           </a:p>
@@ -8455,7 +8455,7 @@
                 <a:ea typeface="Inter" pitchFamily="34" charset="-122"/>
                 <a:cs typeface="Inter" pitchFamily="34" charset="-120"/>
               </a:rPr>
-              <a:t>+$27K</a:t>
+              <a:t>+$20K</a:t>
             </a:r>
             <a:endParaRPr lang="en-US" sz="1300" dirty="0"/>
           </a:p>
@@ -8631,7 +8631,7 @@
                 <a:ea typeface="Inter" pitchFamily="34" charset="-122"/>
                 <a:cs typeface="Inter" pitchFamily="34" charset="-120"/>
               </a:rPr>
-              <a:t>+$23K</a:t>
+              <a:t>+$18K</a:t>
             </a:r>
             <a:endParaRPr lang="en-US" sz="1300" dirty="0"/>
           </a:p>
@@ -8807,7 +8807,7 @@
                 <a:ea typeface="Inter" pitchFamily="34" charset="-122"/>
                 <a:cs typeface="Inter" pitchFamily="34" charset="-120"/>
               </a:rPr>
-              <a:t>+$17K</a:t>
+              <a:t>+$13K</a:t>
             </a:r>
             <a:endParaRPr lang="en-US" sz="1300" dirty="0"/>
           </a:p>
@@ -8983,7 +8983,7 @@
                 <a:ea typeface="Inter" pitchFamily="34" charset="-122"/>
                 <a:cs typeface="Inter" pitchFamily="34" charset="-120"/>
               </a:rPr>
-              <a:t>+$14K</a:t>
+              <a:t>+$11K</a:t>
             </a:r>
             <a:endParaRPr lang="en-US" sz="1300" dirty="0"/>
           </a:p>
@@ -9159,7 +9159,7 @@
                 <a:ea typeface="Inter" pitchFamily="34" charset="-122"/>
                 <a:cs typeface="Inter" pitchFamily="34" charset="-120"/>
               </a:rPr>
-              <a:t>−$865</a:t>
+              <a:t>−$649</a:t>
             </a:r>
             <a:endParaRPr lang="en-US" sz="1300" dirty="0"/>
           </a:p>
@@ -9335,7 +9335,7 @@
                 <a:ea typeface="Inter" pitchFamily="34" charset="-122"/>
                 <a:cs typeface="Inter" pitchFamily="34" charset="-120"/>
               </a:rPr>
-              <a:t>−$7K</a:t>
+              <a:t>−$5K</a:t>
             </a:r>
             <a:endParaRPr lang="en-US" sz="1300" dirty="0"/>
           </a:p>
@@ -9511,7 +9511,7 @@
                 <a:ea typeface="Inter" pitchFamily="34" charset="-122"/>
                 <a:cs typeface="Inter" pitchFamily="34" charset="-120"/>
               </a:rPr>
-              <a:t>−$9K</a:t>
+              <a:t>−$7K</a:t>
             </a:r>
             <a:endParaRPr lang="en-US" sz="1300" dirty="0"/>
           </a:p>
@@ -9687,7 +9687,7 @@
                 <a:ea typeface="Inter" pitchFamily="34" charset="-122"/>
                 <a:cs typeface="Inter" pitchFamily="34" charset="-120"/>
               </a:rPr>
-              <a:t>−$10K</a:t>
+              <a:t>−$7K</a:t>
             </a:r>
             <a:endParaRPr lang="en-US" sz="1300" dirty="0"/>
           </a:p>
@@ -9863,7 +9863,7 @@
                 <a:ea typeface="Inter" pitchFamily="34" charset="-122"/>
                 <a:cs typeface="Inter" pitchFamily="34" charset="-120"/>
               </a:rPr>
-              <a:t>−$10K</a:t>
+              <a:t>−$8K</a:t>
             </a:r>
             <a:endParaRPr lang="en-US" sz="1300" dirty="0"/>
           </a:p>
@@ -10039,7 +10039,7 @@
                 <a:ea typeface="Inter" pitchFamily="34" charset="-122"/>
                 <a:cs typeface="Inter" pitchFamily="34" charset="-120"/>
               </a:rPr>
-              <a:t>−$11K</a:t>
+              <a:t>−$9K</a:t>
             </a:r>
             <a:endParaRPr lang="en-US" sz="1300" dirty="0"/>
           </a:p>
@@ -10215,7 +10215,7 @@
                 <a:ea typeface="Inter" pitchFamily="34" charset="-122"/>
                 <a:cs typeface="Inter" pitchFamily="34" charset="-120"/>
               </a:rPr>
-              <a:t>−$12K</a:t>
+              <a:t>−$9K</a:t>
             </a:r>
             <a:endParaRPr lang="en-US" sz="1300" dirty="0"/>
           </a:p>
@@ -10391,7 +10391,7 @@
                 <a:ea typeface="Inter" pitchFamily="34" charset="-122"/>
                 <a:cs typeface="Inter" pitchFamily="34" charset="-120"/>
               </a:rPr>
-              <a:t>−$18K</a:t>
+              <a:t>−$13K</a:t>
             </a:r>
             <a:endParaRPr lang="en-US" sz="1300" dirty="0"/>
           </a:p>
@@ -10567,7 +10567,7 @@
                 <a:ea typeface="Inter" pitchFamily="34" charset="-122"/>
                 <a:cs typeface="Inter" pitchFamily="34" charset="-120"/>
               </a:rPr>
-              <a:t>−$21K</a:t>
+              <a:t>−$16K</a:t>
             </a:r>
             <a:endParaRPr lang="en-US" sz="1300" dirty="0"/>
           </a:p>
@@ -10743,7 +10743,7 @@
                 <a:ea typeface="Inter" pitchFamily="34" charset="-122"/>
                 <a:cs typeface="Inter" pitchFamily="34" charset="-120"/>
               </a:rPr>
-              <a:t>−$23K</a:t>
+              <a:t>−$17K</a:t>
             </a:r>
             <a:endParaRPr lang="en-US" sz="1300" dirty="0"/>
           </a:p>
@@ -10919,7 +10919,7 @@
                 <a:ea typeface="Inter" pitchFamily="34" charset="-122"/>
                 <a:cs typeface="Inter" pitchFamily="34" charset="-120"/>
               </a:rPr>
-              <a:t>−$23K</a:t>
+              <a:t>−$18K</a:t>
             </a:r>
             <a:endParaRPr lang="en-US" sz="1300" dirty="0"/>
           </a:p>
@@ -11095,7 +11095,7 @@
                 <a:ea typeface="Inter" pitchFamily="34" charset="-122"/>
                 <a:cs typeface="Inter" pitchFamily="34" charset="-120"/>
               </a:rPr>
-              <a:t>−$25K</a:t>
+              <a:t>−$19K</a:t>
             </a:r>
             <a:endParaRPr lang="en-US" sz="1300" dirty="0"/>
           </a:p>
@@ -11271,7 +11271,7 @@
                 <a:ea typeface="Inter" pitchFamily="34" charset="-122"/>
                 <a:cs typeface="Inter" pitchFamily="34" charset="-120"/>
               </a:rPr>
-              <a:t>−$26K</a:t>
+              <a:t>−$20K</a:t>
             </a:r>
             <a:endParaRPr lang="en-US" sz="1300" dirty="0"/>
           </a:p>
@@ -11447,7 +11447,7 @@
                 <a:ea typeface="Inter" pitchFamily="34" charset="-122"/>
                 <a:cs typeface="Inter" pitchFamily="34" charset="-120"/>
               </a:rPr>
-              <a:t>−$33K</a:t>
+              <a:t>−$24K</a:t>
             </a:r>
             <a:endParaRPr lang="en-US" sz="1300" dirty="0"/>
           </a:p>
@@ -11623,7 +11623,7 @@
                 <a:ea typeface="Inter" pitchFamily="34" charset="-122"/>
                 <a:cs typeface="Inter" pitchFamily="34" charset="-120"/>
               </a:rPr>
-              <a:t>−$33K</a:t>
+              <a:t>−$25K</a:t>
             </a:r>
             <a:endParaRPr lang="en-US" sz="1300" dirty="0"/>
           </a:p>
@@ -11799,7 +11799,7 @@
                 <a:ea typeface="Inter" pitchFamily="34" charset="-122"/>
                 <a:cs typeface="Inter" pitchFamily="34" charset="-120"/>
               </a:rPr>
-              <a:t>−$34K</a:t>
+              <a:t>−$26K</a:t>
             </a:r>
             <a:endParaRPr lang="en-US" sz="1300" dirty="0"/>
           </a:p>
@@ -11975,7 +11975,7 @@
                 <a:ea typeface="Inter" pitchFamily="34" charset="-122"/>
                 <a:cs typeface="Inter" pitchFamily="34" charset="-120"/>
               </a:rPr>
-              <a:t>−$36K</a:t>
+              <a:t>−$27K</a:t>
             </a:r>
             <a:endParaRPr lang="en-US" sz="1300" dirty="0"/>
           </a:p>
@@ -12151,7 +12151,7 @@
                 <a:ea typeface="Inter" pitchFamily="34" charset="-122"/>
                 <a:cs typeface="Inter" pitchFamily="34" charset="-120"/>
               </a:rPr>
-              <a:t>−$38K</a:t>
+              <a:t>−$29K</a:t>
             </a:r>
             <a:endParaRPr lang="en-US" sz="1300" dirty="0"/>
           </a:p>
@@ -12327,7 +12327,7 @@
                 <a:ea typeface="Inter" pitchFamily="34" charset="-122"/>
                 <a:cs typeface="Inter" pitchFamily="34" charset="-120"/>
               </a:rPr>
-              <a:t>−$49K</a:t>
+              <a:t>−$37K</a:t>
             </a:r>
             <a:endParaRPr lang="en-US" sz="1300" dirty="0"/>
           </a:p>
@@ -12503,7 +12503,7 @@
                 <a:ea typeface="Inter" pitchFamily="34" charset="-122"/>
                 <a:cs typeface="Inter" pitchFamily="34" charset="-120"/>
               </a:rPr>
-              <a:t>−$57K</a:t>
+              <a:t>−$43K</a:t>
             </a:r>
             <a:endParaRPr lang="en-US" sz="1300" dirty="0"/>
           </a:p>
@@ -12679,7 +12679,7 @@
                 <a:ea typeface="Inter" pitchFamily="34" charset="-122"/>
                 <a:cs typeface="Inter" pitchFamily="34" charset="-120"/>
               </a:rPr>
-              <a:t>−$75K</a:t>
+              <a:t>−$57K</a:t>
             </a:r>
             <a:endParaRPr lang="en-US" sz="1300" dirty="0"/>
           </a:p>
@@ -12855,7 +12855,7 @@
                 <a:ea typeface="Inter" pitchFamily="34" charset="-122"/>
                 <a:cs typeface="Inter" pitchFamily="34" charset="-120"/>
               </a:rPr>
-              <a:t>−$77K</a:t>
+              <a:t>−$58K</a:t>
             </a:r>
             <a:endParaRPr lang="en-US" sz="1300" dirty="0"/>
           </a:p>
@@ -13031,7 +13031,7 @@
                 <a:ea typeface="Inter" pitchFamily="34" charset="-122"/>
                 <a:cs typeface="Inter" pitchFamily="34" charset="-120"/>
               </a:rPr>
-              <a:t>−$83K</a:t>
+              <a:t>−$62K</a:t>
             </a:r>
             <a:endParaRPr lang="en-US" sz="1300" dirty="0"/>
           </a:p>
@@ -13207,7 +13207,7 @@
                 <a:ea typeface="Inter" pitchFamily="34" charset="-122"/>
                 <a:cs typeface="Inter" pitchFamily="34" charset="-120"/>
               </a:rPr>
-              <a:t>−$90K</a:t>
+              <a:t>−$67K</a:t>
             </a:r>
             <a:endParaRPr lang="en-US" sz="1300" dirty="0"/>
           </a:p>
@@ -13383,7 +13383,7 @@
                 <a:ea typeface="Inter" pitchFamily="34" charset="-122"/>
                 <a:cs typeface="Inter" pitchFamily="34" charset="-120"/>
               </a:rPr>
-              <a:t>−$225K</a:t>
+              <a:t>−$169K</a:t>
             </a:r>
             <a:endParaRPr lang="en-US" sz="1300" dirty="0"/>
           </a:p>
@@ -13457,7 +13457,7 @@
         <p:spPr>
           <a:xfrm>
             <a:off x="457200" y="6126480"/>
-            <a:ext cx="11274552" cy="341376"/>
+            <a:ext cx="11274552" cy="615696"/>
           </a:xfrm>
           <a:prstGeom prst="rect">
             <a:avLst/>
@@ -13477,7 +13477,7 @@
         <p:spPr>
           <a:xfrm>
             <a:off x="658368" y="6144768"/>
-            <a:ext cx="10927080" cy="304800"/>
+            <a:ext cx="10927080" cy="579120"/>
           </a:xfrm>
           <a:prstGeom prst="rect">
             <a:avLst/>
@@ -13493,7 +13493,7 @@
               <a:buNone/>
             </a:pPr>
             <a:r>
-              <a:rPr lang="en-US" sz="1400" b="1" dirty="0">
+              <a:rPr lang="en-US" sz="1600" b="1" dirty="0">
                 <a:solidFill>
                   <a:srgbClr val="A82B26"/>
                 </a:solidFill>
@@ -13501,9 +13501,9 @@
                 <a:ea typeface="Inter" pitchFamily="34" charset="-122"/>
                 <a:cs typeface="Inter" pitchFamily="34" charset="-120"/>
               </a:rPr>
-              <a:t>25 stores under 15% leave $1,029,276 a year; 8 are at or above it. Toyota Spokane is furthest below at −$225K.</a:t>
-            </a:r>
-            <a:endParaRPr lang="en-US" sz="1400" dirty="0"/>
+              <a:t>25 stores under 15% have left $771,957 so far this year; 8 are at or above it. Toyota Spokane is furthest below at −$169K.</a:t>
+            </a:r>
+            <a:endParaRPr lang="en-US" sz="1600" dirty="0"/>
           </a:p>
         </p:txBody>
       </p:sp>
@@ -13592,7 +13592,7 @@
                 <a:ea typeface="Inter" pitchFamily="34" charset="-122"/>
                 <a:cs typeface="Inter" pitchFamily="34" charset="-120"/>
               </a:rPr>
-              <a:t>OPCODES · JAN–SEP 2026, ANNUALIZED</a:t>
+              <a:t>OPCODES · JAN–SEP 2026 YTD</a:t>
             </a:r>
             <a:endParaRPr lang="en-US" sz="1400" dirty="0"/>
           </a:p>
@@ -13984,7 +13984,7 @@
                 <a:ea typeface="Inter" pitchFamily="34" charset="-122"/>
                 <a:cs typeface="Inter" pitchFamily="34" charset="-120"/>
               </a:rPr>
-              <a:t>+$70K</a:t>
+              <a:t>+$52K</a:t>
             </a:r>
             <a:endParaRPr lang="en-US" sz="1300" dirty="0"/>
           </a:p>
@@ -14160,7 +14160,7 @@
                 <a:ea typeface="Inter" pitchFamily="34" charset="-122"/>
                 <a:cs typeface="Inter" pitchFamily="34" charset="-120"/>
               </a:rPr>
-              <a:t>+$31K</a:t>
+              <a:t>+$23K</a:t>
             </a:r>
             <a:endParaRPr lang="en-US" sz="1300" dirty="0"/>
           </a:p>
@@ -14336,7 +14336,7 @@
                 <a:ea typeface="Inter" pitchFamily="34" charset="-122"/>
                 <a:cs typeface="Inter" pitchFamily="34" charset="-120"/>
               </a:rPr>
-              <a:t>+$14K</a:t>
+              <a:t>+$10K</a:t>
             </a:r>
             <a:endParaRPr lang="en-US" sz="1300" dirty="0"/>
           </a:p>
@@ -14512,7 +14512,7 @@
                 <a:ea typeface="Inter" pitchFamily="34" charset="-122"/>
                 <a:cs typeface="Inter" pitchFamily="34" charset="-120"/>
               </a:rPr>
-              <a:t>+$6K</a:t>
+              <a:t>+$4K</a:t>
             </a:r>
             <a:endParaRPr lang="en-US" sz="1300" dirty="0"/>
           </a:p>
@@ -14688,7 +14688,7 @@
                 <a:ea typeface="Inter" pitchFamily="34" charset="-122"/>
                 <a:cs typeface="Inter" pitchFamily="34" charset="-120"/>
               </a:rPr>
-              <a:t>−$34</a:t>
+              <a:t>−$26</a:t>
             </a:r>
             <a:endParaRPr lang="en-US" sz="1300" dirty="0"/>
           </a:p>
@@ -14864,7 +14864,7 @@
                 <a:ea typeface="Inter" pitchFamily="34" charset="-122"/>
                 <a:cs typeface="Inter" pitchFamily="34" charset="-120"/>
               </a:rPr>
-              <a:t>−$3K</a:t>
+              <a:t>−$2K</a:t>
             </a:r>
             <a:endParaRPr lang="en-US" sz="1300" dirty="0"/>
           </a:p>
@@ -15040,7 +15040,7 @@
                 <a:ea typeface="Inter" pitchFamily="34" charset="-122"/>
                 <a:cs typeface="Inter" pitchFamily="34" charset="-120"/>
               </a:rPr>
-              <a:t>−$6K</a:t>
+              <a:t>−$4K</a:t>
             </a:r>
             <a:endParaRPr lang="en-US" sz="1300" dirty="0"/>
           </a:p>
@@ -15216,7 +15216,7 @@
                 <a:ea typeface="Inter" pitchFamily="34" charset="-122"/>
                 <a:cs typeface="Inter" pitchFamily="34" charset="-120"/>
               </a:rPr>
-              <a:t>−$8K</a:t>
+              <a:t>−$6K</a:t>
             </a:r>
             <a:endParaRPr lang="en-US" sz="1300" dirty="0"/>
           </a:p>
@@ -15392,7 +15392,7 @@
                 <a:ea typeface="Inter" pitchFamily="34" charset="-122"/>
                 <a:cs typeface="Inter" pitchFamily="34" charset="-120"/>
               </a:rPr>
-              <a:t>−$11K</a:t>
+              <a:t>−$8K</a:t>
             </a:r>
             <a:endParaRPr lang="en-US" sz="1300" dirty="0"/>
           </a:p>
@@ -15568,7 +15568,7 @@
                 <a:ea typeface="Inter" pitchFamily="34" charset="-122"/>
                 <a:cs typeface="Inter" pitchFamily="34" charset="-120"/>
               </a:rPr>
-              <a:t>−$14K</a:t>
+              <a:t>−$11K</a:t>
             </a:r>
             <a:endParaRPr lang="en-US" sz="1300" dirty="0"/>
           </a:p>
@@ -15744,7 +15744,7 @@
                 <a:ea typeface="Inter" pitchFamily="34" charset="-122"/>
                 <a:cs typeface="Inter" pitchFamily="34" charset="-120"/>
               </a:rPr>
-              <a:t>−$18K</a:t>
+              <a:t>−$14K</a:t>
             </a:r>
             <a:endParaRPr lang="en-US" sz="1300" dirty="0"/>
           </a:p>
@@ -15920,7 +15920,7 @@
                 <a:ea typeface="Inter" pitchFamily="34" charset="-122"/>
                 <a:cs typeface="Inter" pitchFamily="34" charset="-120"/>
               </a:rPr>
-              <a:t>−$21K</a:t>
+              <a:t>−$16K</a:t>
             </a:r>
             <a:endParaRPr lang="en-US" sz="1300" dirty="0"/>
           </a:p>
@@ -16096,7 +16096,7 @@
                 <a:ea typeface="Inter" pitchFamily="34" charset="-122"/>
                 <a:cs typeface="Inter" pitchFamily="34" charset="-120"/>
               </a:rPr>
-              <a:t>−$27K</a:t>
+              <a:t>−$20K</a:t>
             </a:r>
             <a:endParaRPr lang="en-US" sz="1300" dirty="0"/>
           </a:p>
@@ -16272,7 +16272,7 @@
                 <a:ea typeface="Inter" pitchFamily="34" charset="-122"/>
                 <a:cs typeface="Inter" pitchFamily="34" charset="-120"/>
               </a:rPr>
-              <a:t>−$27K</a:t>
+              <a:t>−$21K</a:t>
             </a:r>
             <a:endParaRPr lang="en-US" sz="1300" dirty="0"/>
           </a:p>
@@ -16448,7 +16448,7 @@
                 <a:ea typeface="Inter" pitchFamily="34" charset="-122"/>
                 <a:cs typeface="Inter" pitchFamily="34" charset="-120"/>
               </a:rPr>
-              <a:t>−$28K</a:t>
+              <a:t>−$21K</a:t>
             </a:r>
             <a:endParaRPr lang="en-US" sz="1300" dirty="0"/>
           </a:p>
@@ -16624,7 +16624,7 @@
                 <a:ea typeface="Inter" pitchFamily="34" charset="-122"/>
                 <a:cs typeface="Inter" pitchFamily="34" charset="-120"/>
               </a:rPr>
-              <a:t>−$31K</a:t>
+              <a:t>−$23K</a:t>
             </a:r>
             <a:endParaRPr lang="en-US" sz="1300" dirty="0"/>
           </a:p>
@@ -16800,7 +16800,7 @@
                 <a:ea typeface="Inter" pitchFamily="34" charset="-122"/>
                 <a:cs typeface="Inter" pitchFamily="34" charset="-120"/>
               </a:rPr>
-              <a:t>−$36K</a:t>
+              <a:t>−$27K</a:t>
             </a:r>
             <a:endParaRPr lang="en-US" sz="1300" dirty="0"/>
           </a:p>
@@ -16976,7 +16976,7 @@
                 <a:ea typeface="Inter" pitchFamily="34" charset="-122"/>
                 <a:cs typeface="Inter" pitchFamily="34" charset="-120"/>
               </a:rPr>
-              <a:t>−$38K</a:t>
+              <a:t>−$29K</a:t>
             </a:r>
             <a:endParaRPr lang="en-US" sz="1300" dirty="0"/>
           </a:p>
@@ -17152,7 +17152,7 @@
                 <a:ea typeface="Inter" pitchFamily="34" charset="-122"/>
                 <a:cs typeface="Inter" pitchFamily="34" charset="-120"/>
               </a:rPr>
-              <a:t>−$52K</a:t>
+              <a:t>−$39K</a:t>
             </a:r>
             <a:endParaRPr lang="en-US" sz="1300" dirty="0"/>
           </a:p>
@@ -17328,7 +17328,7 @@
                 <a:ea typeface="Inter" pitchFamily="34" charset="-122"/>
                 <a:cs typeface="Inter" pitchFamily="34" charset="-120"/>
               </a:rPr>
-              <a:t>−$52K</a:t>
+              <a:t>−$39K</a:t>
             </a:r>
             <a:endParaRPr lang="en-US" sz="1300" dirty="0"/>
           </a:p>
@@ -17504,7 +17504,7 @@
                 <a:ea typeface="Inter" pitchFamily="34" charset="-122"/>
                 <a:cs typeface="Inter" pitchFamily="34" charset="-120"/>
               </a:rPr>
-              <a:t>−$56K</a:t>
+              <a:t>−$42K</a:t>
             </a:r>
             <a:endParaRPr lang="en-US" sz="1300" dirty="0"/>
           </a:p>
@@ -17680,7 +17680,7 @@
                 <a:ea typeface="Inter" pitchFamily="34" charset="-122"/>
                 <a:cs typeface="Inter" pitchFamily="34" charset="-120"/>
               </a:rPr>
-              <a:t>−$68K</a:t>
+              <a:t>−$51K</a:t>
             </a:r>
             <a:endParaRPr lang="en-US" sz="1300" dirty="0"/>
           </a:p>
@@ -17856,7 +17856,7 @@
                 <a:ea typeface="Inter" pitchFamily="34" charset="-122"/>
                 <a:cs typeface="Inter" pitchFamily="34" charset="-120"/>
               </a:rPr>
-              <a:t>−$68K</a:t>
+              <a:t>−$51K</a:t>
             </a:r>
             <a:endParaRPr lang="en-US" sz="1300" dirty="0"/>
           </a:p>
@@ -18032,7 +18032,7 @@
                 <a:ea typeface="Inter" pitchFamily="34" charset="-122"/>
                 <a:cs typeface="Inter" pitchFamily="34" charset="-120"/>
               </a:rPr>
-              <a:t>−$72K</a:t>
+              <a:t>−$54K</a:t>
             </a:r>
             <a:endParaRPr lang="en-US" sz="1300" dirty="0"/>
           </a:p>
@@ -18208,7 +18208,7 @@
                 <a:ea typeface="Inter" pitchFamily="34" charset="-122"/>
                 <a:cs typeface="Inter" pitchFamily="34" charset="-120"/>
               </a:rPr>
-              <a:t>−$73K</a:t>
+              <a:t>−$55K</a:t>
             </a:r>
             <a:endParaRPr lang="en-US" sz="1300" dirty="0"/>
           </a:p>
@@ -18384,7 +18384,7 @@
                 <a:ea typeface="Inter" pitchFamily="34" charset="-122"/>
                 <a:cs typeface="Inter" pitchFamily="34" charset="-120"/>
               </a:rPr>
-              <a:t>−$77K</a:t>
+              <a:t>−$58K</a:t>
             </a:r>
             <a:endParaRPr lang="en-US" sz="1300" dirty="0"/>
           </a:p>
@@ -18560,7 +18560,7 @@
                 <a:ea typeface="Inter" pitchFamily="34" charset="-122"/>
                 <a:cs typeface="Inter" pitchFamily="34" charset="-120"/>
               </a:rPr>
-              <a:t>−$80K</a:t>
+              <a:t>−$60K</a:t>
             </a:r>
             <a:endParaRPr lang="en-US" sz="1300" dirty="0"/>
           </a:p>
@@ -18736,7 +18736,7 @@
                 <a:ea typeface="Inter" pitchFamily="34" charset="-122"/>
                 <a:cs typeface="Inter" pitchFamily="34" charset="-120"/>
               </a:rPr>
-              <a:t>−$106K</a:t>
+              <a:t>−$80K</a:t>
             </a:r>
             <a:endParaRPr lang="en-US" sz="1300" dirty="0"/>
           </a:p>
@@ -18912,7 +18912,7 @@
                 <a:ea typeface="Inter" pitchFamily="34" charset="-122"/>
                 <a:cs typeface="Inter" pitchFamily="34" charset="-120"/>
               </a:rPr>
-              <a:t>−$109K</a:t>
+              <a:t>−$82K</a:t>
             </a:r>
             <a:endParaRPr lang="en-US" sz="1300" dirty="0"/>
           </a:p>
@@ -19088,7 +19088,7 @@
                 <a:ea typeface="Inter" pitchFamily="34" charset="-122"/>
                 <a:cs typeface="Inter" pitchFamily="34" charset="-120"/>
               </a:rPr>
-              <a:t>−$125K</a:t>
+              <a:t>−$94K</a:t>
             </a:r>
             <a:endParaRPr lang="en-US" sz="1300" dirty="0"/>
           </a:p>
@@ -19264,7 +19264,7 @@
                 <a:ea typeface="Inter" pitchFamily="34" charset="-122"/>
                 <a:cs typeface="Inter" pitchFamily="34" charset="-120"/>
               </a:rPr>
-              <a:t>−$132K</a:t>
+              <a:t>−$99K</a:t>
             </a:r>
             <a:endParaRPr lang="en-US" sz="1300" dirty="0"/>
           </a:p>
@@ -19440,7 +19440,7 @@
                 <a:ea typeface="Inter" pitchFamily="34" charset="-122"/>
                 <a:cs typeface="Inter" pitchFamily="34" charset="-120"/>
               </a:rPr>
-              <a:t>−$147K</a:t>
+              <a:t>−$111K</a:t>
             </a:r>
             <a:endParaRPr lang="en-US" sz="1300" dirty="0"/>
           </a:p>
@@ -19616,7 +19616,7 @@
                 <a:ea typeface="Inter" pitchFamily="34" charset="-122"/>
                 <a:cs typeface="Inter" pitchFamily="34" charset="-120"/>
               </a:rPr>
-              <a:t>−$180K</a:t>
+              <a:t>−$135K</a:t>
             </a:r>
             <a:endParaRPr lang="en-US" sz="1300" dirty="0"/>
           </a:p>
@@ -19690,7 +19690,7 @@
         <p:spPr>
           <a:xfrm>
             <a:off x="457200" y="6126480"/>
-            <a:ext cx="11274552" cy="341376"/>
+            <a:ext cx="11274552" cy="615696"/>
           </a:xfrm>
           <a:prstGeom prst="rect">
             <a:avLst/>
@@ -19710,7 +19710,7 @@
         <p:spPr>
           <a:xfrm>
             <a:off x="658368" y="6144768"/>
-            <a:ext cx="10927080" cy="304800"/>
+            <a:ext cx="10927080" cy="579120"/>
           </a:xfrm>
           <a:prstGeom prst="rect">
             <a:avLst/>
@@ -19726,7 +19726,7 @@
               <a:buNone/>
             </a:pPr>
             <a:r>
-              <a:rPr lang="en-US" sz="1400" b="1" dirty="0">
+              <a:rPr lang="en-US" sz="1600" b="1" dirty="0">
                 <a:solidFill>
                   <a:srgbClr val="A82B26"/>
                 </a:solidFill>
@@ -19734,9 +19734,9 @@
                 <a:ea typeface="Inter" pitchFamily="34" charset="-122"/>
                 <a:cs typeface="Inter" pitchFamily="34" charset="-120"/>
               </a:rPr>
-              <a:t>29 stores under 15% leave $1,664,385 a year; 4 are at or above it. Toyota Spokane is furthest below at −$180K.</a:t>
-            </a:r>
-            <a:endParaRPr lang="en-US" sz="1400" dirty="0"/>
+              <a:t>29 stores under 15% have left $1,248,289 so far this year; 4 are at or above it. Toyota Spokane is furthest below at −$135K.</a:t>
+            </a:r>
+            <a:endParaRPr lang="en-US" sz="1600" dirty="0"/>
           </a:p>
         </p:txBody>
       </p:sp>
@@ -19825,7 +19825,7 @@
                 <a:ea typeface="Inter" pitchFamily="34" charset="-122"/>
                 <a:cs typeface="Inter" pitchFamily="34" charset="-120"/>
               </a:rPr>
-              <a:t>OPCODES · JAN–SEP 2026, ANNUALIZED</a:t>
+              <a:t>OPCODES · JAN–SEP 2026 YTD</a:t>
             </a:r>
             <a:endParaRPr lang="en-US" sz="1400" dirty="0"/>
           </a:p>
@@ -20217,7 +20217,7 @@
                 <a:ea typeface="Inter" pitchFamily="34" charset="-122"/>
                 <a:cs typeface="Inter" pitchFamily="34" charset="-120"/>
               </a:rPr>
-              <a:t>+$260K</a:t>
+              <a:t>+$195K</a:t>
             </a:r>
             <a:endParaRPr lang="en-US" sz="1300" dirty="0"/>
           </a:p>
@@ -20393,7 +20393,7 @@
                 <a:ea typeface="Inter" pitchFamily="34" charset="-122"/>
                 <a:cs typeface="Inter" pitchFamily="34" charset="-120"/>
               </a:rPr>
-              <a:t>+$187K</a:t>
+              <a:t>+$141K</a:t>
             </a:r>
             <a:endParaRPr lang="en-US" sz="1300" dirty="0"/>
           </a:p>
@@ -20569,7 +20569,7 @@
                 <a:ea typeface="Inter" pitchFamily="34" charset="-122"/>
                 <a:cs typeface="Inter" pitchFamily="34" charset="-120"/>
               </a:rPr>
-              <a:t>+$67K</a:t>
+              <a:t>+$51K</a:t>
             </a:r>
             <a:endParaRPr lang="en-US" sz="1300" dirty="0"/>
           </a:p>
@@ -20745,7 +20745,7 @@
                 <a:ea typeface="Inter" pitchFamily="34" charset="-122"/>
                 <a:cs typeface="Inter" pitchFamily="34" charset="-120"/>
               </a:rPr>
-              <a:t>+$34K</a:t>
+              <a:t>+$25K</a:t>
             </a:r>
             <a:endParaRPr lang="en-US" sz="1300" dirty="0"/>
           </a:p>
@@ -20921,7 +20921,7 @@
                 <a:ea typeface="Inter" pitchFamily="34" charset="-122"/>
                 <a:cs typeface="Inter" pitchFamily="34" charset="-120"/>
               </a:rPr>
-              <a:t>+$33K</a:t>
+              <a:t>+$24K</a:t>
             </a:r>
             <a:endParaRPr lang="en-US" sz="1300" dirty="0"/>
           </a:p>
@@ -21097,7 +21097,7 @@
                 <a:ea typeface="Inter" pitchFamily="34" charset="-122"/>
                 <a:cs typeface="Inter" pitchFamily="34" charset="-120"/>
               </a:rPr>
-              <a:t>+$24K</a:t>
+              <a:t>+$18K</a:t>
             </a:r>
             <a:endParaRPr lang="en-US" sz="1300" dirty="0"/>
           </a:p>
@@ -21273,7 +21273,7 @@
                 <a:ea typeface="Inter" pitchFamily="34" charset="-122"/>
                 <a:cs typeface="Inter" pitchFamily="34" charset="-120"/>
               </a:rPr>
-              <a:t>+$21K</a:t>
+              <a:t>+$16K</a:t>
             </a:r>
             <a:endParaRPr lang="en-US" sz="1300" dirty="0"/>
           </a:p>
@@ -21449,7 +21449,7 @@
                 <a:ea typeface="Inter" pitchFamily="34" charset="-122"/>
                 <a:cs typeface="Inter" pitchFamily="34" charset="-120"/>
               </a:rPr>
-              <a:t>+$20K</a:t>
+              <a:t>+$15K</a:t>
             </a:r>
             <a:endParaRPr lang="en-US" sz="1300" dirty="0"/>
           </a:p>
@@ -21625,7 +21625,7 @@
                 <a:ea typeface="Inter" pitchFamily="34" charset="-122"/>
                 <a:cs typeface="Inter" pitchFamily="34" charset="-120"/>
               </a:rPr>
-              <a:t>+$16K</a:t>
+              <a:t>+$12K</a:t>
             </a:r>
             <a:endParaRPr lang="en-US" sz="1300" dirty="0"/>
           </a:p>
@@ -21801,7 +21801,7 @@
                 <a:ea typeface="Inter" pitchFamily="34" charset="-122"/>
                 <a:cs typeface="Inter" pitchFamily="34" charset="-120"/>
               </a:rPr>
-              <a:t>+$9K</a:t>
+              <a:t>+$7K</a:t>
             </a:r>
             <a:endParaRPr lang="en-US" sz="1300" dirty="0"/>
           </a:p>
@@ -21977,7 +21977,7 @@
                 <a:ea typeface="Inter" pitchFamily="34" charset="-122"/>
                 <a:cs typeface="Inter" pitchFamily="34" charset="-120"/>
               </a:rPr>
-              <a:t>+$7K</a:t>
+              <a:t>+$5K</a:t>
             </a:r>
             <a:endParaRPr lang="en-US" sz="1300" dirty="0"/>
           </a:p>
@@ -22153,7 +22153,7 @@
                 <a:ea typeface="Inter" pitchFamily="34" charset="-122"/>
                 <a:cs typeface="Inter" pitchFamily="34" charset="-120"/>
               </a:rPr>
-              <a:t>+$5K</a:t>
+              <a:t>+$4K</a:t>
             </a:r>
             <a:endParaRPr lang="en-US" sz="1300" dirty="0"/>
           </a:p>
@@ -22329,7 +22329,7 @@
                 <a:ea typeface="Inter" pitchFamily="34" charset="-122"/>
                 <a:cs typeface="Inter" pitchFamily="34" charset="-120"/>
               </a:rPr>
-              <a:t>−$3K</a:t>
+              <a:t>−$2K</a:t>
             </a:r>
             <a:endParaRPr lang="en-US" sz="1300" dirty="0"/>
           </a:p>
@@ -22505,7 +22505,7 @@
                 <a:ea typeface="Inter" pitchFamily="34" charset="-122"/>
                 <a:cs typeface="Inter" pitchFamily="34" charset="-120"/>
               </a:rPr>
-              <a:t>−$4K</a:t>
+              <a:t>−$3K</a:t>
             </a:r>
             <a:endParaRPr lang="en-US" sz="1300" dirty="0"/>
           </a:p>
@@ -22681,7 +22681,7 @@
                 <a:ea typeface="Inter" pitchFamily="34" charset="-122"/>
                 <a:cs typeface="Inter" pitchFamily="34" charset="-120"/>
               </a:rPr>
-              <a:t>−$11K</a:t>
+              <a:t>−$8K</a:t>
             </a:r>
             <a:endParaRPr lang="en-US" sz="1300" dirty="0"/>
           </a:p>
@@ -22857,7 +22857,7 @@
                 <a:ea typeface="Inter" pitchFamily="34" charset="-122"/>
                 <a:cs typeface="Inter" pitchFamily="34" charset="-120"/>
               </a:rPr>
-              <a:t>−$13K</a:t>
+              <a:t>−$10K</a:t>
             </a:r>
             <a:endParaRPr lang="en-US" sz="1300" dirty="0"/>
           </a:p>
@@ -23033,7 +23033,7 @@
                 <a:ea typeface="Inter" pitchFamily="34" charset="-122"/>
                 <a:cs typeface="Inter" pitchFamily="34" charset="-120"/>
               </a:rPr>
-              <a:t>−$15K</a:t>
+              <a:t>−$11K</a:t>
             </a:r>
             <a:endParaRPr lang="en-US" sz="1300" dirty="0"/>
           </a:p>
@@ -23209,7 +23209,7 @@
                 <a:ea typeface="Inter" pitchFamily="34" charset="-122"/>
                 <a:cs typeface="Inter" pitchFamily="34" charset="-120"/>
               </a:rPr>
-              <a:t>−$18K</a:t>
+              <a:t>−$13K</a:t>
             </a:r>
             <a:endParaRPr lang="en-US" sz="1300" dirty="0"/>
           </a:p>
@@ -23385,7 +23385,7 @@
                 <a:ea typeface="Inter" pitchFamily="34" charset="-122"/>
                 <a:cs typeface="Inter" pitchFamily="34" charset="-120"/>
               </a:rPr>
-              <a:t>−$20K</a:t>
+              <a:t>−$15K</a:t>
             </a:r>
             <a:endParaRPr lang="en-US" sz="1300" dirty="0"/>
           </a:p>
@@ -23561,7 +23561,7 @@
                 <a:ea typeface="Inter" pitchFamily="34" charset="-122"/>
                 <a:cs typeface="Inter" pitchFamily="34" charset="-120"/>
               </a:rPr>
-              <a:t>−$21K</a:t>
+              <a:t>−$15K</a:t>
             </a:r>
             <a:endParaRPr lang="en-US" sz="1300" dirty="0"/>
           </a:p>
@@ -23737,7 +23737,7 @@
                 <a:ea typeface="Inter" pitchFamily="34" charset="-122"/>
                 <a:cs typeface="Inter" pitchFamily="34" charset="-120"/>
               </a:rPr>
-              <a:t>−$21K</a:t>
+              <a:t>−$16K</a:t>
             </a:r>
             <a:endParaRPr lang="en-US" sz="1300" dirty="0"/>
           </a:p>
@@ -23913,7 +23913,7 @@
                 <a:ea typeface="Inter" pitchFamily="34" charset="-122"/>
                 <a:cs typeface="Inter" pitchFamily="34" charset="-120"/>
               </a:rPr>
-              <a:t>−$22K</a:t>
+              <a:t>−$17K</a:t>
             </a:r>
             <a:endParaRPr lang="en-US" sz="1300" dirty="0"/>
           </a:p>
@@ -24089,7 +24089,7 @@
                 <a:ea typeface="Inter" pitchFamily="34" charset="-122"/>
                 <a:cs typeface="Inter" pitchFamily="34" charset="-120"/>
               </a:rPr>
-              <a:t>−$25K</a:t>
+              <a:t>−$19K</a:t>
             </a:r>
             <a:endParaRPr lang="en-US" sz="1300" dirty="0"/>
           </a:p>
@@ -24265,7 +24265,7 @@
                 <a:ea typeface="Inter" pitchFamily="34" charset="-122"/>
                 <a:cs typeface="Inter" pitchFamily="34" charset="-120"/>
               </a:rPr>
-              <a:t>−$32K</a:t>
+              <a:t>−$24K</a:t>
             </a:r>
             <a:endParaRPr lang="en-US" sz="1300" dirty="0"/>
           </a:p>
@@ -24441,7 +24441,7 @@
                 <a:ea typeface="Inter" pitchFamily="34" charset="-122"/>
                 <a:cs typeface="Inter" pitchFamily="34" charset="-120"/>
               </a:rPr>
-              <a:t>−$32K</a:t>
+              <a:t>−$24K</a:t>
             </a:r>
             <a:endParaRPr lang="en-US" sz="1300" dirty="0"/>
           </a:p>
@@ -24617,7 +24617,7 @@
                 <a:ea typeface="Inter" pitchFamily="34" charset="-122"/>
                 <a:cs typeface="Inter" pitchFamily="34" charset="-120"/>
               </a:rPr>
-              <a:t>−$48K</a:t>
+              <a:t>−$36K</a:t>
             </a:r>
             <a:endParaRPr lang="en-US" sz="1300" dirty="0"/>
           </a:p>
@@ -24793,7 +24793,7 @@
                 <a:ea typeface="Inter" pitchFamily="34" charset="-122"/>
                 <a:cs typeface="Inter" pitchFamily="34" charset="-120"/>
               </a:rPr>
-              <a:t>−$53K</a:t>
+              <a:t>−$39K</a:t>
             </a:r>
             <a:endParaRPr lang="en-US" sz="1300" dirty="0"/>
           </a:p>
@@ -24969,7 +24969,7 @@
                 <a:ea typeface="Inter" pitchFamily="34" charset="-122"/>
                 <a:cs typeface="Inter" pitchFamily="34" charset="-120"/>
               </a:rPr>
-              <a:t>−$57K</a:t>
+              <a:t>−$43K</a:t>
             </a:r>
             <a:endParaRPr lang="en-US" sz="1300" dirty="0"/>
           </a:p>
@@ -25145,7 +25145,7 @@
                 <a:ea typeface="Inter" pitchFamily="34" charset="-122"/>
                 <a:cs typeface="Inter" pitchFamily="34" charset="-120"/>
               </a:rPr>
-              <a:t>−$67K</a:t>
+              <a:t>−$51K</a:t>
             </a:r>
             <a:endParaRPr lang="en-US" sz="1300" dirty="0"/>
           </a:p>
@@ -25321,7 +25321,7 @@
                 <a:ea typeface="Inter" pitchFamily="34" charset="-122"/>
                 <a:cs typeface="Inter" pitchFamily="34" charset="-120"/>
               </a:rPr>
-              <a:t>−$74K</a:t>
+              <a:t>−$56K</a:t>
             </a:r>
             <a:endParaRPr lang="en-US" sz="1300" dirty="0"/>
           </a:p>
@@ -25497,7 +25497,7 @@
                 <a:ea typeface="Inter" pitchFamily="34" charset="-122"/>
                 <a:cs typeface="Inter" pitchFamily="34" charset="-120"/>
               </a:rPr>
-              <a:t>−$78K</a:t>
+              <a:t>−$58K</a:t>
             </a:r>
             <a:endParaRPr lang="en-US" sz="1300" dirty="0"/>
           </a:p>
@@ -25673,7 +25673,7 @@
                 <a:ea typeface="Inter" pitchFamily="34" charset="-122"/>
                 <a:cs typeface="Inter" pitchFamily="34" charset="-120"/>
               </a:rPr>
-              <a:t>−$80K</a:t>
+              <a:t>−$60K</a:t>
             </a:r>
             <a:endParaRPr lang="en-US" sz="1300" dirty="0"/>
           </a:p>
@@ -25849,7 +25849,7 @@
                 <a:ea typeface="Inter" pitchFamily="34" charset="-122"/>
                 <a:cs typeface="Inter" pitchFamily="34" charset="-120"/>
               </a:rPr>
-              <a:t>−$151K</a:t>
+              <a:t>−$113K</a:t>
             </a:r>
             <a:endParaRPr lang="en-US" sz="1300" dirty="0"/>
           </a:p>
@@ -25923,7 +25923,7 @@
         <p:spPr>
           <a:xfrm>
             <a:off x="457200" y="6126480"/>
-            <a:ext cx="11274552" cy="356616"/>
+            <a:ext cx="11274552" cy="615696"/>
           </a:xfrm>
           <a:prstGeom prst="rect">
             <a:avLst/>
@@ -25943,7 +25943,7 @@
         <p:spPr>
           <a:xfrm>
             <a:off x="658368" y="6144768"/>
-            <a:ext cx="10927080" cy="320040"/>
+            <a:ext cx="10927080" cy="579120"/>
           </a:xfrm>
           <a:prstGeom prst="rect">
             <a:avLst/>
@@ -25959,7 +25959,7 @@
               <a:buNone/>
             </a:pPr>
             <a:r>
-              <a:rPr lang="en-US" sz="1500" b="1" dirty="0">
+              <a:rPr lang="en-US" sz="1600" b="1" dirty="0">
                 <a:solidFill>
                   <a:srgbClr val="A82B26"/>
                 </a:solidFill>
@@ -25967,9 +25967,9 @@
                 <a:ea typeface="Inter" pitchFamily="34" charset="-122"/>
                 <a:cs typeface="Inter" pitchFamily="34" charset="-120"/>
               </a:rPr>
-              <a:t>21 stores under 10% leave $844,657 a year; 12 are at or above it. Chevy LV is furthest below at −$151K.</a:t>
-            </a:r>
-            <a:endParaRPr lang="en-US" sz="1500" dirty="0"/>
+              <a:t>21 stores under 10% have left $633,493 so far this year; 12 are at or above it. Chevy LV is furthest below at −$113K.</a:t>
+            </a:r>
+            <a:endParaRPr lang="en-US" sz="1600" dirty="0"/>
           </a:p>
         </p:txBody>
       </p:sp>
@@ -26058,7 +26058,7 @@
                 <a:ea typeface="Inter" pitchFamily="34" charset="-122"/>
                 <a:cs typeface="Inter" pitchFamily="34" charset="-120"/>
               </a:rPr>
-              <a:t>OPCODES · JAN–SEP 2026, ANNUALIZED</a:t>
+              <a:t>OPCODES · JAN–SEP 2026 YTD</a:t>
             </a:r>
             <a:endParaRPr lang="en-US" sz="1400" dirty="0"/>
           </a:p>
@@ -26450,7 +26450,7 @@
                 <a:ea typeface="Inter" pitchFamily="34" charset="-122"/>
                 <a:cs typeface="Inter" pitchFamily="34" charset="-120"/>
               </a:rPr>
-              <a:t>+$185K</a:t>
+              <a:t>+$138K</a:t>
             </a:r>
             <a:endParaRPr lang="en-US" sz="1300" dirty="0"/>
           </a:p>
@@ -26626,7 +26626,7 @@
                 <a:ea typeface="Inter" pitchFamily="34" charset="-122"/>
                 <a:cs typeface="Inter" pitchFamily="34" charset="-120"/>
               </a:rPr>
-              <a:t>+$72K</a:t>
+              <a:t>+$54K</a:t>
             </a:r>
             <a:endParaRPr lang="en-US" sz="1300" dirty="0"/>
           </a:p>
@@ -26802,7 +26802,7 @@
                 <a:ea typeface="Inter" pitchFamily="34" charset="-122"/>
                 <a:cs typeface="Inter" pitchFamily="34" charset="-120"/>
               </a:rPr>
-              <a:t>+$51K</a:t>
+              <a:t>+$39K</a:t>
             </a:r>
             <a:endParaRPr lang="en-US" sz="1300" dirty="0"/>
           </a:p>
@@ -26978,7 +26978,7 @@
                 <a:ea typeface="Inter" pitchFamily="34" charset="-122"/>
                 <a:cs typeface="Inter" pitchFamily="34" charset="-120"/>
               </a:rPr>
-              <a:t>+$13K</a:t>
+              <a:t>+$10K</a:t>
             </a:r>
             <a:endParaRPr lang="en-US" sz="1300" dirty="0"/>
           </a:p>
@@ -27154,7 +27154,7 @@
                 <a:ea typeface="Inter" pitchFamily="34" charset="-122"/>
                 <a:cs typeface="Inter" pitchFamily="34" charset="-120"/>
               </a:rPr>
-              <a:t>+$12K</a:t>
+              <a:t>+$9K</a:t>
             </a:r>
             <a:endParaRPr lang="en-US" sz="1300" dirty="0"/>
           </a:p>
@@ -27330,7 +27330,7 @@
                 <a:ea typeface="Inter" pitchFamily="34" charset="-122"/>
                 <a:cs typeface="Inter" pitchFamily="34" charset="-120"/>
               </a:rPr>
-              <a:t>+$4K</a:t>
+              <a:t>+$3K</a:t>
             </a:r>
             <a:endParaRPr lang="en-US" sz="1300" dirty="0"/>
           </a:p>
@@ -27506,7 +27506,7 @@
                 <a:ea typeface="Inter" pitchFamily="34" charset="-122"/>
                 <a:cs typeface="Inter" pitchFamily="34" charset="-120"/>
               </a:rPr>
-              <a:t>+$4K</a:t>
+              <a:t>+$3K</a:t>
             </a:r>
             <a:endParaRPr lang="en-US" sz="1300" dirty="0"/>
           </a:p>
@@ -27682,7 +27682,7 @@
                 <a:ea typeface="Inter" pitchFamily="34" charset="-122"/>
                 <a:cs typeface="Inter" pitchFamily="34" charset="-120"/>
               </a:rPr>
-              <a:t>−$1K</a:t>
+              <a:t>−$905</a:t>
             </a:r>
             <a:endParaRPr lang="en-US" sz="1300" dirty="0"/>
           </a:p>
@@ -27858,7 +27858,7 @@
                 <a:ea typeface="Inter" pitchFamily="34" charset="-122"/>
                 <a:cs typeface="Inter" pitchFamily="34" charset="-120"/>
               </a:rPr>
-              <a:t>−$10K</a:t>
+              <a:t>−$8K</a:t>
             </a:r>
             <a:endParaRPr lang="en-US" sz="1300" dirty="0"/>
           </a:p>
@@ -28034,7 +28034,7 @@
                 <a:ea typeface="Inter" pitchFamily="34" charset="-122"/>
                 <a:cs typeface="Inter" pitchFamily="34" charset="-120"/>
               </a:rPr>
-              <a:t>−$13K</a:t>
+              <a:t>−$10K</a:t>
             </a:r>
             <a:endParaRPr lang="en-US" sz="1300" dirty="0"/>
           </a:p>
@@ -28210,7 +28210,7 @@
                 <a:ea typeface="Inter" pitchFamily="34" charset="-122"/>
                 <a:cs typeface="Inter" pitchFamily="34" charset="-120"/>
               </a:rPr>
-              <a:t>−$18K</a:t>
+              <a:t>−$14K</a:t>
             </a:r>
             <a:endParaRPr lang="en-US" sz="1300" dirty="0"/>
           </a:p>
@@ -28386,7 +28386,7 @@
                 <a:ea typeface="Inter" pitchFamily="34" charset="-122"/>
                 <a:cs typeface="Inter" pitchFamily="34" charset="-120"/>
               </a:rPr>
-              <a:t>−$19K</a:t>
+              <a:t>−$14K</a:t>
             </a:r>
             <a:endParaRPr lang="en-US" sz="1300" dirty="0"/>
           </a:p>
@@ -28562,7 +28562,7 @@
                 <a:ea typeface="Inter" pitchFamily="34" charset="-122"/>
                 <a:cs typeface="Inter" pitchFamily="34" charset="-120"/>
               </a:rPr>
-              <a:t>−$21K</a:t>
+              <a:t>−$16K</a:t>
             </a:r>
             <a:endParaRPr lang="en-US" sz="1300" dirty="0"/>
           </a:p>
@@ -28738,7 +28738,7 @@
                 <a:ea typeface="Inter" pitchFamily="34" charset="-122"/>
                 <a:cs typeface="Inter" pitchFamily="34" charset="-120"/>
               </a:rPr>
-              <a:t>−$24K</a:t>
+              <a:t>−$18K</a:t>
             </a:r>
             <a:endParaRPr lang="en-US" sz="1300" dirty="0"/>
           </a:p>
@@ -28914,7 +28914,7 @@
                 <a:ea typeface="Inter" pitchFamily="34" charset="-122"/>
                 <a:cs typeface="Inter" pitchFamily="34" charset="-120"/>
               </a:rPr>
-              <a:t>−$25K</a:t>
+              <a:t>−$19K</a:t>
             </a:r>
             <a:endParaRPr lang="en-US" sz="1300" dirty="0"/>
           </a:p>
@@ -29090,7 +29090,7 @@
                 <a:ea typeface="Inter" pitchFamily="34" charset="-122"/>
                 <a:cs typeface="Inter" pitchFamily="34" charset="-120"/>
               </a:rPr>
-              <a:t>−$26K</a:t>
+              <a:t>−$20K</a:t>
             </a:r>
             <a:endParaRPr lang="en-US" sz="1300" dirty="0"/>
           </a:p>
@@ -29266,7 +29266,7 @@
                 <a:ea typeface="Inter" pitchFamily="34" charset="-122"/>
                 <a:cs typeface="Inter" pitchFamily="34" charset="-120"/>
               </a:rPr>
-              <a:t>−$29K</a:t>
+              <a:t>−$22K</a:t>
             </a:r>
             <a:endParaRPr lang="en-US" sz="1300" dirty="0"/>
           </a:p>
@@ -29442,7 +29442,7 @@
                 <a:ea typeface="Inter" pitchFamily="34" charset="-122"/>
                 <a:cs typeface="Inter" pitchFamily="34" charset="-120"/>
               </a:rPr>
-              <a:t>−$34K</a:t>
+              <a:t>−$25K</a:t>
             </a:r>
             <a:endParaRPr lang="en-US" sz="1300" dirty="0"/>
           </a:p>
@@ -29618,7 +29618,7 @@
                 <a:ea typeface="Inter" pitchFamily="34" charset="-122"/>
                 <a:cs typeface="Inter" pitchFamily="34" charset="-120"/>
               </a:rPr>
-              <a:t>−$46K</a:t>
+              <a:t>−$34K</a:t>
             </a:r>
             <a:endParaRPr lang="en-US" sz="1300" dirty="0"/>
           </a:p>
@@ -29794,7 +29794,7 @@
                 <a:ea typeface="Inter" pitchFamily="34" charset="-122"/>
                 <a:cs typeface="Inter" pitchFamily="34" charset="-120"/>
               </a:rPr>
-              <a:t>−$51K</a:t>
+              <a:t>−$39K</a:t>
             </a:r>
             <a:endParaRPr lang="en-US" sz="1300" dirty="0"/>
           </a:p>
@@ -29970,7 +29970,7 @@
                 <a:ea typeface="Inter" pitchFamily="34" charset="-122"/>
                 <a:cs typeface="Inter" pitchFamily="34" charset="-120"/>
               </a:rPr>
-              <a:t>−$56K</a:t>
+              <a:t>−$42K</a:t>
             </a:r>
             <a:endParaRPr lang="en-US" sz="1300" dirty="0"/>
           </a:p>
@@ -30146,7 +30146,7 @@
                 <a:ea typeface="Inter" pitchFamily="34" charset="-122"/>
                 <a:cs typeface="Inter" pitchFamily="34" charset="-120"/>
               </a:rPr>
-              <a:t>−$56K</a:t>
+              <a:t>−$42K</a:t>
             </a:r>
             <a:endParaRPr lang="en-US" sz="1300" dirty="0"/>
           </a:p>
@@ -30322,7 +30322,7 @@
                 <a:ea typeface="Inter" pitchFamily="34" charset="-122"/>
                 <a:cs typeface="Inter" pitchFamily="34" charset="-120"/>
               </a:rPr>
-              <a:t>−$60K</a:t>
+              <a:t>−$45K</a:t>
             </a:r>
             <a:endParaRPr lang="en-US" sz="1300" dirty="0"/>
           </a:p>
@@ -30498,7 +30498,7 @@
                 <a:ea typeface="Inter" pitchFamily="34" charset="-122"/>
                 <a:cs typeface="Inter" pitchFamily="34" charset="-120"/>
               </a:rPr>
-              <a:t>−$62K</a:t>
+              <a:t>−$46K</a:t>
             </a:r>
             <a:endParaRPr lang="en-US" sz="1300" dirty="0"/>
           </a:p>
@@ -30674,7 +30674,7 @@
                 <a:ea typeface="Inter" pitchFamily="34" charset="-122"/>
                 <a:cs typeface="Inter" pitchFamily="34" charset="-120"/>
               </a:rPr>
-              <a:t>−$62K</a:t>
+              <a:t>−$47K</a:t>
             </a:r>
             <a:endParaRPr lang="en-US" sz="1300" dirty="0"/>
           </a:p>
@@ -30850,7 +30850,7 @@
                 <a:ea typeface="Inter" pitchFamily="34" charset="-122"/>
                 <a:cs typeface="Inter" pitchFamily="34" charset="-120"/>
               </a:rPr>
-              <a:t>−$64K</a:t>
+              <a:t>−$48K</a:t>
             </a:r>
             <a:endParaRPr lang="en-US" sz="1300" dirty="0"/>
           </a:p>
@@ -31026,7 +31026,7 @@
                 <a:ea typeface="Inter" pitchFamily="34" charset="-122"/>
                 <a:cs typeface="Inter" pitchFamily="34" charset="-120"/>
               </a:rPr>
-              <a:t>−$65K</a:t>
+              <a:t>−$49K</a:t>
             </a:r>
             <a:endParaRPr lang="en-US" sz="1300" dirty="0"/>
           </a:p>
@@ -31202,7 +31202,7 @@
                 <a:ea typeface="Inter" pitchFamily="34" charset="-122"/>
                 <a:cs typeface="Inter" pitchFamily="34" charset="-120"/>
               </a:rPr>
-              <a:t>−$75K</a:t>
+              <a:t>−$56K</a:t>
             </a:r>
             <a:endParaRPr lang="en-US" sz="1300" dirty="0"/>
           </a:p>
@@ -31378,7 +31378,7 @@
                 <a:ea typeface="Inter" pitchFamily="34" charset="-122"/>
                 <a:cs typeface="Inter" pitchFamily="34" charset="-120"/>
               </a:rPr>
-              <a:t>−$76K</a:t>
+              <a:t>−$57K</a:t>
             </a:r>
             <a:endParaRPr lang="en-US" sz="1300" dirty="0"/>
           </a:p>
@@ -31554,7 +31554,7 @@
                 <a:ea typeface="Inter" pitchFamily="34" charset="-122"/>
                 <a:cs typeface="Inter" pitchFamily="34" charset="-120"/>
               </a:rPr>
-              <a:t>−$85K</a:t>
+              <a:t>−$63K</a:t>
             </a:r>
             <a:endParaRPr lang="en-US" sz="1300" dirty="0"/>
           </a:p>
@@ -31730,7 +31730,7 @@
                 <a:ea typeface="Inter" pitchFamily="34" charset="-122"/>
                 <a:cs typeface="Inter" pitchFamily="34" charset="-120"/>
               </a:rPr>
-              <a:t>−$109K</a:t>
+              <a:t>−$82K</a:t>
             </a:r>
             <a:endParaRPr lang="en-US" sz="1300" dirty="0"/>
           </a:p>
@@ -31906,7 +31906,7 @@
                 <a:ea typeface="Inter" pitchFamily="34" charset="-122"/>
                 <a:cs typeface="Inter" pitchFamily="34" charset="-120"/>
               </a:rPr>
-              <a:t>−$129K</a:t>
+              <a:t>−$96K</a:t>
             </a:r>
             <a:endParaRPr lang="en-US" sz="1300" dirty="0"/>
           </a:p>
@@ -32082,7 +32082,7 @@
                 <a:ea typeface="Inter" pitchFamily="34" charset="-122"/>
                 <a:cs typeface="Inter" pitchFamily="34" charset="-120"/>
               </a:rPr>
-              <a:t>−$142K</a:t>
+              <a:t>−$107K</a:t>
             </a:r>
             <a:endParaRPr lang="en-US" sz="1300" dirty="0"/>
           </a:p>
@@ -32156,7 +32156,7 @@
         <p:spPr>
           <a:xfrm>
             <a:off x="457200" y="6126480"/>
-            <a:ext cx="11274552" cy="356616"/>
+            <a:ext cx="11274552" cy="615696"/>
           </a:xfrm>
           <a:prstGeom prst="rect">
             <a:avLst/>
@@ -32176,7 +32176,7 @@
         <p:spPr>
           <a:xfrm>
             <a:off x="658368" y="6144768"/>
-            <a:ext cx="10927080" cy="320040"/>
+            <a:ext cx="10927080" cy="579120"/>
           </a:xfrm>
           <a:prstGeom prst="rect">
             <a:avLst/>
@@ -32192,7 +32192,7 @@
               <a:buNone/>
             </a:pPr>
             <a:r>
-              <a:rPr lang="en-US" sz="1500" b="1" dirty="0">
+              <a:rPr lang="en-US" sz="1600" b="1" dirty="0">
                 <a:solidFill>
                   <a:srgbClr val="A82B26"/>
                 </a:solidFill>
@@ -32200,9 +32200,9 @@
                 <a:ea typeface="Inter" pitchFamily="34" charset="-122"/>
                 <a:cs typeface="Inter" pitchFamily="34" charset="-120"/>
               </a:rPr>
-              <a:t>26 stores under 7.5% leave $1,356,881 a year; 7 are at or above it. Chevy LV is furthest below at −$142K.</a:t>
-            </a:r>
-            <a:endParaRPr lang="en-US" sz="1500" dirty="0"/>
+              <a:t>26 stores under 7.5% have left $1,017,661 so far this year; 7 are at or above it. Chevy LV is furthest below at −$107K.</a:t>
+            </a:r>
+            <a:endParaRPr lang="en-US" sz="1600" dirty="0"/>
           </a:p>
         </p:txBody>
       </p:sp>

</xml_diff>

<commit_message>
Total variance slide: opcodes column (four services added together)
Co-Authored-By: Claude Opus 5.5 <noreply@anthropic.com>
Claude-Session: https://claude.ai/code/session_01Xa4nFVxuQGXmHARGph9WhS
</commit_message>
<xml_diff>
--- a/day2-deck/decks/Op Code Missed Opportunity - Review.pptx
+++ b/day2-deck/decks/Op Code Missed Opportunity - Review.pptx
@@ -595,39 +595,39 @@
           <a:p>
             <a:r>
               <a:rPr lang="en-US" dirty="0"/>
-              <a:t>Source: Qlik - Closed Repair Orders. Customer pay, Jan-Sep 2026 by close date, op code report basis. Same-store, INEOS excluded (opened 2026). Services short = benchmark x the store's CP ROs, minus the services it sold. Each service valued at the store's own labor + parts gross per service sold (group average where the store sold fewer than 30), capped at twice the group average because some flagged lines carry other work bundled on them. Alignment, tire balance, brake fluid and fuel system service added together, every store: gross Jan-Sep 2026 above (+) or below (-) the four benchmarks, at the store's own gross per service. Below-benchmark services count against above-benchmark ones here.TOYOTA SPOKANE: −$406K Jan-Sep against the four benchmarks; under 4 of 4
-CHEVY LV: −$356K Jan-Sep against the four benchmarks; under 4 of 4
-TOYOTA FLAGSTAFF: −$267K Jan-Sep against the four benchmarks; under 4 of 4
-TOYOTA HENDERSON: −$227K Jan-Sep against the four benchmarks; under 3 of 4
-KIA LV: −$185K Jan-Sep against the four benchmarks; under 4 of 4
-CDJR POST FALLS: −$184K Jan-Sep against the four benchmarks; under 4 of 4
-TOYOTA PRESCOTT: −$175K Jan-Sep against the four benchmarks; under 4 of 4
-AUDI RENO: −$162K Jan-Sep against the four benchmarks; under 4 of 4
-HONDA FLAGSTAFF: −$150K Jan-Sep against the four benchmarks; under 4 of 4
-NISSAN: −$150K Jan-Sep against the four benchmarks; under 3 of 4
-HONDA SPOKANE: −$140K Jan-Sep against the four benchmarks; under 3 of 4
-LEXUS: −$105K Jan-Sep against the four benchmarks; under 4 of 4
-VW HENDERSON: −$105K Jan-Sep against the four benchmarks; under 4 of 4
-CHEVY GMC BULLHEAD: −$100K Jan-Sep against the four benchmarks; under 4 of 4
-CADILLAC: −$94K Jan-Sep against the four benchmarks; under 4 of 4
-VW ST GEORGE: −$66K Jan-Sep against the four benchmarks; under 4 of 4
-HYUNDAI ST GEORGE: −$61K Jan-Sep against the four benchmarks; under 4 of 4
-GMC PRESCOTT: −$60K Jan-Sep against the four benchmarks; under 4 of 4
-SUBARU LV: −$59K Jan-Sep against the four benchmarks; under 3 of 4
-KIA ST GEORGE: −$53K Jan-Sep against the four benchmarks; under 3 of 4
-LINCOLN: −$48K Jan-Sep against the four benchmarks; under 3 of 4
-SUBARU ST GEORGE: −$41K Jan-Sep against the four benchmarks; under 2 of 4
-LR RENO: −$32K Jan-Sep against the four benchmarks; under 3 of 4
-VOLVO: −$29K Jan-Sep against the four benchmarks; under 3 of 4
-MAZDA: −$28K Jan-Sep against the four benchmarks; under 3 of 4
-AUDI HENDERSON: −$22K Jan-Sep against the four benchmarks; under 3 of 4
-HYUNDAI PRESCOTT: +$23K Jan-Sep against the four benchmarks; under 3 of 4
-ACURA: +$33K Jan-Sep against the four benchmarks; under 1 of 4
-SUBARU PRESCOTT: +$41K Jan-Sep against the four benchmarks; under 2 of 4
-HONDA NORTH: +$45K Jan-Sep against the four benchmarks; under 1 of 4
-LR HENDERSON: +$54K Jan-Sep against the four benchmarks; under 1 of 4
-LR LV: +$151K Jan-Sep against the four benchmarks; under 1 of 4
-HONDA HENDERSON: +$557K Jan-Sep against the four benchmarks; under 0 of 4</a:t>
+              <a:t>Source: Qlik - Closed Repair Orders. Customer pay, Jan-Sep 2026 by close date, op code report basis. Same-store, INEOS excluded (opened 2026). Services short = benchmark x the store's CP ROs, minus the services it sold. Each service valued at the store's own labor + parts gross per service sold (group average where the store sold fewer than 30), capped at twice the group average because some flagged lines carry other work bundled on them. Alignment, tire balance, brake fluid and fuel system service added together, every store: gross Jan-Sep 2026 above (+) or below (-) the four benchmarks, at the store's own gross per service. Opcodes = the four services' opcodes above (+) or below (-) their benchmarks, added together. Below-benchmark services count against above-benchmark ones here.TOYOTA SPOKANE: −$406K, −5,191 opcodes Jan-Sep against the four benchmarks; under 4 of 4
+CHEVY LV: −$356K, −3,177 opcodes Jan-Sep against the four benchmarks; under 4 of 4
+TOYOTA FLAGSTAFF: −$267K, −3,494 opcodes Jan-Sep against the four benchmarks; under 4 of 4
+TOYOTA HENDERSON: −$227K, −3,005 opcodes Jan-Sep against the four benchmarks; under 3 of 4
+KIA LV: −$185K, −1,708 opcodes Jan-Sep against the four benchmarks; under 4 of 4
+CDJR POST FALLS: −$184K, −1,863 opcodes Jan-Sep against the four benchmarks; under 4 of 4
+TOYOTA PRESCOTT: −$175K, −1,906 opcodes Jan-Sep against the four benchmarks; under 4 of 4
+AUDI RENO: −$162K, −1,152 opcodes Jan-Sep against the four benchmarks; under 4 of 4
+HONDA FLAGSTAFF: −$150K, −1,257 opcodes Jan-Sep against the four benchmarks; under 4 of 4
+NISSAN: −$150K, −1,613 opcodes Jan-Sep against the four benchmarks; under 3 of 4
+HONDA SPOKANE: −$140K, −1,717 opcodes Jan-Sep against the four benchmarks; under 3 of 4
+LEXUS: −$105K, −1,068 opcodes Jan-Sep against the four benchmarks; under 4 of 4
+VW HENDERSON: −$105K, −827 opcodes Jan-Sep against the four benchmarks; under 4 of 4
+CHEVY GMC BULLHEAD: −$100K, −1,100 opcodes Jan-Sep against the four benchmarks; under 4 of 4
+CADILLAC: −$94K, −954 opcodes Jan-Sep against the four benchmarks; under 4 of 4
+VW ST GEORGE: −$66K, −640 opcodes Jan-Sep against the four benchmarks; under 4 of 4
+HYUNDAI ST GEORGE: −$61K, −697 opcodes Jan-Sep against the four benchmarks; under 4 of 4
+GMC PRESCOTT: −$60K, −568 opcodes Jan-Sep against the four benchmarks; under 4 of 4
+SUBARU LV: −$59K, −783 opcodes Jan-Sep against the four benchmarks; under 3 of 4
+KIA ST GEORGE: −$53K, −660 opcodes Jan-Sep against the four benchmarks; under 3 of 4
+LINCOLN: −$48K, −569 opcodes Jan-Sep against the four benchmarks; under 3 of 4
+SUBARU ST GEORGE: −$41K, −452 opcodes Jan-Sep against the four benchmarks; under 2 of 4
+LR RENO: −$32K, −83 opcodes Jan-Sep against the four benchmarks; under 3 of 4
+VOLVO: −$29K, −340 opcodes Jan-Sep against the four benchmarks; under 3 of 4
+MAZDA: −$28K, −223 opcodes Jan-Sep against the four benchmarks; under 3 of 4
+AUDI HENDERSON: −$22K, −661 opcodes Jan-Sep against the four benchmarks; under 3 of 4
+HYUNDAI PRESCOTT: +$23K, +97 opcodes Jan-Sep against the four benchmarks; under 3 of 4
+ACURA: +$33K, +228 opcodes Jan-Sep against the four benchmarks; under 1 of 4
+SUBARU PRESCOTT: +$41K, +24 opcodes Jan-Sep against the four benchmarks; under 2 of 4
+HONDA NORTH: +$45K, +70 opcodes Jan-Sep against the four benchmarks; under 1 of 4
+LR HENDERSON: +$54K, +324 opcodes Jan-Sep against the four benchmarks; under 1 of 4
+LR LV: +$151K, +456 opcodes Jan-Sep against the four benchmarks; under 1 of 4
+HONDA HENDERSON: +$557K, +4,476 opcodes Jan-Sep against the four benchmarks; under 0 of 4</a:t>
             </a:r>
             <a:endParaRPr lang="en-US" dirty="0"/>
           </a:p>
@@ -2564,7 +2564,7 @@
         </p:nvSpPr>
         <p:spPr>
           <a:xfrm>
-            <a:off x="4818888" y="1316736"/>
+            <a:off x="3950208" y="1316736"/>
             <a:ext cx="1097280" cy="329184"/>
           </a:xfrm>
           <a:prstGeom prst="rect">
@@ -2597,13 +2597,52 @@
       </p:sp>
       <p:sp>
         <p:nvSpPr>
-          <p:cNvPr id="7" name="Shape 5"/>
+          <p:cNvPr id="7" name="Text 5"/>
+          <p:cNvSpPr txBox="1"/>
+          <p:nvPr/>
+        </p:nvSpPr>
+        <p:spPr>
+          <a:xfrm>
+            <a:off x="5047488" y="1316736"/>
+            <a:ext cx="868680" cy="329184"/>
+          </a:xfrm>
+          <a:prstGeom prst="rect">
+            <a:avLst/>
+          </a:prstGeom>
+          <a:noFill/>
+          <a:ln/>
+        </p:spPr>
+        <p:txBody>
+          <a:bodyPr wrap="square" lIns="0" tIns="0" rIns="0" bIns="0" rtlCol="0" anchor="ctr"/>
+          <a:lstStyle/>
+          <a:p>
+            <a:pPr algn="r" indent="0" marL="0">
+              <a:buNone/>
+            </a:pPr>
+            <a:r>
+              <a:rPr lang="en-US" sz="1400" b="1" dirty="0">
+                <a:solidFill>
+                  <a:srgbClr val="595959"/>
+                </a:solidFill>
+                <a:latin typeface="Inter" pitchFamily="34" charset="0"/>
+                <a:ea typeface="Inter" pitchFamily="34" charset="-122"/>
+                <a:cs typeface="Inter" pitchFamily="34" charset="-120"/>
+              </a:rPr>
+              <a:t>Opcodes</a:t>
+            </a:r>
+            <a:endParaRPr lang="en-US" sz="1400" dirty="0"/>
+          </a:p>
+        </p:txBody>
+      </p:sp>
+      <p:sp>
+        <p:nvSpPr>
+          <p:cNvPr id="8" name="Shape 6"/>
           <p:cNvSpPr/>
           <p:nvPr/>
         </p:nvSpPr>
         <p:spPr>
           <a:xfrm>
-            <a:off x="3795511" y="1700784"/>
+            <a:off x="3429510" y="1700784"/>
             <a:ext cx="10973" cy="4224528"/>
           </a:xfrm>
           <a:prstGeom prst="rect">
@@ -2617,13 +2656,13 @@
       </p:sp>
       <p:sp>
         <p:nvSpPr>
-          <p:cNvPr id="8" name="Text 6"/>
-          <p:cNvSpPr txBox="1"/>
-          <p:nvPr/>
-        </p:nvSpPr>
-        <p:spPr>
-          <a:xfrm>
-            <a:off x="10369296" y="1316736"/>
+          <p:cNvPr id="9" name="Text 7"/>
+          <p:cNvSpPr txBox="1"/>
+          <p:nvPr/>
+        </p:nvSpPr>
+        <p:spPr>
+          <a:xfrm>
+            <a:off x="9500616" y="1316736"/>
             <a:ext cx="1097280" cy="329184"/>
           </a:xfrm>
           <a:prstGeom prst="rect">
@@ -2656,13 +2695,52 @@
       </p:sp>
       <p:sp>
         <p:nvSpPr>
-          <p:cNvPr id="9" name="Shape 7"/>
+          <p:cNvPr id="10" name="Text 8"/>
+          <p:cNvSpPr txBox="1"/>
+          <p:nvPr/>
+        </p:nvSpPr>
+        <p:spPr>
+          <a:xfrm>
+            <a:off x="10597896" y="1316736"/>
+            <a:ext cx="868680" cy="329184"/>
+          </a:xfrm>
+          <a:prstGeom prst="rect">
+            <a:avLst/>
+          </a:prstGeom>
+          <a:noFill/>
+          <a:ln/>
+        </p:spPr>
+        <p:txBody>
+          <a:bodyPr wrap="square" lIns="0" tIns="0" rIns="0" bIns="0" rtlCol="0" anchor="ctr"/>
+          <a:lstStyle/>
+          <a:p>
+            <a:pPr algn="r" indent="0" marL="0">
+              <a:buNone/>
+            </a:pPr>
+            <a:r>
+              <a:rPr lang="en-US" sz="1400" b="1" dirty="0">
+                <a:solidFill>
+                  <a:srgbClr val="595959"/>
+                </a:solidFill>
+                <a:latin typeface="Inter" pitchFamily="34" charset="0"/>
+                <a:ea typeface="Inter" pitchFamily="34" charset="-122"/>
+                <a:cs typeface="Inter" pitchFamily="34" charset="-120"/>
+              </a:rPr>
+              <a:t>Opcodes</a:t>
+            </a:r>
+            <a:endParaRPr lang="en-US" sz="1400" dirty="0"/>
+          </a:p>
+        </p:txBody>
+      </p:sp>
+      <p:sp>
+        <p:nvSpPr>
+          <p:cNvPr id="11" name="Shape 9"/>
           <p:cNvSpPr/>
           <p:nvPr/>
         </p:nvSpPr>
         <p:spPr>
           <a:xfrm>
-            <a:off x="9345919" y="1700784"/>
+            <a:off x="8979918" y="1700784"/>
             <a:ext cx="10973" cy="3976026"/>
           </a:xfrm>
           <a:prstGeom prst="rect">
@@ -2676,7 +2754,7 @@
       </p:sp>
       <p:sp>
         <p:nvSpPr>
-          <p:cNvPr id="10" name="Text 8"/>
+          <p:cNvPr id="12" name="Text 10"/>
           <p:cNvSpPr txBox="1"/>
           <p:nvPr/>
         </p:nvSpPr>
@@ -2715,7 +2793,7 @@
       </p:sp>
       <p:sp>
         <p:nvSpPr>
-          <p:cNvPr id="11" name="Text 9"/>
+          <p:cNvPr id="13" name="Text 11"/>
           <p:cNvSpPr txBox="1"/>
           <p:nvPr/>
         </p:nvSpPr>
@@ -2754,14 +2832,14 @@
       </p:sp>
       <p:sp>
         <p:nvSpPr>
-          <p:cNvPr id="12" name="Shape 10"/>
+          <p:cNvPr id="14" name="Shape 12"/>
           <p:cNvSpPr/>
           <p:nvPr/>
         </p:nvSpPr>
         <p:spPr>
           <a:xfrm>
-            <a:off x="3800997" y="1756697"/>
-            <a:ext cx="963027" cy="136676"/>
+            <a:off x="3434996" y="1756697"/>
+            <a:ext cx="460348" cy="136676"/>
           </a:xfrm>
           <a:prstGeom prst="rect">
             <a:avLst/>
@@ -2774,13 +2852,13 @@
       </p:sp>
       <p:sp>
         <p:nvSpPr>
-          <p:cNvPr id="13" name="Text 11"/>
-          <p:cNvSpPr txBox="1"/>
-          <p:nvPr/>
-        </p:nvSpPr>
-        <p:spPr>
-          <a:xfrm>
-            <a:off x="4818888" y="1700784"/>
+          <p:cNvPr id="15" name="Text 13"/>
+          <p:cNvSpPr txBox="1"/>
+          <p:nvPr/>
+        </p:nvSpPr>
+        <p:spPr>
+          <a:xfrm>
+            <a:off x="3950208" y="1700784"/>
             <a:ext cx="1097280" cy="248502"/>
           </a:xfrm>
           <a:prstGeom prst="rect">
@@ -2813,7 +2891,46 @@
       </p:sp>
       <p:sp>
         <p:nvSpPr>
-          <p:cNvPr id="14" name="Text 12"/>
+          <p:cNvPr id="16" name="Text 14"/>
+          <p:cNvSpPr txBox="1"/>
+          <p:nvPr/>
+        </p:nvSpPr>
+        <p:spPr>
+          <a:xfrm>
+            <a:off x="5047488" y="1700784"/>
+            <a:ext cx="868680" cy="248502"/>
+          </a:xfrm>
+          <a:prstGeom prst="rect">
+            <a:avLst/>
+          </a:prstGeom>
+          <a:noFill/>
+          <a:ln/>
+        </p:spPr>
+        <p:txBody>
+          <a:bodyPr wrap="square" lIns="0" tIns="0" rIns="0" bIns="0" rtlCol="0" anchor="ctr"/>
+          <a:lstStyle/>
+          <a:p>
+            <a:pPr algn="r" indent="0" marL="0">
+              <a:buNone/>
+            </a:pPr>
+            <a:r>
+              <a:rPr lang="en-US" sz="1300" dirty="0">
+                <a:solidFill>
+                  <a:srgbClr val="595959"/>
+                </a:solidFill>
+                <a:latin typeface="Inter" pitchFamily="34" charset="0"/>
+                <a:ea typeface="Inter" pitchFamily="34" charset="-122"/>
+                <a:cs typeface="Inter" pitchFamily="34" charset="-120"/>
+              </a:rPr>
+              <a:t>+4,476</a:t>
+            </a:r>
+            <a:endParaRPr lang="en-US" sz="1300" dirty="0"/>
+          </a:p>
+        </p:txBody>
+      </p:sp>
+      <p:sp>
+        <p:nvSpPr>
+          <p:cNvPr id="17" name="Text 15"/>
           <p:cNvSpPr txBox="1"/>
           <p:nvPr/>
         </p:nvSpPr>
@@ -2852,7 +2969,7 @@
       </p:sp>
       <p:sp>
         <p:nvSpPr>
-          <p:cNvPr id="15" name="Text 13"/>
+          <p:cNvPr id="18" name="Text 16"/>
           <p:cNvSpPr txBox="1"/>
           <p:nvPr/>
         </p:nvSpPr>
@@ -2891,14 +3008,14 @@
       </p:sp>
       <p:sp>
         <p:nvSpPr>
-          <p:cNvPr id="16" name="Shape 14"/>
+          <p:cNvPr id="19" name="Shape 17"/>
           <p:cNvSpPr/>
           <p:nvPr/>
         </p:nvSpPr>
         <p:spPr>
           <a:xfrm>
-            <a:off x="3800997" y="2005199"/>
-            <a:ext cx="260306" cy="136676"/>
+            <a:off x="3434996" y="2005199"/>
+            <a:ext cx="124432" cy="136676"/>
           </a:xfrm>
           <a:prstGeom prst="rect">
             <a:avLst/>
@@ -2911,13 +3028,13 @@
       </p:sp>
       <p:sp>
         <p:nvSpPr>
-          <p:cNvPr id="17" name="Text 15"/>
-          <p:cNvSpPr txBox="1"/>
-          <p:nvPr/>
-        </p:nvSpPr>
-        <p:spPr>
-          <a:xfrm>
-            <a:off x="4818888" y="1949286"/>
+          <p:cNvPr id="20" name="Text 18"/>
+          <p:cNvSpPr txBox="1"/>
+          <p:nvPr/>
+        </p:nvSpPr>
+        <p:spPr>
+          <a:xfrm>
+            <a:off x="3950208" y="1949286"/>
             <a:ext cx="1097280" cy="248502"/>
           </a:xfrm>
           <a:prstGeom prst="rect">
@@ -2950,7 +3067,46 @@
       </p:sp>
       <p:sp>
         <p:nvSpPr>
-          <p:cNvPr id="18" name="Text 16"/>
+          <p:cNvPr id="21" name="Text 19"/>
+          <p:cNvSpPr txBox="1"/>
+          <p:nvPr/>
+        </p:nvSpPr>
+        <p:spPr>
+          <a:xfrm>
+            <a:off x="5047488" y="1949286"/>
+            <a:ext cx="868680" cy="248502"/>
+          </a:xfrm>
+          <a:prstGeom prst="rect">
+            <a:avLst/>
+          </a:prstGeom>
+          <a:noFill/>
+          <a:ln/>
+        </p:spPr>
+        <p:txBody>
+          <a:bodyPr wrap="square" lIns="0" tIns="0" rIns="0" bIns="0" rtlCol="0" anchor="ctr"/>
+          <a:lstStyle/>
+          <a:p>
+            <a:pPr algn="r" indent="0" marL="0">
+              <a:buNone/>
+            </a:pPr>
+            <a:r>
+              <a:rPr lang="en-US" sz="1300" dirty="0">
+                <a:solidFill>
+                  <a:srgbClr val="595959"/>
+                </a:solidFill>
+                <a:latin typeface="Inter" pitchFamily="34" charset="0"/>
+                <a:ea typeface="Inter" pitchFamily="34" charset="-122"/>
+                <a:cs typeface="Inter" pitchFamily="34" charset="-120"/>
+              </a:rPr>
+              <a:t>+456</a:t>
+            </a:r>
+            <a:endParaRPr lang="en-US" sz="1300" dirty="0"/>
+          </a:p>
+        </p:txBody>
+      </p:sp>
+      <p:sp>
+        <p:nvSpPr>
+          <p:cNvPr id="22" name="Text 20"/>
           <p:cNvSpPr txBox="1"/>
           <p:nvPr/>
         </p:nvSpPr>
@@ -2989,7 +3145,7 @@
       </p:sp>
       <p:sp>
         <p:nvSpPr>
-          <p:cNvPr id="19" name="Text 17"/>
+          <p:cNvPr id="23" name="Text 21"/>
           <p:cNvSpPr txBox="1"/>
           <p:nvPr/>
         </p:nvSpPr>
@@ -3028,14 +3184,14 @@
       </p:sp>
       <p:sp>
         <p:nvSpPr>
-          <p:cNvPr id="20" name="Shape 18"/>
+          <p:cNvPr id="24" name="Shape 22"/>
           <p:cNvSpPr/>
           <p:nvPr/>
         </p:nvSpPr>
         <p:spPr>
           <a:xfrm>
-            <a:off x="3800997" y="2253700"/>
-            <a:ext cx="92755" cy="136676"/>
+            <a:off x="3434996" y="2253700"/>
+            <a:ext cx="44339" cy="136676"/>
           </a:xfrm>
           <a:prstGeom prst="rect">
             <a:avLst/>
@@ -3048,13 +3204,13 @@
       </p:sp>
       <p:sp>
         <p:nvSpPr>
-          <p:cNvPr id="21" name="Text 19"/>
-          <p:cNvSpPr txBox="1"/>
-          <p:nvPr/>
-        </p:nvSpPr>
-        <p:spPr>
-          <a:xfrm>
-            <a:off x="4818888" y="2197787"/>
+          <p:cNvPr id="25" name="Text 23"/>
+          <p:cNvSpPr txBox="1"/>
+          <p:nvPr/>
+        </p:nvSpPr>
+        <p:spPr>
+          <a:xfrm>
+            <a:off x="3950208" y="2197787"/>
             <a:ext cx="1097280" cy="248502"/>
           </a:xfrm>
           <a:prstGeom prst="rect">
@@ -3087,7 +3243,46 @@
       </p:sp>
       <p:sp>
         <p:nvSpPr>
-          <p:cNvPr id="22" name="Text 20"/>
+          <p:cNvPr id="26" name="Text 24"/>
+          <p:cNvSpPr txBox="1"/>
+          <p:nvPr/>
+        </p:nvSpPr>
+        <p:spPr>
+          <a:xfrm>
+            <a:off x="5047488" y="2197787"/>
+            <a:ext cx="868680" cy="248502"/>
+          </a:xfrm>
+          <a:prstGeom prst="rect">
+            <a:avLst/>
+          </a:prstGeom>
+          <a:noFill/>
+          <a:ln/>
+        </p:spPr>
+        <p:txBody>
+          <a:bodyPr wrap="square" lIns="0" tIns="0" rIns="0" bIns="0" rtlCol="0" anchor="ctr"/>
+          <a:lstStyle/>
+          <a:p>
+            <a:pPr algn="r" indent="0" marL="0">
+              <a:buNone/>
+            </a:pPr>
+            <a:r>
+              <a:rPr lang="en-US" sz="1300" dirty="0">
+                <a:solidFill>
+                  <a:srgbClr val="595959"/>
+                </a:solidFill>
+                <a:latin typeface="Inter" pitchFamily="34" charset="0"/>
+                <a:ea typeface="Inter" pitchFamily="34" charset="-122"/>
+                <a:cs typeface="Inter" pitchFamily="34" charset="-120"/>
+              </a:rPr>
+              <a:t>+324</a:t>
+            </a:r>
+            <a:endParaRPr lang="en-US" sz="1300" dirty="0"/>
+          </a:p>
+        </p:txBody>
+      </p:sp>
+      <p:sp>
+        <p:nvSpPr>
+          <p:cNvPr id="27" name="Text 25"/>
           <p:cNvSpPr txBox="1"/>
           <p:nvPr/>
         </p:nvSpPr>
@@ -3126,7 +3321,7 @@
       </p:sp>
       <p:sp>
         <p:nvSpPr>
-          <p:cNvPr id="23" name="Text 21"/>
+          <p:cNvPr id="28" name="Text 26"/>
           <p:cNvSpPr txBox="1"/>
           <p:nvPr/>
         </p:nvSpPr>
@@ -3165,14 +3360,14 @@
       </p:sp>
       <p:sp>
         <p:nvSpPr>
-          <p:cNvPr id="24" name="Shape 22"/>
+          <p:cNvPr id="29" name="Shape 27"/>
           <p:cNvSpPr/>
           <p:nvPr/>
         </p:nvSpPr>
         <p:spPr>
           <a:xfrm>
-            <a:off x="3800997" y="2502202"/>
-            <a:ext cx="77707" cy="136676"/>
+            <a:off x="3434996" y="2502202"/>
+            <a:ext cx="37145" cy="136676"/>
           </a:xfrm>
           <a:prstGeom prst="rect">
             <a:avLst/>
@@ -3185,13 +3380,13 @@
       </p:sp>
       <p:sp>
         <p:nvSpPr>
-          <p:cNvPr id="25" name="Text 23"/>
-          <p:cNvSpPr txBox="1"/>
-          <p:nvPr/>
-        </p:nvSpPr>
-        <p:spPr>
-          <a:xfrm>
-            <a:off x="4818888" y="2446289"/>
+          <p:cNvPr id="30" name="Text 28"/>
+          <p:cNvSpPr txBox="1"/>
+          <p:nvPr/>
+        </p:nvSpPr>
+        <p:spPr>
+          <a:xfrm>
+            <a:off x="3950208" y="2446289"/>
             <a:ext cx="1097280" cy="248502"/>
           </a:xfrm>
           <a:prstGeom prst="rect">
@@ -3224,7 +3419,46 @@
       </p:sp>
       <p:sp>
         <p:nvSpPr>
-          <p:cNvPr id="26" name="Text 24"/>
+          <p:cNvPr id="31" name="Text 29"/>
+          <p:cNvSpPr txBox="1"/>
+          <p:nvPr/>
+        </p:nvSpPr>
+        <p:spPr>
+          <a:xfrm>
+            <a:off x="5047488" y="2446289"/>
+            <a:ext cx="868680" cy="248502"/>
+          </a:xfrm>
+          <a:prstGeom prst="rect">
+            <a:avLst/>
+          </a:prstGeom>
+          <a:noFill/>
+          <a:ln/>
+        </p:spPr>
+        <p:txBody>
+          <a:bodyPr wrap="square" lIns="0" tIns="0" rIns="0" bIns="0" rtlCol="0" anchor="ctr"/>
+          <a:lstStyle/>
+          <a:p>
+            <a:pPr algn="r" indent="0" marL="0">
+              <a:buNone/>
+            </a:pPr>
+            <a:r>
+              <a:rPr lang="en-US" sz="1300" dirty="0">
+                <a:solidFill>
+                  <a:srgbClr val="595959"/>
+                </a:solidFill>
+                <a:latin typeface="Inter" pitchFamily="34" charset="0"/>
+                <a:ea typeface="Inter" pitchFamily="34" charset="-122"/>
+                <a:cs typeface="Inter" pitchFamily="34" charset="-120"/>
+              </a:rPr>
+              <a:t>+70</a:t>
+            </a:r>
+            <a:endParaRPr lang="en-US" sz="1300" dirty="0"/>
+          </a:p>
+        </p:txBody>
+      </p:sp>
+      <p:sp>
+        <p:nvSpPr>
+          <p:cNvPr id="32" name="Text 30"/>
           <p:cNvSpPr txBox="1"/>
           <p:nvPr/>
         </p:nvSpPr>
@@ -3263,7 +3497,7 @@
       </p:sp>
       <p:sp>
         <p:nvSpPr>
-          <p:cNvPr id="27" name="Text 25"/>
+          <p:cNvPr id="33" name="Text 31"/>
           <p:cNvSpPr txBox="1"/>
           <p:nvPr/>
         </p:nvSpPr>
@@ -3302,14 +3536,14 @@
       </p:sp>
       <p:sp>
         <p:nvSpPr>
-          <p:cNvPr id="28" name="Shape 26"/>
+          <p:cNvPr id="34" name="Shape 32"/>
           <p:cNvSpPr/>
           <p:nvPr/>
         </p:nvSpPr>
         <p:spPr>
           <a:xfrm>
-            <a:off x="3800997" y="2750703"/>
-            <a:ext cx="71427" cy="136676"/>
+            <a:off x="3434996" y="2750703"/>
+            <a:ext cx="34144" cy="136676"/>
           </a:xfrm>
           <a:prstGeom prst="rect">
             <a:avLst/>
@@ -3322,13 +3556,13 @@
       </p:sp>
       <p:sp>
         <p:nvSpPr>
-          <p:cNvPr id="29" name="Text 27"/>
-          <p:cNvSpPr txBox="1"/>
-          <p:nvPr/>
-        </p:nvSpPr>
-        <p:spPr>
-          <a:xfrm>
-            <a:off x="4818888" y="2694791"/>
+          <p:cNvPr id="35" name="Text 33"/>
+          <p:cNvSpPr txBox="1"/>
+          <p:nvPr/>
+        </p:nvSpPr>
+        <p:spPr>
+          <a:xfrm>
+            <a:off x="3950208" y="2694791"/>
             <a:ext cx="1097280" cy="248502"/>
           </a:xfrm>
           <a:prstGeom prst="rect">
@@ -3361,7 +3595,46 @@
       </p:sp>
       <p:sp>
         <p:nvSpPr>
-          <p:cNvPr id="30" name="Text 28"/>
+          <p:cNvPr id="36" name="Text 34"/>
+          <p:cNvSpPr txBox="1"/>
+          <p:nvPr/>
+        </p:nvSpPr>
+        <p:spPr>
+          <a:xfrm>
+            <a:off x="5047488" y="2694791"/>
+            <a:ext cx="868680" cy="248502"/>
+          </a:xfrm>
+          <a:prstGeom prst="rect">
+            <a:avLst/>
+          </a:prstGeom>
+          <a:noFill/>
+          <a:ln/>
+        </p:spPr>
+        <p:txBody>
+          <a:bodyPr wrap="square" lIns="0" tIns="0" rIns="0" bIns="0" rtlCol="0" anchor="ctr"/>
+          <a:lstStyle/>
+          <a:p>
+            <a:pPr algn="r" indent="0" marL="0">
+              <a:buNone/>
+            </a:pPr>
+            <a:r>
+              <a:rPr lang="en-US" sz="1300" dirty="0">
+                <a:solidFill>
+                  <a:srgbClr val="595959"/>
+                </a:solidFill>
+                <a:latin typeface="Inter" pitchFamily="34" charset="0"/>
+                <a:ea typeface="Inter" pitchFamily="34" charset="-122"/>
+                <a:cs typeface="Inter" pitchFamily="34" charset="-120"/>
+              </a:rPr>
+              <a:t>+24</a:t>
+            </a:r>
+            <a:endParaRPr lang="en-US" sz="1300" dirty="0"/>
+          </a:p>
+        </p:txBody>
+      </p:sp>
+      <p:sp>
+        <p:nvSpPr>
+          <p:cNvPr id="37" name="Text 35"/>
           <p:cNvSpPr txBox="1"/>
           <p:nvPr/>
         </p:nvSpPr>
@@ -3400,7 +3673,7 @@
       </p:sp>
       <p:sp>
         <p:nvSpPr>
-          <p:cNvPr id="31" name="Text 29"/>
+          <p:cNvPr id="38" name="Text 36"/>
           <p:cNvSpPr txBox="1"/>
           <p:nvPr/>
         </p:nvSpPr>
@@ -3439,14 +3712,14 @@
       </p:sp>
       <p:sp>
         <p:nvSpPr>
-          <p:cNvPr id="32" name="Shape 30"/>
+          <p:cNvPr id="39" name="Shape 37"/>
           <p:cNvSpPr/>
           <p:nvPr/>
         </p:nvSpPr>
         <p:spPr>
           <a:xfrm>
-            <a:off x="3800997" y="2999205"/>
-            <a:ext cx="57698" cy="136676"/>
+            <a:off x="3434996" y="2999205"/>
+            <a:ext cx="27581" cy="136676"/>
           </a:xfrm>
           <a:prstGeom prst="rect">
             <a:avLst/>
@@ -3459,13 +3732,13 @@
       </p:sp>
       <p:sp>
         <p:nvSpPr>
-          <p:cNvPr id="33" name="Text 31"/>
-          <p:cNvSpPr txBox="1"/>
-          <p:nvPr/>
-        </p:nvSpPr>
-        <p:spPr>
-          <a:xfrm>
-            <a:off x="4818888" y="2943292"/>
+          <p:cNvPr id="40" name="Text 38"/>
+          <p:cNvSpPr txBox="1"/>
+          <p:nvPr/>
+        </p:nvSpPr>
+        <p:spPr>
+          <a:xfrm>
+            <a:off x="3950208" y="2943292"/>
             <a:ext cx="1097280" cy="248502"/>
           </a:xfrm>
           <a:prstGeom prst="rect">
@@ -3498,7 +3771,46 @@
       </p:sp>
       <p:sp>
         <p:nvSpPr>
-          <p:cNvPr id="34" name="Text 32"/>
+          <p:cNvPr id="41" name="Text 39"/>
+          <p:cNvSpPr txBox="1"/>
+          <p:nvPr/>
+        </p:nvSpPr>
+        <p:spPr>
+          <a:xfrm>
+            <a:off x="5047488" y="2943292"/>
+            <a:ext cx="868680" cy="248502"/>
+          </a:xfrm>
+          <a:prstGeom prst="rect">
+            <a:avLst/>
+          </a:prstGeom>
+          <a:noFill/>
+          <a:ln/>
+        </p:spPr>
+        <p:txBody>
+          <a:bodyPr wrap="square" lIns="0" tIns="0" rIns="0" bIns="0" rtlCol="0" anchor="ctr"/>
+          <a:lstStyle/>
+          <a:p>
+            <a:pPr algn="r" indent="0" marL="0">
+              <a:buNone/>
+            </a:pPr>
+            <a:r>
+              <a:rPr lang="en-US" sz="1300" dirty="0">
+                <a:solidFill>
+                  <a:srgbClr val="595959"/>
+                </a:solidFill>
+                <a:latin typeface="Inter" pitchFamily="34" charset="0"/>
+                <a:ea typeface="Inter" pitchFamily="34" charset="-122"/>
+                <a:cs typeface="Inter" pitchFamily="34" charset="-120"/>
+              </a:rPr>
+              <a:t>+228</a:t>
+            </a:r>
+            <a:endParaRPr lang="en-US" sz="1300" dirty="0"/>
+          </a:p>
+        </p:txBody>
+      </p:sp>
+      <p:sp>
+        <p:nvSpPr>
+          <p:cNvPr id="42" name="Text 40"/>
           <p:cNvSpPr txBox="1"/>
           <p:nvPr/>
         </p:nvSpPr>
@@ -3537,7 +3849,7 @@
       </p:sp>
       <p:sp>
         <p:nvSpPr>
-          <p:cNvPr id="35" name="Text 33"/>
+          <p:cNvPr id="43" name="Text 41"/>
           <p:cNvSpPr txBox="1"/>
           <p:nvPr/>
         </p:nvSpPr>
@@ -3576,14 +3888,14 @@
       </p:sp>
       <p:sp>
         <p:nvSpPr>
-          <p:cNvPr id="36" name="Shape 34"/>
+          <p:cNvPr id="44" name="Shape 42"/>
           <p:cNvSpPr/>
           <p:nvPr/>
         </p:nvSpPr>
         <p:spPr>
           <a:xfrm>
-            <a:off x="3800997" y="3247707"/>
-            <a:ext cx="40337" cy="136676"/>
+            <a:off x="3434996" y="3247707"/>
+            <a:ext cx="19282" cy="136676"/>
           </a:xfrm>
           <a:prstGeom prst="rect">
             <a:avLst/>
@@ -3596,13 +3908,13 @@
       </p:sp>
       <p:sp>
         <p:nvSpPr>
-          <p:cNvPr id="37" name="Text 35"/>
-          <p:cNvSpPr txBox="1"/>
-          <p:nvPr/>
-        </p:nvSpPr>
-        <p:spPr>
-          <a:xfrm>
-            <a:off x="4818888" y="3191794"/>
+          <p:cNvPr id="45" name="Text 43"/>
+          <p:cNvSpPr txBox="1"/>
+          <p:nvPr/>
+        </p:nvSpPr>
+        <p:spPr>
+          <a:xfrm>
+            <a:off x="3950208" y="3191794"/>
             <a:ext cx="1097280" cy="248502"/>
           </a:xfrm>
           <a:prstGeom prst="rect">
@@ -3635,7 +3947,46 @@
       </p:sp>
       <p:sp>
         <p:nvSpPr>
-          <p:cNvPr id="38" name="Text 36"/>
+          <p:cNvPr id="46" name="Text 44"/>
+          <p:cNvSpPr txBox="1"/>
+          <p:nvPr/>
+        </p:nvSpPr>
+        <p:spPr>
+          <a:xfrm>
+            <a:off x="5047488" y="3191794"/>
+            <a:ext cx="868680" cy="248502"/>
+          </a:xfrm>
+          <a:prstGeom prst="rect">
+            <a:avLst/>
+          </a:prstGeom>
+          <a:noFill/>
+          <a:ln/>
+        </p:spPr>
+        <p:txBody>
+          <a:bodyPr wrap="square" lIns="0" tIns="0" rIns="0" bIns="0" rtlCol="0" anchor="ctr"/>
+          <a:lstStyle/>
+          <a:p>
+            <a:pPr algn="r" indent="0" marL="0">
+              <a:buNone/>
+            </a:pPr>
+            <a:r>
+              <a:rPr lang="en-US" sz="1300" dirty="0">
+                <a:solidFill>
+                  <a:srgbClr val="595959"/>
+                </a:solidFill>
+                <a:latin typeface="Inter" pitchFamily="34" charset="0"/>
+                <a:ea typeface="Inter" pitchFamily="34" charset="-122"/>
+                <a:cs typeface="Inter" pitchFamily="34" charset="-120"/>
+              </a:rPr>
+              <a:t>+97</a:t>
+            </a:r>
+            <a:endParaRPr lang="en-US" sz="1300" dirty="0"/>
+          </a:p>
+        </p:txBody>
+      </p:sp>
+      <p:sp>
+        <p:nvSpPr>
+          <p:cNvPr id="47" name="Text 45"/>
           <p:cNvSpPr txBox="1"/>
           <p:nvPr/>
         </p:nvSpPr>
@@ -3674,7 +4025,7 @@
       </p:sp>
       <p:sp>
         <p:nvSpPr>
-          <p:cNvPr id="39" name="Text 37"/>
+          <p:cNvPr id="48" name="Text 46"/>
           <p:cNvSpPr txBox="1"/>
           <p:nvPr/>
         </p:nvSpPr>
@@ -3713,14 +4064,14 @@
       </p:sp>
       <p:sp>
         <p:nvSpPr>
-          <p:cNvPr id="40" name="Shape 38"/>
+          <p:cNvPr id="49" name="Shape 47"/>
           <p:cNvSpPr/>
           <p:nvPr/>
         </p:nvSpPr>
         <p:spPr>
           <a:xfrm>
-            <a:off x="3762731" y="3496208"/>
-            <a:ext cx="38266" cy="136676"/>
+            <a:off x="3416704" y="3496208"/>
+            <a:ext cx="18292" cy="136676"/>
           </a:xfrm>
           <a:prstGeom prst="rect">
             <a:avLst/>
@@ -3733,13 +4084,13 @@
       </p:sp>
       <p:sp>
         <p:nvSpPr>
-          <p:cNvPr id="41" name="Text 39"/>
-          <p:cNvSpPr txBox="1"/>
-          <p:nvPr/>
-        </p:nvSpPr>
-        <p:spPr>
-          <a:xfrm>
-            <a:off x="4818888" y="3440296"/>
+          <p:cNvPr id="50" name="Text 48"/>
+          <p:cNvSpPr txBox="1"/>
+          <p:nvPr/>
+        </p:nvSpPr>
+        <p:spPr>
+          <a:xfrm>
+            <a:off x="3950208" y="3440296"/>
             <a:ext cx="1097280" cy="248502"/>
           </a:xfrm>
           <a:prstGeom prst="rect">
@@ -3772,7 +4123,46 @@
       </p:sp>
       <p:sp>
         <p:nvSpPr>
-          <p:cNvPr id="42" name="Text 40"/>
+          <p:cNvPr id="51" name="Text 49"/>
+          <p:cNvSpPr txBox="1"/>
+          <p:nvPr/>
+        </p:nvSpPr>
+        <p:spPr>
+          <a:xfrm>
+            <a:off x="5047488" y="3440296"/>
+            <a:ext cx="868680" cy="248502"/>
+          </a:xfrm>
+          <a:prstGeom prst="rect">
+            <a:avLst/>
+          </a:prstGeom>
+          <a:noFill/>
+          <a:ln/>
+        </p:spPr>
+        <p:txBody>
+          <a:bodyPr wrap="square" lIns="0" tIns="0" rIns="0" bIns="0" rtlCol="0" anchor="ctr"/>
+          <a:lstStyle/>
+          <a:p>
+            <a:pPr algn="r" indent="0" marL="0">
+              <a:buNone/>
+            </a:pPr>
+            <a:r>
+              <a:rPr lang="en-US" sz="1300" dirty="0">
+                <a:solidFill>
+                  <a:srgbClr val="595959"/>
+                </a:solidFill>
+                <a:latin typeface="Inter" pitchFamily="34" charset="0"/>
+                <a:ea typeface="Inter" pitchFamily="34" charset="-122"/>
+                <a:cs typeface="Inter" pitchFamily="34" charset="-120"/>
+              </a:rPr>
+              <a:t>−661</a:t>
+            </a:r>
+            <a:endParaRPr lang="en-US" sz="1300" dirty="0"/>
+          </a:p>
+        </p:txBody>
+      </p:sp>
+      <p:sp>
+        <p:nvSpPr>
+          <p:cNvPr id="52" name="Text 50"/>
           <p:cNvSpPr txBox="1"/>
           <p:nvPr/>
         </p:nvSpPr>
@@ -3811,7 +4201,7 @@
       </p:sp>
       <p:sp>
         <p:nvSpPr>
-          <p:cNvPr id="43" name="Text 41"/>
+          <p:cNvPr id="53" name="Text 51"/>
           <p:cNvSpPr txBox="1"/>
           <p:nvPr/>
         </p:nvSpPr>
@@ -3850,14 +4240,14 @@
       </p:sp>
       <p:sp>
         <p:nvSpPr>
-          <p:cNvPr id="44" name="Shape 42"/>
+          <p:cNvPr id="54" name="Shape 52"/>
           <p:cNvSpPr/>
           <p:nvPr/>
         </p:nvSpPr>
         <p:spPr>
           <a:xfrm>
-            <a:off x="3752270" y="3744710"/>
-            <a:ext cx="48727" cy="136676"/>
+            <a:off x="3411703" y="3744710"/>
+            <a:ext cx="23293" cy="136676"/>
           </a:xfrm>
           <a:prstGeom prst="rect">
             <a:avLst/>
@@ -3870,13 +4260,13 @@
       </p:sp>
       <p:sp>
         <p:nvSpPr>
-          <p:cNvPr id="45" name="Text 43"/>
-          <p:cNvSpPr txBox="1"/>
-          <p:nvPr/>
-        </p:nvSpPr>
-        <p:spPr>
-          <a:xfrm>
-            <a:off x="4818888" y="3688797"/>
+          <p:cNvPr id="55" name="Text 53"/>
+          <p:cNvSpPr txBox="1"/>
+          <p:nvPr/>
+        </p:nvSpPr>
+        <p:spPr>
+          <a:xfrm>
+            <a:off x="3950208" y="3688797"/>
             <a:ext cx="1097280" cy="248502"/>
           </a:xfrm>
           <a:prstGeom prst="rect">
@@ -3909,7 +4299,46 @@
       </p:sp>
       <p:sp>
         <p:nvSpPr>
-          <p:cNvPr id="46" name="Text 44"/>
+          <p:cNvPr id="56" name="Text 54"/>
+          <p:cNvSpPr txBox="1"/>
+          <p:nvPr/>
+        </p:nvSpPr>
+        <p:spPr>
+          <a:xfrm>
+            <a:off x="5047488" y="3688797"/>
+            <a:ext cx="868680" cy="248502"/>
+          </a:xfrm>
+          <a:prstGeom prst="rect">
+            <a:avLst/>
+          </a:prstGeom>
+          <a:noFill/>
+          <a:ln/>
+        </p:spPr>
+        <p:txBody>
+          <a:bodyPr wrap="square" lIns="0" tIns="0" rIns="0" bIns="0" rtlCol="0" anchor="ctr"/>
+          <a:lstStyle/>
+          <a:p>
+            <a:pPr algn="r" indent="0" marL="0">
+              <a:buNone/>
+            </a:pPr>
+            <a:r>
+              <a:rPr lang="en-US" sz="1300" dirty="0">
+                <a:solidFill>
+                  <a:srgbClr val="595959"/>
+                </a:solidFill>
+                <a:latin typeface="Inter" pitchFamily="34" charset="0"/>
+                <a:ea typeface="Inter" pitchFamily="34" charset="-122"/>
+                <a:cs typeface="Inter" pitchFamily="34" charset="-120"/>
+              </a:rPr>
+              <a:t>−223</a:t>
+            </a:r>
+            <a:endParaRPr lang="en-US" sz="1300" dirty="0"/>
+          </a:p>
+        </p:txBody>
+      </p:sp>
+      <p:sp>
+        <p:nvSpPr>
+          <p:cNvPr id="57" name="Text 55"/>
           <p:cNvSpPr txBox="1"/>
           <p:nvPr/>
         </p:nvSpPr>
@@ -3948,7 +4377,7 @@
       </p:sp>
       <p:sp>
         <p:nvSpPr>
-          <p:cNvPr id="47" name="Text 45"/>
+          <p:cNvPr id="58" name="Text 56"/>
           <p:cNvSpPr txBox="1"/>
           <p:nvPr/>
         </p:nvSpPr>
@@ -3987,14 +4416,14 @@
       </p:sp>
       <p:sp>
         <p:nvSpPr>
-          <p:cNvPr id="48" name="Shape 46"/>
+          <p:cNvPr id="59" name="Shape 57"/>
           <p:cNvSpPr/>
           <p:nvPr/>
         </p:nvSpPr>
         <p:spPr>
           <a:xfrm>
-            <a:off x="3751591" y="3993212"/>
-            <a:ext cx="49407" cy="136676"/>
+            <a:off x="3411379" y="3993212"/>
+            <a:ext cx="23618" cy="136676"/>
           </a:xfrm>
           <a:prstGeom prst="rect">
             <a:avLst/>
@@ -4007,13 +4436,13 @@
       </p:sp>
       <p:sp>
         <p:nvSpPr>
-          <p:cNvPr id="49" name="Text 47"/>
-          <p:cNvSpPr txBox="1"/>
-          <p:nvPr/>
-        </p:nvSpPr>
-        <p:spPr>
-          <a:xfrm>
-            <a:off x="4818888" y="3937299"/>
+          <p:cNvPr id="60" name="Text 58"/>
+          <p:cNvSpPr txBox="1"/>
+          <p:nvPr/>
+        </p:nvSpPr>
+        <p:spPr>
+          <a:xfrm>
+            <a:off x="3950208" y="3937299"/>
             <a:ext cx="1097280" cy="248502"/>
           </a:xfrm>
           <a:prstGeom prst="rect">
@@ -4046,7 +4475,46 @@
       </p:sp>
       <p:sp>
         <p:nvSpPr>
-          <p:cNvPr id="50" name="Text 48"/>
+          <p:cNvPr id="61" name="Text 59"/>
+          <p:cNvSpPr txBox="1"/>
+          <p:nvPr/>
+        </p:nvSpPr>
+        <p:spPr>
+          <a:xfrm>
+            <a:off x="5047488" y="3937299"/>
+            <a:ext cx="868680" cy="248502"/>
+          </a:xfrm>
+          <a:prstGeom prst="rect">
+            <a:avLst/>
+          </a:prstGeom>
+          <a:noFill/>
+          <a:ln/>
+        </p:spPr>
+        <p:txBody>
+          <a:bodyPr wrap="square" lIns="0" tIns="0" rIns="0" bIns="0" rtlCol="0" anchor="ctr"/>
+          <a:lstStyle/>
+          <a:p>
+            <a:pPr algn="r" indent="0" marL="0">
+              <a:buNone/>
+            </a:pPr>
+            <a:r>
+              <a:rPr lang="en-US" sz="1300" dirty="0">
+                <a:solidFill>
+                  <a:srgbClr val="595959"/>
+                </a:solidFill>
+                <a:latin typeface="Inter" pitchFamily="34" charset="0"/>
+                <a:ea typeface="Inter" pitchFamily="34" charset="-122"/>
+                <a:cs typeface="Inter" pitchFamily="34" charset="-120"/>
+              </a:rPr>
+              <a:t>−340</a:t>
+            </a:r>
+            <a:endParaRPr lang="en-US" sz="1300" dirty="0"/>
+          </a:p>
+        </p:txBody>
+      </p:sp>
+      <p:sp>
+        <p:nvSpPr>
+          <p:cNvPr id="62" name="Text 60"/>
           <p:cNvSpPr txBox="1"/>
           <p:nvPr/>
         </p:nvSpPr>
@@ -4085,7 +4553,7 @@
       </p:sp>
       <p:sp>
         <p:nvSpPr>
-          <p:cNvPr id="51" name="Text 49"/>
+          <p:cNvPr id="63" name="Text 61"/>
           <p:cNvSpPr txBox="1"/>
           <p:nvPr/>
         </p:nvSpPr>
@@ -4124,14 +4592,14 @@
       </p:sp>
       <p:sp>
         <p:nvSpPr>
-          <p:cNvPr id="52" name="Shape 50"/>
+          <p:cNvPr id="64" name="Shape 62"/>
           <p:cNvSpPr/>
           <p:nvPr/>
         </p:nvSpPr>
         <p:spPr>
           <a:xfrm>
-            <a:off x="3745550" y="4241713"/>
-            <a:ext cx="55448" cy="136676"/>
+            <a:off x="3408491" y="4241713"/>
+            <a:ext cx="26505" cy="136676"/>
           </a:xfrm>
           <a:prstGeom prst="rect">
             <a:avLst/>
@@ -4144,13 +4612,13 @@
       </p:sp>
       <p:sp>
         <p:nvSpPr>
-          <p:cNvPr id="53" name="Text 51"/>
-          <p:cNvSpPr txBox="1"/>
-          <p:nvPr/>
-        </p:nvSpPr>
-        <p:spPr>
-          <a:xfrm>
-            <a:off x="4818888" y="4185800"/>
+          <p:cNvPr id="65" name="Text 63"/>
+          <p:cNvSpPr txBox="1"/>
+          <p:nvPr/>
+        </p:nvSpPr>
+        <p:spPr>
+          <a:xfrm>
+            <a:off x="3950208" y="4185800"/>
             <a:ext cx="1097280" cy="248502"/>
           </a:xfrm>
           <a:prstGeom prst="rect">
@@ -4183,7 +4651,46 @@
       </p:sp>
       <p:sp>
         <p:nvSpPr>
-          <p:cNvPr id="54" name="Text 52"/>
+          <p:cNvPr id="66" name="Text 64"/>
+          <p:cNvSpPr txBox="1"/>
+          <p:nvPr/>
+        </p:nvSpPr>
+        <p:spPr>
+          <a:xfrm>
+            <a:off x="5047488" y="4185800"/>
+            <a:ext cx="868680" cy="248502"/>
+          </a:xfrm>
+          <a:prstGeom prst="rect">
+            <a:avLst/>
+          </a:prstGeom>
+          <a:noFill/>
+          <a:ln/>
+        </p:spPr>
+        <p:txBody>
+          <a:bodyPr wrap="square" lIns="0" tIns="0" rIns="0" bIns="0" rtlCol="0" anchor="ctr"/>
+          <a:lstStyle/>
+          <a:p>
+            <a:pPr algn="r" indent="0" marL="0">
+              <a:buNone/>
+            </a:pPr>
+            <a:r>
+              <a:rPr lang="en-US" sz="1300" dirty="0">
+                <a:solidFill>
+                  <a:srgbClr val="595959"/>
+                </a:solidFill>
+                <a:latin typeface="Inter" pitchFamily="34" charset="0"/>
+                <a:ea typeface="Inter" pitchFamily="34" charset="-122"/>
+                <a:cs typeface="Inter" pitchFamily="34" charset="-120"/>
+              </a:rPr>
+              <a:t>−83</a:t>
+            </a:r>
+            <a:endParaRPr lang="en-US" sz="1300" dirty="0"/>
+          </a:p>
+        </p:txBody>
+      </p:sp>
+      <p:sp>
+        <p:nvSpPr>
+          <p:cNvPr id="67" name="Text 65"/>
           <p:cNvSpPr txBox="1"/>
           <p:nvPr/>
         </p:nvSpPr>
@@ -4222,7 +4729,7 @@
       </p:sp>
       <p:sp>
         <p:nvSpPr>
-          <p:cNvPr id="55" name="Text 53"/>
+          <p:cNvPr id="68" name="Text 66"/>
           <p:cNvSpPr txBox="1"/>
           <p:nvPr/>
         </p:nvSpPr>
@@ -4261,14 +4768,14 @@
       </p:sp>
       <p:sp>
         <p:nvSpPr>
-          <p:cNvPr id="56" name="Shape 54"/>
+          <p:cNvPr id="69" name="Shape 67"/>
           <p:cNvSpPr/>
           <p:nvPr/>
         </p:nvSpPr>
         <p:spPr>
           <a:xfrm>
-            <a:off x="3729945" y="4490215"/>
-            <a:ext cx="71053" cy="136676"/>
+            <a:off x="3401031" y="4490215"/>
+            <a:ext cx="33965" cy="136676"/>
           </a:xfrm>
           <a:prstGeom prst="rect">
             <a:avLst/>
@@ -4281,13 +4788,13 @@
       </p:sp>
       <p:sp>
         <p:nvSpPr>
-          <p:cNvPr id="57" name="Text 55"/>
-          <p:cNvSpPr txBox="1"/>
-          <p:nvPr/>
-        </p:nvSpPr>
-        <p:spPr>
-          <a:xfrm>
-            <a:off x="4818888" y="4434302"/>
+          <p:cNvPr id="70" name="Text 68"/>
+          <p:cNvSpPr txBox="1"/>
+          <p:nvPr/>
+        </p:nvSpPr>
+        <p:spPr>
+          <a:xfrm>
+            <a:off x="3950208" y="4434302"/>
             <a:ext cx="1097280" cy="248502"/>
           </a:xfrm>
           <a:prstGeom prst="rect">
@@ -4320,7 +4827,46 @@
       </p:sp>
       <p:sp>
         <p:nvSpPr>
-          <p:cNvPr id="58" name="Text 56"/>
+          <p:cNvPr id="71" name="Text 69"/>
+          <p:cNvSpPr txBox="1"/>
+          <p:nvPr/>
+        </p:nvSpPr>
+        <p:spPr>
+          <a:xfrm>
+            <a:off x="5047488" y="4434302"/>
+            <a:ext cx="868680" cy="248502"/>
+          </a:xfrm>
+          <a:prstGeom prst="rect">
+            <a:avLst/>
+          </a:prstGeom>
+          <a:noFill/>
+          <a:ln/>
+        </p:spPr>
+        <p:txBody>
+          <a:bodyPr wrap="square" lIns="0" tIns="0" rIns="0" bIns="0" rtlCol="0" anchor="ctr"/>
+          <a:lstStyle/>
+          <a:p>
+            <a:pPr algn="r" indent="0" marL="0">
+              <a:buNone/>
+            </a:pPr>
+            <a:r>
+              <a:rPr lang="en-US" sz="1300" dirty="0">
+                <a:solidFill>
+                  <a:srgbClr val="595959"/>
+                </a:solidFill>
+                <a:latin typeface="Inter" pitchFamily="34" charset="0"/>
+                <a:ea typeface="Inter" pitchFamily="34" charset="-122"/>
+                <a:cs typeface="Inter" pitchFamily="34" charset="-120"/>
+              </a:rPr>
+              <a:t>−452</a:t>
+            </a:r>
+            <a:endParaRPr lang="en-US" sz="1300" dirty="0"/>
+          </a:p>
+        </p:txBody>
+      </p:sp>
+      <p:sp>
+        <p:nvSpPr>
+          <p:cNvPr id="72" name="Text 70"/>
           <p:cNvSpPr txBox="1"/>
           <p:nvPr/>
         </p:nvSpPr>
@@ -4359,7 +4905,7 @@
       </p:sp>
       <p:sp>
         <p:nvSpPr>
-          <p:cNvPr id="59" name="Text 57"/>
+          <p:cNvPr id="73" name="Text 71"/>
           <p:cNvSpPr txBox="1"/>
           <p:nvPr/>
         </p:nvSpPr>
@@ -4398,14 +4944,14 @@
       </p:sp>
       <p:sp>
         <p:nvSpPr>
-          <p:cNvPr id="60" name="Shape 58"/>
+          <p:cNvPr id="74" name="Shape 72"/>
           <p:cNvSpPr/>
           <p:nvPr/>
         </p:nvSpPr>
         <p:spPr>
           <a:xfrm>
-            <a:off x="3718481" y="4738717"/>
-            <a:ext cx="82517" cy="136676"/>
+            <a:off x="3395551" y="4738717"/>
+            <a:ext cx="39445" cy="136676"/>
           </a:xfrm>
           <a:prstGeom prst="rect">
             <a:avLst/>
@@ -4418,13 +4964,13 @@
       </p:sp>
       <p:sp>
         <p:nvSpPr>
-          <p:cNvPr id="61" name="Text 59"/>
-          <p:cNvSpPr txBox="1"/>
-          <p:nvPr/>
-        </p:nvSpPr>
-        <p:spPr>
-          <a:xfrm>
-            <a:off x="4818888" y="4682804"/>
+          <p:cNvPr id="75" name="Text 73"/>
+          <p:cNvSpPr txBox="1"/>
+          <p:nvPr/>
+        </p:nvSpPr>
+        <p:spPr>
+          <a:xfrm>
+            <a:off x="3950208" y="4682804"/>
             <a:ext cx="1097280" cy="248502"/>
           </a:xfrm>
           <a:prstGeom prst="rect">
@@ -4457,7 +5003,46 @@
       </p:sp>
       <p:sp>
         <p:nvSpPr>
-          <p:cNvPr id="62" name="Text 60"/>
+          <p:cNvPr id="76" name="Text 74"/>
+          <p:cNvSpPr txBox="1"/>
+          <p:nvPr/>
+        </p:nvSpPr>
+        <p:spPr>
+          <a:xfrm>
+            <a:off x="5047488" y="4682804"/>
+            <a:ext cx="868680" cy="248502"/>
+          </a:xfrm>
+          <a:prstGeom prst="rect">
+            <a:avLst/>
+          </a:prstGeom>
+          <a:noFill/>
+          <a:ln/>
+        </p:spPr>
+        <p:txBody>
+          <a:bodyPr wrap="square" lIns="0" tIns="0" rIns="0" bIns="0" rtlCol="0" anchor="ctr"/>
+          <a:lstStyle/>
+          <a:p>
+            <a:pPr algn="r" indent="0" marL="0">
+              <a:buNone/>
+            </a:pPr>
+            <a:r>
+              <a:rPr lang="en-US" sz="1300" dirty="0">
+                <a:solidFill>
+                  <a:srgbClr val="595959"/>
+                </a:solidFill>
+                <a:latin typeface="Inter" pitchFamily="34" charset="0"/>
+                <a:ea typeface="Inter" pitchFamily="34" charset="-122"/>
+                <a:cs typeface="Inter" pitchFamily="34" charset="-120"/>
+              </a:rPr>
+              <a:t>−569</a:t>
+            </a:r>
+            <a:endParaRPr lang="en-US" sz="1300" dirty="0"/>
+          </a:p>
+        </p:txBody>
+      </p:sp>
+      <p:sp>
+        <p:nvSpPr>
+          <p:cNvPr id="77" name="Text 75"/>
           <p:cNvSpPr txBox="1"/>
           <p:nvPr/>
         </p:nvSpPr>
@@ -4496,7 +5081,7 @@
       </p:sp>
       <p:sp>
         <p:nvSpPr>
-          <p:cNvPr id="63" name="Text 61"/>
+          <p:cNvPr id="78" name="Text 76"/>
           <p:cNvSpPr txBox="1"/>
           <p:nvPr/>
         </p:nvSpPr>
@@ -4535,14 +5120,14 @@
       </p:sp>
       <p:sp>
         <p:nvSpPr>
-          <p:cNvPr id="64" name="Shape 62"/>
+          <p:cNvPr id="79" name="Shape 77"/>
           <p:cNvSpPr/>
           <p:nvPr/>
         </p:nvSpPr>
         <p:spPr>
           <a:xfrm>
-            <a:off x="3710263" y="4987218"/>
-            <a:ext cx="90735" cy="136676"/>
+            <a:off x="3391623" y="4987218"/>
+            <a:ext cx="43373" cy="136676"/>
           </a:xfrm>
           <a:prstGeom prst="rect">
             <a:avLst/>
@@ -4555,13 +5140,13 @@
       </p:sp>
       <p:sp>
         <p:nvSpPr>
-          <p:cNvPr id="65" name="Text 63"/>
-          <p:cNvSpPr txBox="1"/>
-          <p:nvPr/>
-        </p:nvSpPr>
-        <p:spPr>
-          <a:xfrm>
-            <a:off x="4818888" y="4931305"/>
+          <p:cNvPr id="80" name="Text 78"/>
+          <p:cNvSpPr txBox="1"/>
+          <p:nvPr/>
+        </p:nvSpPr>
+        <p:spPr>
+          <a:xfrm>
+            <a:off x="3950208" y="4931305"/>
             <a:ext cx="1097280" cy="248502"/>
           </a:xfrm>
           <a:prstGeom prst="rect">
@@ -4594,7 +5179,46 @@
       </p:sp>
       <p:sp>
         <p:nvSpPr>
-          <p:cNvPr id="66" name="Text 64"/>
+          <p:cNvPr id="81" name="Text 79"/>
+          <p:cNvSpPr txBox="1"/>
+          <p:nvPr/>
+        </p:nvSpPr>
+        <p:spPr>
+          <a:xfrm>
+            <a:off x="5047488" y="4931305"/>
+            <a:ext cx="868680" cy="248502"/>
+          </a:xfrm>
+          <a:prstGeom prst="rect">
+            <a:avLst/>
+          </a:prstGeom>
+          <a:noFill/>
+          <a:ln/>
+        </p:spPr>
+        <p:txBody>
+          <a:bodyPr wrap="square" lIns="0" tIns="0" rIns="0" bIns="0" rtlCol="0" anchor="ctr"/>
+          <a:lstStyle/>
+          <a:p>
+            <a:pPr algn="r" indent="0" marL="0">
+              <a:buNone/>
+            </a:pPr>
+            <a:r>
+              <a:rPr lang="en-US" sz="1300" dirty="0">
+                <a:solidFill>
+                  <a:srgbClr val="595959"/>
+                </a:solidFill>
+                <a:latin typeface="Inter" pitchFamily="34" charset="0"/>
+                <a:ea typeface="Inter" pitchFamily="34" charset="-122"/>
+                <a:cs typeface="Inter" pitchFamily="34" charset="-120"/>
+              </a:rPr>
+              <a:t>−660</a:t>
+            </a:r>
+            <a:endParaRPr lang="en-US" sz="1300" dirty="0"/>
+          </a:p>
+        </p:txBody>
+      </p:sp>
+      <p:sp>
+        <p:nvSpPr>
+          <p:cNvPr id="82" name="Text 80"/>
           <p:cNvSpPr txBox="1"/>
           <p:nvPr/>
         </p:nvSpPr>
@@ -4633,7 +5257,7 @@
       </p:sp>
       <p:sp>
         <p:nvSpPr>
-          <p:cNvPr id="67" name="Text 65"/>
+          <p:cNvPr id="83" name="Text 81"/>
           <p:cNvSpPr txBox="1"/>
           <p:nvPr/>
         </p:nvSpPr>
@@ -4672,14 +5296,14 @@
       </p:sp>
       <p:sp>
         <p:nvSpPr>
-          <p:cNvPr id="68" name="Shape 66"/>
+          <p:cNvPr id="84" name="Shape 82"/>
           <p:cNvSpPr/>
           <p:nvPr/>
         </p:nvSpPr>
         <p:spPr>
           <a:xfrm>
-            <a:off x="3698735" y="5235720"/>
-            <a:ext cx="102262" cy="136676"/>
+            <a:off x="3386113" y="5235720"/>
+            <a:ext cx="48884" cy="136676"/>
           </a:xfrm>
           <a:prstGeom prst="rect">
             <a:avLst/>
@@ -4692,13 +5316,13 @@
       </p:sp>
       <p:sp>
         <p:nvSpPr>
-          <p:cNvPr id="69" name="Text 67"/>
-          <p:cNvSpPr txBox="1"/>
-          <p:nvPr/>
-        </p:nvSpPr>
-        <p:spPr>
-          <a:xfrm>
-            <a:off x="4818888" y="5179807"/>
+          <p:cNvPr id="85" name="Text 83"/>
+          <p:cNvSpPr txBox="1"/>
+          <p:nvPr/>
+        </p:nvSpPr>
+        <p:spPr>
+          <a:xfrm>
+            <a:off x="3950208" y="5179807"/>
             <a:ext cx="1097280" cy="248502"/>
           </a:xfrm>
           <a:prstGeom prst="rect">
@@ -4731,7 +5355,46 @@
       </p:sp>
       <p:sp>
         <p:nvSpPr>
-          <p:cNvPr id="70" name="Text 68"/>
+          <p:cNvPr id="86" name="Text 84"/>
+          <p:cNvSpPr txBox="1"/>
+          <p:nvPr/>
+        </p:nvSpPr>
+        <p:spPr>
+          <a:xfrm>
+            <a:off x="5047488" y="5179807"/>
+            <a:ext cx="868680" cy="248502"/>
+          </a:xfrm>
+          <a:prstGeom prst="rect">
+            <a:avLst/>
+          </a:prstGeom>
+          <a:noFill/>
+          <a:ln/>
+        </p:spPr>
+        <p:txBody>
+          <a:bodyPr wrap="square" lIns="0" tIns="0" rIns="0" bIns="0" rtlCol="0" anchor="ctr"/>
+          <a:lstStyle/>
+          <a:p>
+            <a:pPr algn="r" indent="0" marL="0">
+              <a:buNone/>
+            </a:pPr>
+            <a:r>
+              <a:rPr lang="en-US" sz="1300" dirty="0">
+                <a:solidFill>
+                  <a:srgbClr val="595959"/>
+                </a:solidFill>
+                <a:latin typeface="Inter" pitchFamily="34" charset="0"/>
+                <a:ea typeface="Inter" pitchFamily="34" charset="-122"/>
+                <a:cs typeface="Inter" pitchFamily="34" charset="-120"/>
+              </a:rPr>
+              <a:t>−783</a:t>
+            </a:r>
+            <a:endParaRPr lang="en-US" sz="1300" dirty="0"/>
+          </a:p>
+        </p:txBody>
+      </p:sp>
+      <p:sp>
+        <p:nvSpPr>
+          <p:cNvPr id="87" name="Text 85"/>
           <p:cNvSpPr txBox="1"/>
           <p:nvPr/>
         </p:nvSpPr>
@@ -4770,7 +5433,7 @@
       </p:sp>
       <p:sp>
         <p:nvSpPr>
-          <p:cNvPr id="71" name="Text 69"/>
+          <p:cNvPr id="88" name="Text 86"/>
           <p:cNvSpPr txBox="1"/>
           <p:nvPr/>
         </p:nvSpPr>
@@ -4809,14 +5472,14 @@
       </p:sp>
       <p:sp>
         <p:nvSpPr>
-          <p:cNvPr id="72" name="Shape 70"/>
+          <p:cNvPr id="89" name="Shape 87"/>
           <p:cNvSpPr/>
           <p:nvPr/>
         </p:nvSpPr>
         <p:spPr>
           <a:xfrm>
-            <a:off x="3697071" y="5484222"/>
-            <a:ext cx="103926" cy="136676"/>
+            <a:off x="3385317" y="5484222"/>
+            <a:ext cx="49679" cy="136676"/>
           </a:xfrm>
           <a:prstGeom prst="rect">
             <a:avLst/>
@@ -4829,13 +5492,13 @@
       </p:sp>
       <p:sp>
         <p:nvSpPr>
-          <p:cNvPr id="73" name="Text 71"/>
-          <p:cNvSpPr txBox="1"/>
-          <p:nvPr/>
-        </p:nvSpPr>
-        <p:spPr>
-          <a:xfrm>
-            <a:off x="4818888" y="5428309"/>
+          <p:cNvPr id="90" name="Text 88"/>
+          <p:cNvSpPr txBox="1"/>
+          <p:nvPr/>
+        </p:nvSpPr>
+        <p:spPr>
+          <a:xfrm>
+            <a:off x="3950208" y="5428309"/>
             <a:ext cx="1097280" cy="248502"/>
           </a:xfrm>
           <a:prstGeom prst="rect">
@@ -4868,7 +5531,46 @@
       </p:sp>
       <p:sp>
         <p:nvSpPr>
-          <p:cNvPr id="74" name="Text 72"/>
+          <p:cNvPr id="91" name="Text 89"/>
+          <p:cNvSpPr txBox="1"/>
+          <p:nvPr/>
+        </p:nvSpPr>
+        <p:spPr>
+          <a:xfrm>
+            <a:off x="5047488" y="5428309"/>
+            <a:ext cx="868680" cy="248502"/>
+          </a:xfrm>
+          <a:prstGeom prst="rect">
+            <a:avLst/>
+          </a:prstGeom>
+          <a:noFill/>
+          <a:ln/>
+        </p:spPr>
+        <p:txBody>
+          <a:bodyPr wrap="square" lIns="0" tIns="0" rIns="0" bIns="0" rtlCol="0" anchor="ctr"/>
+          <a:lstStyle/>
+          <a:p>
+            <a:pPr algn="r" indent="0" marL="0">
+              <a:buNone/>
+            </a:pPr>
+            <a:r>
+              <a:rPr lang="en-US" sz="1300" dirty="0">
+                <a:solidFill>
+                  <a:srgbClr val="595959"/>
+                </a:solidFill>
+                <a:latin typeface="Inter" pitchFamily="34" charset="0"/>
+                <a:ea typeface="Inter" pitchFamily="34" charset="-122"/>
+                <a:cs typeface="Inter" pitchFamily="34" charset="-120"/>
+              </a:rPr>
+              <a:t>−568</a:t>
+            </a:r>
+            <a:endParaRPr lang="en-US" sz="1300" dirty="0"/>
+          </a:p>
+        </p:txBody>
+      </p:sp>
+      <p:sp>
+        <p:nvSpPr>
+          <p:cNvPr id="92" name="Text 90"/>
           <p:cNvSpPr txBox="1"/>
           <p:nvPr/>
         </p:nvSpPr>
@@ -4907,7 +5609,7 @@
       </p:sp>
       <p:sp>
         <p:nvSpPr>
-          <p:cNvPr id="75" name="Text 73"/>
+          <p:cNvPr id="93" name="Text 91"/>
           <p:cNvSpPr txBox="1"/>
           <p:nvPr/>
         </p:nvSpPr>
@@ -4946,14 +5648,14 @@
       </p:sp>
       <p:sp>
         <p:nvSpPr>
-          <p:cNvPr id="76" name="Shape 74"/>
+          <p:cNvPr id="94" name="Shape 92"/>
           <p:cNvSpPr/>
           <p:nvPr/>
         </p:nvSpPr>
         <p:spPr>
           <a:xfrm>
-            <a:off x="3696290" y="5732723"/>
-            <a:ext cx="104707" cy="136676"/>
+            <a:off x="3384944" y="5732723"/>
+            <a:ext cx="50052" cy="136676"/>
           </a:xfrm>
           <a:prstGeom prst="rect">
             <a:avLst/>
@@ -4966,13 +5668,13 @@
       </p:sp>
       <p:sp>
         <p:nvSpPr>
-          <p:cNvPr id="77" name="Text 75"/>
-          <p:cNvSpPr txBox="1"/>
-          <p:nvPr/>
-        </p:nvSpPr>
-        <p:spPr>
-          <a:xfrm>
-            <a:off x="4818888" y="5676810"/>
+          <p:cNvPr id="95" name="Text 93"/>
+          <p:cNvSpPr txBox="1"/>
+          <p:nvPr/>
+        </p:nvSpPr>
+        <p:spPr>
+          <a:xfrm>
+            <a:off x="3950208" y="5676810"/>
             <a:ext cx="1097280" cy="248502"/>
           </a:xfrm>
           <a:prstGeom prst="rect">
@@ -5005,7 +5707,46 @@
       </p:sp>
       <p:sp>
         <p:nvSpPr>
-          <p:cNvPr id="78" name="Text 76"/>
+          <p:cNvPr id="96" name="Text 94"/>
+          <p:cNvSpPr txBox="1"/>
+          <p:nvPr/>
+        </p:nvSpPr>
+        <p:spPr>
+          <a:xfrm>
+            <a:off x="5047488" y="5676810"/>
+            <a:ext cx="868680" cy="248502"/>
+          </a:xfrm>
+          <a:prstGeom prst="rect">
+            <a:avLst/>
+          </a:prstGeom>
+          <a:noFill/>
+          <a:ln/>
+        </p:spPr>
+        <p:txBody>
+          <a:bodyPr wrap="square" lIns="0" tIns="0" rIns="0" bIns="0" rtlCol="0" anchor="ctr"/>
+          <a:lstStyle/>
+          <a:p>
+            <a:pPr algn="r" indent="0" marL="0">
+              <a:buNone/>
+            </a:pPr>
+            <a:r>
+              <a:rPr lang="en-US" sz="1300" dirty="0">
+                <a:solidFill>
+                  <a:srgbClr val="595959"/>
+                </a:solidFill>
+                <a:latin typeface="Inter" pitchFamily="34" charset="0"/>
+                <a:ea typeface="Inter" pitchFamily="34" charset="-122"/>
+                <a:cs typeface="Inter" pitchFamily="34" charset="-120"/>
+              </a:rPr>
+              <a:t>−697</a:t>
+            </a:r>
+            <a:endParaRPr lang="en-US" sz="1300" dirty="0"/>
+          </a:p>
+        </p:txBody>
+      </p:sp>
+      <p:sp>
+        <p:nvSpPr>
+          <p:cNvPr id="97" name="Text 95"/>
           <p:cNvSpPr txBox="1"/>
           <p:nvPr/>
         </p:nvSpPr>
@@ -5044,7 +5785,7 @@
       </p:sp>
       <p:sp>
         <p:nvSpPr>
-          <p:cNvPr id="79" name="Text 77"/>
+          <p:cNvPr id="98" name="Text 96"/>
           <p:cNvSpPr txBox="1"/>
           <p:nvPr/>
         </p:nvSpPr>
@@ -5083,14 +5824,14 @@
       </p:sp>
       <p:sp>
         <p:nvSpPr>
-          <p:cNvPr id="80" name="Shape 78"/>
+          <p:cNvPr id="99" name="Shape 97"/>
           <p:cNvSpPr/>
           <p:nvPr/>
         </p:nvSpPr>
         <p:spPr>
           <a:xfrm>
-            <a:off x="9237983" y="1756697"/>
-            <a:ext cx="113423" cy="136676"/>
+            <a:off x="8931186" y="1756697"/>
+            <a:ext cx="54219" cy="136676"/>
           </a:xfrm>
           <a:prstGeom prst="rect">
             <a:avLst/>
@@ -5103,13 +5844,13 @@
       </p:sp>
       <p:sp>
         <p:nvSpPr>
-          <p:cNvPr id="81" name="Text 79"/>
-          <p:cNvSpPr txBox="1"/>
-          <p:nvPr/>
-        </p:nvSpPr>
-        <p:spPr>
-          <a:xfrm>
-            <a:off x="10369296" y="1700784"/>
+          <p:cNvPr id="100" name="Text 98"/>
+          <p:cNvSpPr txBox="1"/>
+          <p:nvPr/>
+        </p:nvSpPr>
+        <p:spPr>
+          <a:xfrm>
+            <a:off x="9500616" y="1700784"/>
             <a:ext cx="1097280" cy="248502"/>
           </a:xfrm>
           <a:prstGeom prst="rect">
@@ -5142,7 +5883,46 @@
       </p:sp>
       <p:sp>
         <p:nvSpPr>
-          <p:cNvPr id="82" name="Text 80"/>
+          <p:cNvPr id="101" name="Text 99"/>
+          <p:cNvSpPr txBox="1"/>
+          <p:nvPr/>
+        </p:nvSpPr>
+        <p:spPr>
+          <a:xfrm>
+            <a:off x="10597896" y="1700784"/>
+            <a:ext cx="868680" cy="248502"/>
+          </a:xfrm>
+          <a:prstGeom prst="rect">
+            <a:avLst/>
+          </a:prstGeom>
+          <a:noFill/>
+          <a:ln/>
+        </p:spPr>
+        <p:txBody>
+          <a:bodyPr wrap="square" lIns="0" tIns="0" rIns="0" bIns="0" rtlCol="0" anchor="ctr"/>
+          <a:lstStyle/>
+          <a:p>
+            <a:pPr algn="r" indent="0" marL="0">
+              <a:buNone/>
+            </a:pPr>
+            <a:r>
+              <a:rPr lang="en-US" sz="1300" dirty="0">
+                <a:solidFill>
+                  <a:srgbClr val="595959"/>
+                </a:solidFill>
+                <a:latin typeface="Inter" pitchFamily="34" charset="0"/>
+                <a:ea typeface="Inter" pitchFamily="34" charset="-122"/>
+                <a:cs typeface="Inter" pitchFamily="34" charset="-120"/>
+              </a:rPr>
+              <a:t>−640</a:t>
+            </a:r>
+            <a:endParaRPr lang="en-US" sz="1300" dirty="0"/>
+          </a:p>
+        </p:txBody>
+      </p:sp>
+      <p:sp>
+        <p:nvSpPr>
+          <p:cNvPr id="102" name="Text 100"/>
           <p:cNvSpPr txBox="1"/>
           <p:nvPr/>
         </p:nvSpPr>
@@ -5181,7 +5961,7 @@
       </p:sp>
       <p:sp>
         <p:nvSpPr>
-          <p:cNvPr id="83" name="Text 81"/>
+          <p:cNvPr id="103" name="Text 101"/>
           <p:cNvSpPr txBox="1"/>
           <p:nvPr/>
         </p:nvSpPr>
@@ -5220,14 +6000,14 @@
       </p:sp>
       <p:sp>
         <p:nvSpPr>
-          <p:cNvPr id="84" name="Shape 82"/>
+          <p:cNvPr id="104" name="Shape 102"/>
           <p:cNvSpPr/>
           <p:nvPr/>
         </p:nvSpPr>
         <p:spPr>
           <a:xfrm>
-            <a:off x="9188179" y="2005199"/>
-            <a:ext cx="163227" cy="136676"/>
+            <a:off x="8907378" y="2005199"/>
+            <a:ext cx="78026" cy="136676"/>
           </a:xfrm>
           <a:prstGeom prst="rect">
             <a:avLst/>
@@ -5240,13 +6020,13 @@
       </p:sp>
       <p:sp>
         <p:nvSpPr>
-          <p:cNvPr id="85" name="Text 83"/>
-          <p:cNvSpPr txBox="1"/>
-          <p:nvPr/>
-        </p:nvSpPr>
-        <p:spPr>
-          <a:xfrm>
-            <a:off x="10369296" y="1949286"/>
+          <p:cNvPr id="105" name="Text 103"/>
+          <p:cNvSpPr txBox="1"/>
+          <p:nvPr/>
+        </p:nvSpPr>
+        <p:spPr>
+          <a:xfrm>
+            <a:off x="9500616" y="1949286"/>
             <a:ext cx="1097280" cy="248502"/>
           </a:xfrm>
           <a:prstGeom prst="rect">
@@ -5279,7 +6059,46 @@
       </p:sp>
       <p:sp>
         <p:nvSpPr>
-          <p:cNvPr id="86" name="Text 84"/>
+          <p:cNvPr id="106" name="Text 104"/>
+          <p:cNvSpPr txBox="1"/>
+          <p:nvPr/>
+        </p:nvSpPr>
+        <p:spPr>
+          <a:xfrm>
+            <a:off x="10597896" y="1949286"/>
+            <a:ext cx="868680" cy="248502"/>
+          </a:xfrm>
+          <a:prstGeom prst="rect">
+            <a:avLst/>
+          </a:prstGeom>
+          <a:noFill/>
+          <a:ln/>
+        </p:spPr>
+        <p:txBody>
+          <a:bodyPr wrap="square" lIns="0" tIns="0" rIns="0" bIns="0" rtlCol="0" anchor="ctr"/>
+          <a:lstStyle/>
+          <a:p>
+            <a:pPr algn="r" indent="0" marL="0">
+              <a:buNone/>
+            </a:pPr>
+            <a:r>
+              <a:rPr lang="en-US" sz="1300" dirty="0">
+                <a:solidFill>
+                  <a:srgbClr val="595959"/>
+                </a:solidFill>
+                <a:latin typeface="Inter" pitchFamily="34" charset="0"/>
+                <a:ea typeface="Inter" pitchFamily="34" charset="-122"/>
+                <a:cs typeface="Inter" pitchFamily="34" charset="-120"/>
+              </a:rPr>
+              <a:t>−954</a:t>
+            </a:r>
+            <a:endParaRPr lang="en-US" sz="1300" dirty="0"/>
+          </a:p>
+        </p:txBody>
+      </p:sp>
+      <p:sp>
+        <p:nvSpPr>
+          <p:cNvPr id="107" name="Text 105"/>
           <p:cNvSpPr txBox="1"/>
           <p:nvPr/>
         </p:nvSpPr>
@@ -5318,7 +6137,7 @@
       </p:sp>
       <p:sp>
         <p:nvSpPr>
-          <p:cNvPr id="87" name="Text 85"/>
+          <p:cNvPr id="108" name="Text 106"/>
           <p:cNvSpPr txBox="1"/>
           <p:nvPr/>
         </p:nvSpPr>
@@ -5357,14 +6176,14 @@
       </p:sp>
       <p:sp>
         <p:nvSpPr>
-          <p:cNvPr id="88" name="Shape 86"/>
+          <p:cNvPr id="109" name="Shape 107"/>
           <p:cNvSpPr/>
           <p:nvPr/>
         </p:nvSpPr>
         <p:spPr>
           <a:xfrm>
-            <a:off x="9179400" y="2253700"/>
-            <a:ext cx="172006" cy="136676"/>
+            <a:off x="8903182" y="2253700"/>
+            <a:ext cx="82223" cy="136676"/>
           </a:xfrm>
           <a:prstGeom prst="rect">
             <a:avLst/>
@@ -5377,13 +6196,13 @@
       </p:sp>
       <p:sp>
         <p:nvSpPr>
-          <p:cNvPr id="89" name="Text 87"/>
-          <p:cNvSpPr txBox="1"/>
-          <p:nvPr/>
-        </p:nvSpPr>
-        <p:spPr>
-          <a:xfrm>
-            <a:off x="10369296" y="2197787"/>
+          <p:cNvPr id="110" name="Text 108"/>
+          <p:cNvSpPr txBox="1"/>
+          <p:nvPr/>
+        </p:nvSpPr>
+        <p:spPr>
+          <a:xfrm>
+            <a:off x="9500616" y="2197787"/>
             <a:ext cx="1097280" cy="248502"/>
           </a:xfrm>
           <a:prstGeom prst="rect">
@@ -5416,7 +6235,46 @@
       </p:sp>
       <p:sp>
         <p:nvSpPr>
-          <p:cNvPr id="90" name="Text 88"/>
+          <p:cNvPr id="111" name="Text 109"/>
+          <p:cNvSpPr txBox="1"/>
+          <p:nvPr/>
+        </p:nvSpPr>
+        <p:spPr>
+          <a:xfrm>
+            <a:off x="10597896" y="2197787"/>
+            <a:ext cx="868680" cy="248502"/>
+          </a:xfrm>
+          <a:prstGeom prst="rect">
+            <a:avLst/>
+          </a:prstGeom>
+          <a:noFill/>
+          <a:ln/>
+        </p:spPr>
+        <p:txBody>
+          <a:bodyPr wrap="square" lIns="0" tIns="0" rIns="0" bIns="0" rtlCol="0" anchor="ctr"/>
+          <a:lstStyle/>
+          <a:p>
+            <a:pPr algn="r" indent="0" marL="0">
+              <a:buNone/>
+            </a:pPr>
+            <a:r>
+              <a:rPr lang="en-US" sz="1300" dirty="0">
+                <a:solidFill>
+                  <a:srgbClr val="595959"/>
+                </a:solidFill>
+                <a:latin typeface="Inter" pitchFamily="34" charset="0"/>
+                <a:ea typeface="Inter" pitchFamily="34" charset="-122"/>
+                <a:cs typeface="Inter" pitchFamily="34" charset="-120"/>
+              </a:rPr>
+              <a:t>−1,100</a:t>
+            </a:r>
+            <a:endParaRPr lang="en-US" sz="1300" dirty="0"/>
+          </a:p>
+        </p:txBody>
+      </p:sp>
+      <p:sp>
+        <p:nvSpPr>
+          <p:cNvPr id="112" name="Text 110"/>
           <p:cNvSpPr txBox="1"/>
           <p:nvPr/>
         </p:nvSpPr>
@@ -5455,7 +6313,7 @@
       </p:sp>
       <p:sp>
         <p:nvSpPr>
-          <p:cNvPr id="91" name="Text 89"/>
+          <p:cNvPr id="113" name="Text 111"/>
           <p:cNvSpPr txBox="1"/>
           <p:nvPr/>
         </p:nvSpPr>
@@ -5494,14 +6352,14 @@
       </p:sp>
       <p:sp>
         <p:nvSpPr>
-          <p:cNvPr id="92" name="Shape 90"/>
+          <p:cNvPr id="114" name="Shape 112"/>
           <p:cNvSpPr/>
           <p:nvPr/>
         </p:nvSpPr>
         <p:spPr>
           <a:xfrm>
-            <a:off x="9170174" y="2502202"/>
-            <a:ext cx="181231" cy="136676"/>
+            <a:off x="8898772" y="2502202"/>
+            <a:ext cx="86632" cy="136676"/>
           </a:xfrm>
           <a:prstGeom prst="rect">
             <a:avLst/>
@@ -5514,13 +6372,13 @@
       </p:sp>
       <p:sp>
         <p:nvSpPr>
-          <p:cNvPr id="93" name="Text 91"/>
-          <p:cNvSpPr txBox="1"/>
-          <p:nvPr/>
-        </p:nvSpPr>
-        <p:spPr>
-          <a:xfrm>
-            <a:off x="10369296" y="2446289"/>
+          <p:cNvPr id="115" name="Text 113"/>
+          <p:cNvSpPr txBox="1"/>
+          <p:nvPr/>
+        </p:nvSpPr>
+        <p:spPr>
+          <a:xfrm>
+            <a:off x="9500616" y="2446289"/>
             <a:ext cx="1097280" cy="248502"/>
           </a:xfrm>
           <a:prstGeom prst="rect">
@@ -5553,7 +6411,46 @@
       </p:sp>
       <p:sp>
         <p:nvSpPr>
-          <p:cNvPr id="94" name="Text 92"/>
+          <p:cNvPr id="116" name="Text 114"/>
+          <p:cNvSpPr txBox="1"/>
+          <p:nvPr/>
+        </p:nvSpPr>
+        <p:spPr>
+          <a:xfrm>
+            <a:off x="10597896" y="2446289"/>
+            <a:ext cx="868680" cy="248502"/>
+          </a:xfrm>
+          <a:prstGeom prst="rect">
+            <a:avLst/>
+          </a:prstGeom>
+          <a:noFill/>
+          <a:ln/>
+        </p:spPr>
+        <p:txBody>
+          <a:bodyPr wrap="square" lIns="0" tIns="0" rIns="0" bIns="0" rtlCol="0" anchor="ctr"/>
+          <a:lstStyle/>
+          <a:p>
+            <a:pPr algn="r" indent="0" marL="0">
+              <a:buNone/>
+            </a:pPr>
+            <a:r>
+              <a:rPr lang="en-US" sz="1300" dirty="0">
+                <a:solidFill>
+                  <a:srgbClr val="595959"/>
+                </a:solidFill>
+                <a:latin typeface="Inter" pitchFamily="34" charset="0"/>
+                <a:ea typeface="Inter" pitchFamily="34" charset="-122"/>
+                <a:cs typeface="Inter" pitchFamily="34" charset="-120"/>
+              </a:rPr>
+              <a:t>−827</a:t>
+            </a:r>
+            <a:endParaRPr lang="en-US" sz="1300" dirty="0"/>
+          </a:p>
+        </p:txBody>
+      </p:sp>
+      <p:sp>
+        <p:nvSpPr>
+          <p:cNvPr id="117" name="Text 115"/>
           <p:cNvSpPr txBox="1"/>
           <p:nvPr/>
         </p:nvSpPr>
@@ -5592,7 +6489,7 @@
       </p:sp>
       <p:sp>
         <p:nvSpPr>
-          <p:cNvPr id="95" name="Text 93"/>
+          <p:cNvPr id="118" name="Text 116"/>
           <p:cNvSpPr txBox="1"/>
           <p:nvPr/>
         </p:nvSpPr>
@@ -5631,14 +6528,14 @@
       </p:sp>
       <p:sp>
         <p:nvSpPr>
-          <p:cNvPr id="96" name="Shape 94"/>
+          <p:cNvPr id="119" name="Shape 117"/>
           <p:cNvSpPr/>
           <p:nvPr/>
         </p:nvSpPr>
         <p:spPr>
           <a:xfrm>
-            <a:off x="9169305" y="2750703"/>
-            <a:ext cx="182101" cy="136676"/>
+            <a:off x="8898356" y="2750703"/>
+            <a:ext cx="87048" cy="136676"/>
           </a:xfrm>
           <a:prstGeom prst="rect">
             <a:avLst/>
@@ -5651,13 +6548,13 @@
       </p:sp>
       <p:sp>
         <p:nvSpPr>
-          <p:cNvPr id="97" name="Text 95"/>
-          <p:cNvSpPr txBox="1"/>
-          <p:nvPr/>
-        </p:nvSpPr>
-        <p:spPr>
-          <a:xfrm>
-            <a:off x="10369296" y="2694791"/>
+          <p:cNvPr id="120" name="Text 118"/>
+          <p:cNvSpPr txBox="1"/>
+          <p:nvPr/>
+        </p:nvSpPr>
+        <p:spPr>
+          <a:xfrm>
+            <a:off x="9500616" y="2694791"/>
             <a:ext cx="1097280" cy="248502"/>
           </a:xfrm>
           <a:prstGeom prst="rect">
@@ -5690,7 +6587,46 @@
       </p:sp>
       <p:sp>
         <p:nvSpPr>
-          <p:cNvPr id="98" name="Text 96"/>
+          <p:cNvPr id="121" name="Text 119"/>
+          <p:cNvSpPr txBox="1"/>
+          <p:nvPr/>
+        </p:nvSpPr>
+        <p:spPr>
+          <a:xfrm>
+            <a:off x="10597896" y="2694791"/>
+            <a:ext cx="868680" cy="248502"/>
+          </a:xfrm>
+          <a:prstGeom prst="rect">
+            <a:avLst/>
+          </a:prstGeom>
+          <a:noFill/>
+          <a:ln/>
+        </p:spPr>
+        <p:txBody>
+          <a:bodyPr wrap="square" lIns="0" tIns="0" rIns="0" bIns="0" rtlCol="0" anchor="ctr"/>
+          <a:lstStyle/>
+          <a:p>
+            <a:pPr algn="r" indent="0" marL="0">
+              <a:buNone/>
+            </a:pPr>
+            <a:r>
+              <a:rPr lang="en-US" sz="1300" dirty="0">
+                <a:solidFill>
+                  <a:srgbClr val="595959"/>
+                </a:solidFill>
+                <a:latin typeface="Inter" pitchFamily="34" charset="0"/>
+                <a:ea typeface="Inter" pitchFamily="34" charset="-122"/>
+                <a:cs typeface="Inter" pitchFamily="34" charset="-120"/>
+              </a:rPr>
+              <a:t>−1,068</a:t>
+            </a:r>
+            <a:endParaRPr lang="en-US" sz="1300" dirty="0"/>
+          </a:p>
+        </p:txBody>
+      </p:sp>
+      <p:sp>
+        <p:nvSpPr>
+          <p:cNvPr id="122" name="Text 120"/>
           <p:cNvSpPr txBox="1"/>
           <p:nvPr/>
         </p:nvSpPr>
@@ -5729,7 +6665,7 @@
       </p:sp>
       <p:sp>
         <p:nvSpPr>
-          <p:cNvPr id="99" name="Text 97"/>
+          <p:cNvPr id="123" name="Text 121"/>
           <p:cNvSpPr txBox="1"/>
           <p:nvPr/>
         </p:nvSpPr>
@@ -5768,14 +6704,14 @@
       </p:sp>
       <p:sp>
         <p:nvSpPr>
-          <p:cNvPr id="100" name="Shape 98"/>
+          <p:cNvPr id="124" name="Shape 122"/>
           <p:cNvSpPr/>
           <p:nvPr/>
         </p:nvSpPr>
         <p:spPr>
           <a:xfrm>
-            <a:off x="9109792" y="2999205"/>
-            <a:ext cx="241613" cy="136676"/>
+            <a:off x="8869908" y="2999205"/>
+            <a:ext cx="115496" cy="136676"/>
           </a:xfrm>
           <a:prstGeom prst="rect">
             <a:avLst/>
@@ -5788,13 +6724,13 @@
       </p:sp>
       <p:sp>
         <p:nvSpPr>
-          <p:cNvPr id="101" name="Text 99"/>
-          <p:cNvSpPr txBox="1"/>
-          <p:nvPr/>
-        </p:nvSpPr>
-        <p:spPr>
-          <a:xfrm>
-            <a:off x="10369296" y="2943292"/>
+          <p:cNvPr id="125" name="Text 123"/>
+          <p:cNvSpPr txBox="1"/>
+          <p:nvPr/>
+        </p:nvSpPr>
+        <p:spPr>
+          <a:xfrm>
+            <a:off x="9500616" y="2943292"/>
             <a:ext cx="1097280" cy="248502"/>
           </a:xfrm>
           <a:prstGeom prst="rect">
@@ -5827,7 +6763,46 @@
       </p:sp>
       <p:sp>
         <p:nvSpPr>
-          <p:cNvPr id="102" name="Text 100"/>
+          <p:cNvPr id="126" name="Text 124"/>
+          <p:cNvSpPr txBox="1"/>
+          <p:nvPr/>
+        </p:nvSpPr>
+        <p:spPr>
+          <a:xfrm>
+            <a:off x="10597896" y="2943292"/>
+            <a:ext cx="868680" cy="248502"/>
+          </a:xfrm>
+          <a:prstGeom prst="rect">
+            <a:avLst/>
+          </a:prstGeom>
+          <a:noFill/>
+          <a:ln/>
+        </p:spPr>
+        <p:txBody>
+          <a:bodyPr wrap="square" lIns="0" tIns="0" rIns="0" bIns="0" rtlCol="0" anchor="ctr"/>
+          <a:lstStyle/>
+          <a:p>
+            <a:pPr algn="r" indent="0" marL="0">
+              <a:buNone/>
+            </a:pPr>
+            <a:r>
+              <a:rPr lang="en-US" sz="1300" dirty="0">
+                <a:solidFill>
+                  <a:srgbClr val="595959"/>
+                </a:solidFill>
+                <a:latin typeface="Inter" pitchFamily="34" charset="0"/>
+                <a:ea typeface="Inter" pitchFamily="34" charset="-122"/>
+                <a:cs typeface="Inter" pitchFamily="34" charset="-120"/>
+              </a:rPr>
+              <a:t>−1,717</a:t>
+            </a:r>
+            <a:endParaRPr lang="en-US" sz="1300" dirty="0"/>
+          </a:p>
+        </p:txBody>
+      </p:sp>
+      <p:sp>
+        <p:nvSpPr>
+          <p:cNvPr id="127" name="Text 125"/>
           <p:cNvSpPr txBox="1"/>
           <p:nvPr/>
         </p:nvSpPr>
@@ -5866,7 +6841,7 @@
       </p:sp>
       <p:sp>
         <p:nvSpPr>
-          <p:cNvPr id="103" name="Text 101"/>
+          <p:cNvPr id="128" name="Text 126"/>
           <p:cNvSpPr txBox="1"/>
           <p:nvPr/>
         </p:nvSpPr>
@@ -5905,14 +6880,14 @@
       </p:sp>
       <p:sp>
         <p:nvSpPr>
-          <p:cNvPr id="104" name="Shape 102"/>
+          <p:cNvPr id="129" name="Shape 127"/>
           <p:cNvSpPr/>
           <p:nvPr/>
         </p:nvSpPr>
         <p:spPr>
           <a:xfrm>
-            <a:off x="9092573" y="3247707"/>
-            <a:ext cx="258833" cy="136676"/>
+            <a:off x="8861676" y="3247707"/>
+            <a:ext cx="123728" cy="136676"/>
           </a:xfrm>
           <a:prstGeom prst="rect">
             <a:avLst/>
@@ -5925,13 +6900,13 @@
       </p:sp>
       <p:sp>
         <p:nvSpPr>
-          <p:cNvPr id="105" name="Text 103"/>
-          <p:cNvSpPr txBox="1"/>
-          <p:nvPr/>
-        </p:nvSpPr>
-        <p:spPr>
-          <a:xfrm>
-            <a:off x="10369296" y="3191794"/>
+          <p:cNvPr id="130" name="Text 128"/>
+          <p:cNvSpPr txBox="1"/>
+          <p:nvPr/>
+        </p:nvSpPr>
+        <p:spPr>
+          <a:xfrm>
+            <a:off x="9500616" y="3191794"/>
             <a:ext cx="1097280" cy="248502"/>
           </a:xfrm>
           <a:prstGeom prst="rect">
@@ -5964,7 +6939,46 @@
       </p:sp>
       <p:sp>
         <p:nvSpPr>
-          <p:cNvPr id="106" name="Text 104"/>
+          <p:cNvPr id="131" name="Text 129"/>
+          <p:cNvSpPr txBox="1"/>
+          <p:nvPr/>
+        </p:nvSpPr>
+        <p:spPr>
+          <a:xfrm>
+            <a:off x="10597896" y="3191794"/>
+            <a:ext cx="868680" cy="248502"/>
+          </a:xfrm>
+          <a:prstGeom prst="rect">
+            <a:avLst/>
+          </a:prstGeom>
+          <a:noFill/>
+          <a:ln/>
+        </p:spPr>
+        <p:txBody>
+          <a:bodyPr wrap="square" lIns="0" tIns="0" rIns="0" bIns="0" rtlCol="0" anchor="ctr"/>
+          <a:lstStyle/>
+          <a:p>
+            <a:pPr algn="r" indent="0" marL="0">
+              <a:buNone/>
+            </a:pPr>
+            <a:r>
+              <a:rPr lang="en-US" sz="1300" dirty="0">
+                <a:solidFill>
+                  <a:srgbClr val="595959"/>
+                </a:solidFill>
+                <a:latin typeface="Inter" pitchFamily="34" charset="0"/>
+                <a:ea typeface="Inter" pitchFamily="34" charset="-122"/>
+                <a:cs typeface="Inter" pitchFamily="34" charset="-120"/>
+              </a:rPr>
+              <a:t>−1,613</a:t>
+            </a:r>
+            <a:endParaRPr lang="en-US" sz="1300" dirty="0"/>
+          </a:p>
+        </p:txBody>
+      </p:sp>
+      <p:sp>
+        <p:nvSpPr>
+          <p:cNvPr id="132" name="Text 130"/>
           <p:cNvSpPr txBox="1"/>
           <p:nvPr/>
         </p:nvSpPr>
@@ -6003,7 +7017,7 @@
       </p:sp>
       <p:sp>
         <p:nvSpPr>
-          <p:cNvPr id="107" name="Text 105"/>
+          <p:cNvPr id="133" name="Text 131"/>
           <p:cNvSpPr txBox="1"/>
           <p:nvPr/>
         </p:nvSpPr>
@@ -6042,14 +7056,14 @@
       </p:sp>
       <p:sp>
         <p:nvSpPr>
-          <p:cNvPr id="108" name="Shape 106"/>
+          <p:cNvPr id="134" name="Shape 132"/>
           <p:cNvSpPr/>
           <p:nvPr/>
         </p:nvSpPr>
         <p:spPr>
           <a:xfrm>
-            <a:off x="9092243" y="3496208"/>
-            <a:ext cx="259162" cy="136676"/>
+            <a:off x="8861519" y="3496208"/>
+            <a:ext cx="123885" cy="136676"/>
           </a:xfrm>
           <a:prstGeom prst="rect">
             <a:avLst/>
@@ -6062,13 +7076,13 @@
       </p:sp>
       <p:sp>
         <p:nvSpPr>
-          <p:cNvPr id="109" name="Text 107"/>
-          <p:cNvSpPr txBox="1"/>
-          <p:nvPr/>
-        </p:nvSpPr>
-        <p:spPr>
-          <a:xfrm>
-            <a:off x="10369296" y="3440296"/>
+          <p:cNvPr id="135" name="Text 133"/>
+          <p:cNvSpPr txBox="1"/>
+          <p:nvPr/>
+        </p:nvSpPr>
+        <p:spPr>
+          <a:xfrm>
+            <a:off x="9500616" y="3440296"/>
             <a:ext cx="1097280" cy="248502"/>
           </a:xfrm>
           <a:prstGeom prst="rect">
@@ -6101,7 +7115,46 @@
       </p:sp>
       <p:sp>
         <p:nvSpPr>
-          <p:cNvPr id="110" name="Text 108"/>
+          <p:cNvPr id="136" name="Text 134"/>
+          <p:cNvSpPr txBox="1"/>
+          <p:nvPr/>
+        </p:nvSpPr>
+        <p:spPr>
+          <a:xfrm>
+            <a:off x="10597896" y="3440296"/>
+            <a:ext cx="868680" cy="248502"/>
+          </a:xfrm>
+          <a:prstGeom prst="rect">
+            <a:avLst/>
+          </a:prstGeom>
+          <a:noFill/>
+          <a:ln/>
+        </p:spPr>
+        <p:txBody>
+          <a:bodyPr wrap="square" lIns="0" tIns="0" rIns="0" bIns="0" rtlCol="0" anchor="ctr"/>
+          <a:lstStyle/>
+          <a:p>
+            <a:pPr algn="r" indent="0" marL="0">
+              <a:buNone/>
+            </a:pPr>
+            <a:r>
+              <a:rPr lang="en-US" sz="1300" dirty="0">
+                <a:solidFill>
+                  <a:srgbClr val="595959"/>
+                </a:solidFill>
+                <a:latin typeface="Inter" pitchFamily="34" charset="0"/>
+                <a:ea typeface="Inter" pitchFamily="34" charset="-122"/>
+                <a:cs typeface="Inter" pitchFamily="34" charset="-120"/>
+              </a:rPr>
+              <a:t>−1,257</a:t>
+            </a:r>
+            <a:endParaRPr lang="en-US" sz="1300" dirty="0"/>
+          </a:p>
+        </p:txBody>
+      </p:sp>
+      <p:sp>
+        <p:nvSpPr>
+          <p:cNvPr id="137" name="Text 135"/>
           <p:cNvSpPr txBox="1"/>
           <p:nvPr/>
         </p:nvSpPr>
@@ -6140,7 +7193,7 @@
       </p:sp>
       <p:sp>
         <p:nvSpPr>
-          <p:cNvPr id="111" name="Text 109"/>
+          <p:cNvPr id="138" name="Text 136"/>
           <p:cNvSpPr txBox="1"/>
           <p:nvPr/>
         </p:nvSpPr>
@@ -6179,14 +7232,14 @@
       </p:sp>
       <p:sp>
         <p:nvSpPr>
-          <p:cNvPr id="112" name="Shape 110"/>
+          <p:cNvPr id="139" name="Shape 137"/>
           <p:cNvSpPr/>
           <p:nvPr/>
         </p:nvSpPr>
         <p:spPr>
           <a:xfrm>
-            <a:off x="9072005" y="3744710"/>
-            <a:ext cx="279401" cy="136676"/>
+            <a:off x="8851844" y="3744710"/>
+            <a:ext cx="133560" cy="136676"/>
           </a:xfrm>
           <a:prstGeom prst="rect">
             <a:avLst/>
@@ -6199,13 +7252,13 @@
       </p:sp>
       <p:sp>
         <p:nvSpPr>
-          <p:cNvPr id="113" name="Text 111"/>
-          <p:cNvSpPr txBox="1"/>
-          <p:nvPr/>
-        </p:nvSpPr>
-        <p:spPr>
-          <a:xfrm>
-            <a:off x="10369296" y="3688797"/>
+          <p:cNvPr id="140" name="Text 138"/>
+          <p:cNvSpPr txBox="1"/>
+          <p:nvPr/>
+        </p:nvSpPr>
+        <p:spPr>
+          <a:xfrm>
+            <a:off x="9500616" y="3688797"/>
             <a:ext cx="1097280" cy="248502"/>
           </a:xfrm>
           <a:prstGeom prst="rect">
@@ -6238,7 +7291,46 @@
       </p:sp>
       <p:sp>
         <p:nvSpPr>
-          <p:cNvPr id="114" name="Text 112"/>
+          <p:cNvPr id="141" name="Text 139"/>
+          <p:cNvSpPr txBox="1"/>
+          <p:nvPr/>
+        </p:nvSpPr>
+        <p:spPr>
+          <a:xfrm>
+            <a:off x="10597896" y="3688797"/>
+            <a:ext cx="868680" cy="248502"/>
+          </a:xfrm>
+          <a:prstGeom prst="rect">
+            <a:avLst/>
+          </a:prstGeom>
+          <a:noFill/>
+          <a:ln/>
+        </p:spPr>
+        <p:txBody>
+          <a:bodyPr wrap="square" lIns="0" tIns="0" rIns="0" bIns="0" rtlCol="0" anchor="ctr"/>
+          <a:lstStyle/>
+          <a:p>
+            <a:pPr algn="r" indent="0" marL="0">
+              <a:buNone/>
+            </a:pPr>
+            <a:r>
+              <a:rPr lang="en-US" sz="1300" dirty="0">
+                <a:solidFill>
+                  <a:srgbClr val="595959"/>
+                </a:solidFill>
+                <a:latin typeface="Inter" pitchFamily="34" charset="0"/>
+                <a:ea typeface="Inter" pitchFamily="34" charset="-122"/>
+                <a:cs typeface="Inter" pitchFamily="34" charset="-120"/>
+              </a:rPr>
+              <a:t>−1,152</a:t>
+            </a:r>
+            <a:endParaRPr lang="en-US" sz="1300" dirty="0"/>
+          </a:p>
+        </p:txBody>
+      </p:sp>
+      <p:sp>
+        <p:nvSpPr>
+          <p:cNvPr id="142" name="Text 140"/>
           <p:cNvSpPr txBox="1"/>
           <p:nvPr/>
         </p:nvSpPr>
@@ -6277,7 +7369,7 @@
       </p:sp>
       <p:sp>
         <p:nvSpPr>
-          <p:cNvPr id="115" name="Text 113"/>
+          <p:cNvPr id="143" name="Text 141"/>
           <p:cNvSpPr txBox="1"/>
           <p:nvPr/>
         </p:nvSpPr>
@@ -6316,14 +7408,14 @@
       </p:sp>
       <p:sp>
         <p:nvSpPr>
-          <p:cNvPr id="116" name="Shape 114"/>
+          <p:cNvPr id="144" name="Shape 142"/>
           <p:cNvSpPr/>
           <p:nvPr/>
         </p:nvSpPr>
         <p:spPr>
           <a:xfrm>
-            <a:off x="9049807" y="3993212"/>
-            <a:ext cx="301599" cy="136676"/>
+            <a:off x="8841233" y="3993212"/>
+            <a:ext cx="144171" cy="136676"/>
           </a:xfrm>
           <a:prstGeom prst="rect">
             <a:avLst/>
@@ -6336,13 +7428,13 @@
       </p:sp>
       <p:sp>
         <p:nvSpPr>
-          <p:cNvPr id="117" name="Text 115"/>
-          <p:cNvSpPr txBox="1"/>
-          <p:nvPr/>
-        </p:nvSpPr>
-        <p:spPr>
-          <a:xfrm>
-            <a:off x="10369296" y="3937299"/>
+          <p:cNvPr id="145" name="Text 143"/>
+          <p:cNvSpPr txBox="1"/>
+          <p:nvPr/>
+        </p:nvSpPr>
+        <p:spPr>
+          <a:xfrm>
+            <a:off x="9500616" y="3937299"/>
             <a:ext cx="1097280" cy="248502"/>
           </a:xfrm>
           <a:prstGeom prst="rect">
@@ -6375,7 +7467,46 @@
       </p:sp>
       <p:sp>
         <p:nvSpPr>
-          <p:cNvPr id="118" name="Text 116"/>
+          <p:cNvPr id="146" name="Text 144"/>
+          <p:cNvSpPr txBox="1"/>
+          <p:nvPr/>
+        </p:nvSpPr>
+        <p:spPr>
+          <a:xfrm>
+            <a:off x="10597896" y="3937299"/>
+            <a:ext cx="868680" cy="248502"/>
+          </a:xfrm>
+          <a:prstGeom prst="rect">
+            <a:avLst/>
+          </a:prstGeom>
+          <a:noFill/>
+          <a:ln/>
+        </p:spPr>
+        <p:txBody>
+          <a:bodyPr wrap="square" lIns="0" tIns="0" rIns="0" bIns="0" rtlCol="0" anchor="ctr"/>
+          <a:lstStyle/>
+          <a:p>
+            <a:pPr algn="r" indent="0" marL="0">
+              <a:buNone/>
+            </a:pPr>
+            <a:r>
+              <a:rPr lang="en-US" sz="1300" dirty="0">
+                <a:solidFill>
+                  <a:srgbClr val="595959"/>
+                </a:solidFill>
+                <a:latin typeface="Inter" pitchFamily="34" charset="0"/>
+                <a:ea typeface="Inter" pitchFamily="34" charset="-122"/>
+                <a:cs typeface="Inter" pitchFamily="34" charset="-120"/>
+              </a:rPr>
+              <a:t>−1,906</a:t>
+            </a:r>
+            <a:endParaRPr lang="en-US" sz="1300" dirty="0"/>
+          </a:p>
+        </p:txBody>
+      </p:sp>
+      <p:sp>
+        <p:nvSpPr>
+          <p:cNvPr id="147" name="Text 145"/>
           <p:cNvSpPr txBox="1"/>
           <p:nvPr/>
         </p:nvSpPr>
@@ -6414,7 +7545,7 @@
       </p:sp>
       <p:sp>
         <p:nvSpPr>
-          <p:cNvPr id="119" name="Text 117"/>
+          <p:cNvPr id="148" name="Text 146"/>
           <p:cNvSpPr txBox="1"/>
           <p:nvPr/>
         </p:nvSpPr>
@@ -6453,14 +7584,14 @@
       </p:sp>
       <p:sp>
         <p:nvSpPr>
-          <p:cNvPr id="120" name="Shape 118"/>
+          <p:cNvPr id="149" name="Shape 147"/>
           <p:cNvSpPr/>
           <p:nvPr/>
         </p:nvSpPr>
         <p:spPr>
           <a:xfrm>
-            <a:off x="9034236" y="4241713"/>
-            <a:ext cx="317170" cy="136676"/>
+            <a:off x="8833790" y="4241713"/>
+            <a:ext cx="151614" cy="136676"/>
           </a:xfrm>
           <a:prstGeom prst="rect">
             <a:avLst/>
@@ -6473,13 +7604,13 @@
       </p:sp>
       <p:sp>
         <p:nvSpPr>
-          <p:cNvPr id="121" name="Text 119"/>
-          <p:cNvSpPr txBox="1"/>
-          <p:nvPr/>
-        </p:nvSpPr>
-        <p:spPr>
-          <a:xfrm>
-            <a:off x="10369296" y="4185800"/>
+          <p:cNvPr id="150" name="Text 148"/>
+          <p:cNvSpPr txBox="1"/>
+          <p:nvPr/>
+        </p:nvSpPr>
+        <p:spPr>
+          <a:xfrm>
+            <a:off x="9500616" y="4185800"/>
             <a:ext cx="1097280" cy="248502"/>
           </a:xfrm>
           <a:prstGeom prst="rect">
@@ -6512,7 +7643,46 @@
       </p:sp>
       <p:sp>
         <p:nvSpPr>
-          <p:cNvPr id="122" name="Text 120"/>
+          <p:cNvPr id="151" name="Text 149"/>
+          <p:cNvSpPr txBox="1"/>
+          <p:nvPr/>
+        </p:nvSpPr>
+        <p:spPr>
+          <a:xfrm>
+            <a:off x="10597896" y="4185800"/>
+            <a:ext cx="868680" cy="248502"/>
+          </a:xfrm>
+          <a:prstGeom prst="rect">
+            <a:avLst/>
+          </a:prstGeom>
+          <a:noFill/>
+          <a:ln/>
+        </p:spPr>
+        <p:txBody>
+          <a:bodyPr wrap="square" lIns="0" tIns="0" rIns="0" bIns="0" rtlCol="0" anchor="ctr"/>
+          <a:lstStyle/>
+          <a:p>
+            <a:pPr algn="r" indent="0" marL="0">
+              <a:buNone/>
+            </a:pPr>
+            <a:r>
+              <a:rPr lang="en-US" sz="1300" dirty="0">
+                <a:solidFill>
+                  <a:srgbClr val="595959"/>
+                </a:solidFill>
+                <a:latin typeface="Inter" pitchFamily="34" charset="0"/>
+                <a:ea typeface="Inter" pitchFamily="34" charset="-122"/>
+                <a:cs typeface="Inter" pitchFamily="34" charset="-120"/>
+              </a:rPr>
+              <a:t>−1,863</a:t>
+            </a:r>
+            <a:endParaRPr lang="en-US" sz="1300" dirty="0"/>
+          </a:p>
+        </p:txBody>
+      </p:sp>
+      <p:sp>
+        <p:nvSpPr>
+          <p:cNvPr id="152" name="Text 150"/>
           <p:cNvSpPr txBox="1"/>
           <p:nvPr/>
         </p:nvSpPr>
@@ -6551,7 +7721,7 @@
       </p:sp>
       <p:sp>
         <p:nvSpPr>
-          <p:cNvPr id="123" name="Text 121"/>
+          <p:cNvPr id="153" name="Text 151"/>
           <p:cNvSpPr txBox="1"/>
           <p:nvPr/>
         </p:nvSpPr>
@@ -6590,14 +7760,14 @@
       </p:sp>
       <p:sp>
         <p:nvSpPr>
-          <p:cNvPr id="124" name="Shape 122"/>
+          <p:cNvPr id="154" name="Shape 152"/>
           <p:cNvSpPr/>
           <p:nvPr/>
         </p:nvSpPr>
         <p:spPr>
           <a:xfrm>
-            <a:off x="9031867" y="4490215"/>
-            <a:ext cx="319539" cy="136676"/>
+            <a:off x="8832658" y="4490215"/>
+            <a:ext cx="152747" cy="136676"/>
           </a:xfrm>
           <a:prstGeom prst="rect">
             <a:avLst/>
@@ -6610,13 +7780,13 @@
       </p:sp>
       <p:sp>
         <p:nvSpPr>
-          <p:cNvPr id="125" name="Text 123"/>
-          <p:cNvSpPr txBox="1"/>
-          <p:nvPr/>
-        </p:nvSpPr>
-        <p:spPr>
-          <a:xfrm>
-            <a:off x="10369296" y="4434302"/>
+          <p:cNvPr id="155" name="Text 153"/>
+          <p:cNvSpPr txBox="1"/>
+          <p:nvPr/>
+        </p:nvSpPr>
+        <p:spPr>
+          <a:xfrm>
+            <a:off x="9500616" y="4434302"/>
             <a:ext cx="1097280" cy="248502"/>
           </a:xfrm>
           <a:prstGeom prst="rect">
@@ -6649,7 +7819,46 @@
       </p:sp>
       <p:sp>
         <p:nvSpPr>
-          <p:cNvPr id="126" name="Text 124"/>
+          <p:cNvPr id="156" name="Text 154"/>
+          <p:cNvSpPr txBox="1"/>
+          <p:nvPr/>
+        </p:nvSpPr>
+        <p:spPr>
+          <a:xfrm>
+            <a:off x="10597896" y="4434302"/>
+            <a:ext cx="868680" cy="248502"/>
+          </a:xfrm>
+          <a:prstGeom prst="rect">
+            <a:avLst/>
+          </a:prstGeom>
+          <a:noFill/>
+          <a:ln/>
+        </p:spPr>
+        <p:txBody>
+          <a:bodyPr wrap="square" lIns="0" tIns="0" rIns="0" bIns="0" rtlCol="0" anchor="ctr"/>
+          <a:lstStyle/>
+          <a:p>
+            <a:pPr algn="r" indent="0" marL="0">
+              <a:buNone/>
+            </a:pPr>
+            <a:r>
+              <a:rPr lang="en-US" sz="1300" dirty="0">
+                <a:solidFill>
+                  <a:srgbClr val="595959"/>
+                </a:solidFill>
+                <a:latin typeface="Inter" pitchFamily="34" charset="0"/>
+                <a:ea typeface="Inter" pitchFamily="34" charset="-122"/>
+                <a:cs typeface="Inter" pitchFamily="34" charset="-120"/>
+              </a:rPr>
+              <a:t>−1,708</a:t>
+            </a:r>
+            <a:endParaRPr lang="en-US" sz="1300" dirty="0"/>
+          </a:p>
+        </p:txBody>
+      </p:sp>
+      <p:sp>
+        <p:nvSpPr>
+          <p:cNvPr id="157" name="Text 155"/>
           <p:cNvSpPr txBox="1"/>
           <p:nvPr/>
         </p:nvSpPr>
@@ -6688,7 +7897,7 @@
       </p:sp>
       <p:sp>
         <p:nvSpPr>
-          <p:cNvPr id="127" name="Text 125"/>
+          <p:cNvPr id="158" name="Text 156"/>
           <p:cNvSpPr txBox="1"/>
           <p:nvPr/>
         </p:nvSpPr>
@@ -6727,14 +7936,14 @@
       </p:sp>
       <p:sp>
         <p:nvSpPr>
-          <p:cNvPr id="128" name="Shape 126"/>
+          <p:cNvPr id="159" name="Shape 157"/>
           <p:cNvSpPr/>
           <p:nvPr/>
         </p:nvSpPr>
         <p:spPr>
           <a:xfrm>
-            <a:off x="8959526" y="4738717"/>
-            <a:ext cx="391880" cy="136676"/>
+            <a:off x="8798077" y="4738717"/>
+            <a:ext cx="187327" cy="136676"/>
           </a:xfrm>
           <a:prstGeom prst="rect">
             <a:avLst/>
@@ -6747,13 +7956,13 @@
       </p:sp>
       <p:sp>
         <p:nvSpPr>
-          <p:cNvPr id="129" name="Text 127"/>
-          <p:cNvSpPr txBox="1"/>
-          <p:nvPr/>
-        </p:nvSpPr>
-        <p:spPr>
-          <a:xfrm>
-            <a:off x="10369296" y="4682804"/>
+          <p:cNvPr id="160" name="Text 158"/>
+          <p:cNvSpPr txBox="1"/>
+          <p:nvPr/>
+        </p:nvSpPr>
+        <p:spPr>
+          <a:xfrm>
+            <a:off x="9500616" y="4682804"/>
             <a:ext cx="1097280" cy="248502"/>
           </a:xfrm>
           <a:prstGeom prst="rect">
@@ -6786,7 +7995,46 @@
       </p:sp>
       <p:sp>
         <p:nvSpPr>
-          <p:cNvPr id="130" name="Text 128"/>
+          <p:cNvPr id="161" name="Text 159"/>
+          <p:cNvSpPr txBox="1"/>
+          <p:nvPr/>
+        </p:nvSpPr>
+        <p:spPr>
+          <a:xfrm>
+            <a:off x="10597896" y="4682804"/>
+            <a:ext cx="868680" cy="248502"/>
+          </a:xfrm>
+          <a:prstGeom prst="rect">
+            <a:avLst/>
+          </a:prstGeom>
+          <a:noFill/>
+          <a:ln/>
+        </p:spPr>
+        <p:txBody>
+          <a:bodyPr wrap="square" lIns="0" tIns="0" rIns="0" bIns="0" rtlCol="0" anchor="ctr"/>
+          <a:lstStyle/>
+          <a:p>
+            <a:pPr algn="r" indent="0" marL="0">
+              <a:buNone/>
+            </a:pPr>
+            <a:r>
+              <a:rPr lang="en-US" sz="1300" dirty="0">
+                <a:solidFill>
+                  <a:srgbClr val="595959"/>
+                </a:solidFill>
+                <a:latin typeface="Inter" pitchFamily="34" charset="0"/>
+                <a:ea typeface="Inter" pitchFamily="34" charset="-122"/>
+                <a:cs typeface="Inter" pitchFamily="34" charset="-120"/>
+              </a:rPr>
+              <a:t>−3,005</a:t>
+            </a:r>
+            <a:endParaRPr lang="en-US" sz="1300" dirty="0"/>
+          </a:p>
+        </p:txBody>
+      </p:sp>
+      <p:sp>
+        <p:nvSpPr>
+          <p:cNvPr id="162" name="Text 160"/>
           <p:cNvSpPr txBox="1"/>
           <p:nvPr/>
         </p:nvSpPr>
@@ -6825,7 +8073,7 @@
       </p:sp>
       <p:sp>
         <p:nvSpPr>
-          <p:cNvPr id="131" name="Text 129"/>
+          <p:cNvPr id="163" name="Text 161"/>
           <p:cNvSpPr txBox="1"/>
           <p:nvPr/>
         </p:nvSpPr>
@@ -6864,14 +8112,14 @@
       </p:sp>
       <p:sp>
         <p:nvSpPr>
-          <p:cNvPr id="132" name="Shape 130"/>
+          <p:cNvPr id="164" name="Shape 162"/>
           <p:cNvSpPr/>
           <p:nvPr/>
         </p:nvSpPr>
         <p:spPr>
           <a:xfrm>
-            <a:off x="8890482" y="4987218"/>
-            <a:ext cx="460924" cy="136676"/>
+            <a:off x="8765072" y="4987218"/>
+            <a:ext cx="220332" cy="136676"/>
           </a:xfrm>
           <a:prstGeom prst="rect">
             <a:avLst/>
@@ -6884,13 +8132,13 @@
       </p:sp>
       <p:sp>
         <p:nvSpPr>
-          <p:cNvPr id="133" name="Text 131"/>
-          <p:cNvSpPr txBox="1"/>
-          <p:nvPr/>
-        </p:nvSpPr>
-        <p:spPr>
-          <a:xfrm>
-            <a:off x="10369296" y="4931305"/>
+          <p:cNvPr id="165" name="Text 163"/>
+          <p:cNvSpPr txBox="1"/>
+          <p:nvPr/>
+        </p:nvSpPr>
+        <p:spPr>
+          <a:xfrm>
+            <a:off x="9500616" y="4931305"/>
             <a:ext cx="1097280" cy="248502"/>
           </a:xfrm>
           <a:prstGeom prst="rect">
@@ -6923,7 +8171,46 @@
       </p:sp>
       <p:sp>
         <p:nvSpPr>
-          <p:cNvPr id="134" name="Text 132"/>
+          <p:cNvPr id="166" name="Text 164"/>
+          <p:cNvSpPr txBox="1"/>
+          <p:nvPr/>
+        </p:nvSpPr>
+        <p:spPr>
+          <a:xfrm>
+            <a:off x="10597896" y="4931305"/>
+            <a:ext cx="868680" cy="248502"/>
+          </a:xfrm>
+          <a:prstGeom prst="rect">
+            <a:avLst/>
+          </a:prstGeom>
+          <a:noFill/>
+          <a:ln/>
+        </p:spPr>
+        <p:txBody>
+          <a:bodyPr wrap="square" lIns="0" tIns="0" rIns="0" bIns="0" rtlCol="0" anchor="ctr"/>
+          <a:lstStyle/>
+          <a:p>
+            <a:pPr algn="r" indent="0" marL="0">
+              <a:buNone/>
+            </a:pPr>
+            <a:r>
+              <a:rPr lang="en-US" sz="1300" dirty="0">
+                <a:solidFill>
+                  <a:srgbClr val="595959"/>
+                </a:solidFill>
+                <a:latin typeface="Inter" pitchFamily="34" charset="0"/>
+                <a:ea typeface="Inter" pitchFamily="34" charset="-122"/>
+                <a:cs typeface="Inter" pitchFamily="34" charset="-120"/>
+              </a:rPr>
+              <a:t>−3,494</a:t>
+            </a:r>
+            <a:endParaRPr lang="en-US" sz="1300" dirty="0"/>
+          </a:p>
+        </p:txBody>
+      </p:sp>
+      <p:sp>
+        <p:nvSpPr>
+          <p:cNvPr id="167" name="Text 165"/>
           <p:cNvSpPr txBox="1"/>
           <p:nvPr/>
         </p:nvSpPr>
@@ -6962,7 +8249,7 @@
       </p:sp>
       <p:sp>
         <p:nvSpPr>
-          <p:cNvPr id="135" name="Text 133"/>
+          <p:cNvPr id="168" name="Text 166"/>
           <p:cNvSpPr txBox="1"/>
           <p:nvPr/>
         </p:nvSpPr>
@@ -7001,14 +8288,14 @@
       </p:sp>
       <p:sp>
         <p:nvSpPr>
-          <p:cNvPr id="136" name="Shape 134"/>
+          <p:cNvPr id="169" name="Shape 167"/>
           <p:cNvSpPr/>
           <p:nvPr/>
         </p:nvSpPr>
         <p:spPr>
           <a:xfrm>
-            <a:off x="8735965" y="5235720"/>
-            <a:ext cx="615441" cy="136676"/>
+            <a:off x="8691210" y="5235720"/>
+            <a:ext cx="294194" cy="136676"/>
           </a:xfrm>
           <a:prstGeom prst="rect">
             <a:avLst/>
@@ -7021,13 +8308,13 @@
       </p:sp>
       <p:sp>
         <p:nvSpPr>
-          <p:cNvPr id="137" name="Text 135"/>
-          <p:cNvSpPr txBox="1"/>
-          <p:nvPr/>
-        </p:nvSpPr>
-        <p:spPr>
-          <a:xfrm>
-            <a:off x="10369296" y="5179807"/>
+          <p:cNvPr id="170" name="Text 168"/>
+          <p:cNvSpPr txBox="1"/>
+          <p:nvPr/>
+        </p:nvSpPr>
+        <p:spPr>
+          <a:xfrm>
+            <a:off x="9500616" y="5179807"/>
             <a:ext cx="1097280" cy="248502"/>
           </a:xfrm>
           <a:prstGeom prst="rect">
@@ -7060,7 +8347,46 @@
       </p:sp>
       <p:sp>
         <p:nvSpPr>
-          <p:cNvPr id="138" name="Text 136"/>
+          <p:cNvPr id="171" name="Text 169"/>
+          <p:cNvSpPr txBox="1"/>
+          <p:nvPr/>
+        </p:nvSpPr>
+        <p:spPr>
+          <a:xfrm>
+            <a:off x="10597896" y="5179807"/>
+            <a:ext cx="868680" cy="248502"/>
+          </a:xfrm>
+          <a:prstGeom prst="rect">
+            <a:avLst/>
+          </a:prstGeom>
+          <a:noFill/>
+          <a:ln/>
+        </p:spPr>
+        <p:txBody>
+          <a:bodyPr wrap="square" lIns="0" tIns="0" rIns="0" bIns="0" rtlCol="0" anchor="ctr"/>
+          <a:lstStyle/>
+          <a:p>
+            <a:pPr algn="r" indent="0" marL="0">
+              <a:buNone/>
+            </a:pPr>
+            <a:r>
+              <a:rPr lang="en-US" sz="1300" dirty="0">
+                <a:solidFill>
+                  <a:srgbClr val="595959"/>
+                </a:solidFill>
+                <a:latin typeface="Inter" pitchFamily="34" charset="0"/>
+                <a:ea typeface="Inter" pitchFamily="34" charset="-122"/>
+                <a:cs typeface="Inter" pitchFamily="34" charset="-120"/>
+              </a:rPr>
+              <a:t>−3,177</a:t>
+            </a:r>
+            <a:endParaRPr lang="en-US" sz="1300" dirty="0"/>
+          </a:p>
+        </p:txBody>
+      </p:sp>
+      <p:sp>
+        <p:nvSpPr>
+          <p:cNvPr id="172" name="Text 170"/>
           <p:cNvSpPr txBox="1"/>
           <p:nvPr/>
         </p:nvSpPr>
@@ -7099,7 +8425,7 @@
       </p:sp>
       <p:sp>
         <p:nvSpPr>
-          <p:cNvPr id="139" name="Text 137"/>
+          <p:cNvPr id="173" name="Text 171"/>
           <p:cNvSpPr txBox="1"/>
           <p:nvPr/>
         </p:nvSpPr>
@@ -7138,14 +8464,14 @@
       </p:sp>
       <p:sp>
         <p:nvSpPr>
-          <p:cNvPr id="140" name="Shape 138"/>
+          <p:cNvPr id="174" name="Shape 172"/>
           <p:cNvSpPr/>
           <p:nvPr/>
         </p:nvSpPr>
         <p:spPr>
           <a:xfrm>
             <a:off x="8650224" y="5484222"/>
-            <a:ext cx="701181" cy="136676"/>
+            <a:ext cx="335180" cy="136676"/>
           </a:xfrm>
           <a:prstGeom prst="rect">
             <a:avLst/>
@@ -7158,13 +8484,13 @@
       </p:sp>
       <p:sp>
         <p:nvSpPr>
-          <p:cNvPr id="141" name="Text 139"/>
-          <p:cNvSpPr txBox="1"/>
-          <p:nvPr/>
-        </p:nvSpPr>
-        <p:spPr>
-          <a:xfrm>
-            <a:off x="10369296" y="5428309"/>
+          <p:cNvPr id="175" name="Text 173"/>
+          <p:cNvSpPr txBox="1"/>
+          <p:nvPr/>
+        </p:nvSpPr>
+        <p:spPr>
+          <a:xfrm>
+            <a:off x="9500616" y="5428309"/>
             <a:ext cx="1097280" cy="248502"/>
           </a:xfrm>
           <a:prstGeom prst="rect">
@@ -7197,7 +8523,46 @@
       </p:sp>
       <p:sp>
         <p:nvSpPr>
-          <p:cNvPr id="142" name="Shape 140"/>
+          <p:cNvPr id="176" name="Text 174"/>
+          <p:cNvSpPr txBox="1"/>
+          <p:nvPr/>
+        </p:nvSpPr>
+        <p:spPr>
+          <a:xfrm>
+            <a:off x="10597896" y="5428309"/>
+            <a:ext cx="868680" cy="248502"/>
+          </a:xfrm>
+          <a:prstGeom prst="rect">
+            <a:avLst/>
+          </a:prstGeom>
+          <a:noFill/>
+          <a:ln/>
+        </p:spPr>
+        <p:txBody>
+          <a:bodyPr wrap="square" lIns="0" tIns="0" rIns="0" bIns="0" rtlCol="0" anchor="ctr"/>
+          <a:lstStyle/>
+          <a:p>
+            <a:pPr algn="r" indent="0" marL="0">
+              <a:buNone/>
+            </a:pPr>
+            <a:r>
+              <a:rPr lang="en-US" sz="1300" dirty="0">
+                <a:solidFill>
+                  <a:srgbClr val="595959"/>
+                </a:solidFill>
+                <a:latin typeface="Inter" pitchFamily="34" charset="0"/>
+                <a:ea typeface="Inter" pitchFamily="34" charset="-122"/>
+                <a:cs typeface="Inter" pitchFamily="34" charset="-120"/>
+              </a:rPr>
+              <a:t>−5,191</a:t>
+            </a:r>
+            <a:endParaRPr lang="en-US" sz="1300" dirty="0"/>
+          </a:p>
+        </p:txBody>
+      </p:sp>
+      <p:sp>
+        <p:nvSpPr>
+          <p:cNvPr id="177" name="Shape 175"/>
           <p:cNvSpPr/>
           <p:nvPr/>
         </p:nvSpPr>
@@ -7217,7 +8582,7 @@
       </p:sp>
       <p:sp>
         <p:nvSpPr>
-          <p:cNvPr id="143" name="Shape 141"/>
+          <p:cNvPr id="178" name="Shape 176"/>
           <p:cNvSpPr/>
           <p:nvPr/>
         </p:nvSpPr>
@@ -7237,7 +8602,7 @@
       </p:sp>
       <p:sp>
         <p:nvSpPr>
-          <p:cNvPr id="144" name="Text 142"/>
+          <p:cNvPr id="179" name="Text 177"/>
           <p:cNvSpPr txBox="1"/>
           <p:nvPr/>
         </p:nvSpPr>

</xml_diff>

<commit_message>
Variance by store: Missed before Opcodes; movers sparkline review (gross)
Co-Authored-By: Claude Opus 5.5 <noreply@anthropic.com>
Claude-Session: https://claude.ai/code/session_01Xa4nFVxuQGXmHARGph9WhS
</commit_message>
<xml_diff>
--- a/day2-deck/decks/Op Code Missed Opportunity - Review.pptx
+++ b/day2-deck/decks/Op Code Missed Opportunity - Review.pptx
@@ -2604,6 +2604,45 @@
         <p:spPr>
           <a:xfrm>
             <a:off x="4270248" y="1316736"/>
+            <a:ext cx="777240" cy="329184"/>
+          </a:xfrm>
+          <a:prstGeom prst="rect">
+            <a:avLst/>
+          </a:prstGeom>
+          <a:noFill/>
+          <a:ln/>
+        </p:spPr>
+        <p:txBody>
+          <a:bodyPr wrap="square" lIns="0" tIns="0" rIns="0" bIns="0" rtlCol="0" anchor="ctr"/>
+          <a:lstStyle/>
+          <a:p>
+            <a:pPr algn="r" indent="0" marL="0">
+              <a:buNone/>
+            </a:pPr>
+            <a:r>
+              <a:rPr lang="en-US" sz="1400" b="1" dirty="0">
+                <a:solidFill>
+                  <a:srgbClr val="595959"/>
+                </a:solidFill>
+                <a:latin typeface="Inter" pitchFamily="34" charset="0"/>
+                <a:ea typeface="Inter" pitchFamily="34" charset="-122"/>
+                <a:cs typeface="Inter" pitchFamily="34" charset="-120"/>
+              </a:rPr>
+              <a:t>Missed</a:t>
+            </a:r>
+            <a:endParaRPr lang="en-US" sz="1400" dirty="0"/>
+          </a:p>
+        </p:txBody>
+      </p:sp>
+      <p:sp>
+        <p:nvSpPr>
+          <p:cNvPr id="8" name="Text 6"/>
+          <p:cNvSpPr txBox="1"/>
+          <p:nvPr/>
+        </p:nvSpPr>
+        <p:spPr>
+          <a:xfrm>
+            <a:off x="5047488" y="1316736"/>
             <a:ext cx="868680" cy="329184"/>
           </a:xfrm>
           <a:prstGeom prst="rect">
@@ -2629,45 +2668,6 @@
                 <a:cs typeface="Inter" pitchFamily="34" charset="-120"/>
               </a:rPr>
               <a:t>Opcodes</a:t>
-            </a:r>
-            <a:endParaRPr lang="en-US" sz="1400" dirty="0"/>
-          </a:p>
-        </p:txBody>
-      </p:sp>
-      <p:sp>
-        <p:nvSpPr>
-          <p:cNvPr id="8" name="Text 6"/>
-          <p:cNvSpPr txBox="1"/>
-          <p:nvPr/>
-        </p:nvSpPr>
-        <p:spPr>
-          <a:xfrm>
-            <a:off x="5138928" y="1316736"/>
-            <a:ext cx="777240" cy="329184"/>
-          </a:xfrm>
-          <a:prstGeom prst="rect">
-            <a:avLst/>
-          </a:prstGeom>
-          <a:noFill/>
-          <a:ln/>
-        </p:spPr>
-        <p:txBody>
-          <a:bodyPr wrap="square" lIns="0" tIns="0" rIns="0" bIns="0" rtlCol="0" anchor="ctr"/>
-          <a:lstStyle/>
-          <a:p>
-            <a:pPr algn="r" indent="0" marL="0">
-              <a:buNone/>
-            </a:pPr>
-            <a:r>
-              <a:rPr lang="en-US" sz="1400" b="1" dirty="0">
-                <a:solidFill>
-                  <a:srgbClr val="595959"/>
-                </a:solidFill>
-                <a:latin typeface="Inter" pitchFamily="34" charset="0"/>
-                <a:ea typeface="Inter" pitchFamily="34" charset="-122"/>
-                <a:cs typeface="Inter" pitchFamily="34" charset="-120"/>
-              </a:rPr>
-              <a:t>Missed</a:t>
             </a:r>
             <a:endParaRPr lang="en-US" sz="1400" dirty="0"/>
           </a:p>
@@ -2741,6 +2741,45 @@
         <p:spPr>
           <a:xfrm>
             <a:off x="9820656" y="1316736"/>
+            <a:ext cx="777240" cy="329184"/>
+          </a:xfrm>
+          <a:prstGeom prst="rect">
+            <a:avLst/>
+          </a:prstGeom>
+          <a:noFill/>
+          <a:ln/>
+        </p:spPr>
+        <p:txBody>
+          <a:bodyPr wrap="square" lIns="0" tIns="0" rIns="0" bIns="0" rtlCol="0" anchor="ctr"/>
+          <a:lstStyle/>
+          <a:p>
+            <a:pPr algn="r" indent="0" marL="0">
+              <a:buNone/>
+            </a:pPr>
+            <a:r>
+              <a:rPr lang="en-US" sz="1400" b="1" dirty="0">
+                <a:solidFill>
+                  <a:srgbClr val="595959"/>
+                </a:solidFill>
+                <a:latin typeface="Inter" pitchFamily="34" charset="0"/>
+                <a:ea typeface="Inter" pitchFamily="34" charset="-122"/>
+                <a:cs typeface="Inter" pitchFamily="34" charset="-120"/>
+              </a:rPr>
+              <a:t>Missed</a:t>
+            </a:r>
+            <a:endParaRPr lang="en-US" sz="1400" dirty="0"/>
+          </a:p>
+        </p:txBody>
+      </p:sp>
+      <p:sp>
+        <p:nvSpPr>
+          <p:cNvPr id="12" name="Text 10"/>
+          <p:cNvSpPr txBox="1"/>
+          <p:nvPr/>
+        </p:nvSpPr>
+        <p:spPr>
+          <a:xfrm>
+            <a:off x="10597896" y="1316736"/>
             <a:ext cx="868680" cy="329184"/>
           </a:xfrm>
           <a:prstGeom prst="rect">
@@ -2766,45 +2805,6 @@
                 <a:cs typeface="Inter" pitchFamily="34" charset="-120"/>
               </a:rPr>
               <a:t>Opcodes</a:t>
-            </a:r>
-            <a:endParaRPr lang="en-US" sz="1400" dirty="0"/>
-          </a:p>
-        </p:txBody>
-      </p:sp>
-      <p:sp>
-        <p:nvSpPr>
-          <p:cNvPr id="12" name="Text 10"/>
-          <p:cNvSpPr txBox="1"/>
-          <p:nvPr/>
-        </p:nvSpPr>
-        <p:spPr>
-          <a:xfrm>
-            <a:off x="10689336" y="1316736"/>
-            <a:ext cx="777240" cy="329184"/>
-          </a:xfrm>
-          <a:prstGeom prst="rect">
-            <a:avLst/>
-          </a:prstGeom>
-          <a:noFill/>
-          <a:ln/>
-        </p:spPr>
-        <p:txBody>
-          <a:bodyPr wrap="square" lIns="0" tIns="0" rIns="0" bIns="0" rtlCol="0" anchor="ctr"/>
-          <a:lstStyle/>
-          <a:p>
-            <a:pPr algn="r" indent="0" marL="0">
-              <a:buNone/>
-            </a:pPr>
-            <a:r>
-              <a:rPr lang="en-US" sz="1400" b="1" dirty="0">
-                <a:solidFill>
-                  <a:srgbClr val="595959"/>
-                </a:solidFill>
-                <a:latin typeface="Inter" pitchFamily="34" charset="0"/>
-                <a:ea typeface="Inter" pitchFamily="34" charset="-122"/>
-                <a:cs typeface="Inter" pitchFamily="34" charset="-120"/>
-              </a:rPr>
-              <a:t>Missed</a:t>
             </a:r>
             <a:endParaRPr lang="en-US" sz="1400" dirty="0"/>
           </a:p>
@@ -2976,6 +2976,45 @@
         <p:spPr>
           <a:xfrm>
             <a:off x="4270248" y="1700784"/>
+            <a:ext cx="777240" cy="248502"/>
+          </a:xfrm>
+          <a:prstGeom prst="rect">
+            <a:avLst/>
+          </a:prstGeom>
+          <a:noFill/>
+          <a:ln/>
+        </p:spPr>
+        <p:txBody>
+          <a:bodyPr wrap="square" lIns="0" tIns="0" rIns="0" bIns="0" rtlCol="0" anchor="ctr"/>
+          <a:lstStyle/>
+          <a:p>
+            <a:pPr algn="r" indent="0" marL="0">
+              <a:buNone/>
+            </a:pPr>
+            <a:r>
+              <a:rPr lang="en-US" sz="1300" dirty="0">
+                <a:solidFill>
+                  <a:srgbClr val="595959"/>
+                </a:solidFill>
+                <a:latin typeface="Inter" pitchFamily="34" charset="0"/>
+                <a:ea typeface="Inter" pitchFamily="34" charset="-122"/>
+                <a:cs typeface="Inter" pitchFamily="34" charset="-120"/>
+              </a:rPr>
+              <a:t>0 of 4</a:t>
+            </a:r>
+            <a:endParaRPr lang="en-US" sz="1300" dirty="0"/>
+          </a:p>
+        </p:txBody>
+      </p:sp>
+      <p:sp>
+        <p:nvSpPr>
+          <p:cNvPr id="19" name="Text 17"/>
+          <p:cNvSpPr txBox="1"/>
+          <p:nvPr/>
+        </p:nvSpPr>
+        <p:spPr>
+          <a:xfrm>
+            <a:off x="5047488" y="1700784"/>
             <a:ext cx="868680" cy="248502"/>
           </a:xfrm>
           <a:prstGeom prst="rect">
@@ -3008,13 +3047,13 @@
       </p:sp>
       <p:sp>
         <p:nvSpPr>
-          <p:cNvPr id="19" name="Shape 17"/>
+          <p:cNvPr id="20" name="Shape 18"/>
           <p:cNvSpPr/>
           <p:nvPr/>
         </p:nvSpPr>
         <p:spPr>
           <a:xfrm>
-            <a:off x="5193792" y="1746504"/>
+            <a:off x="5971032" y="1746504"/>
             <a:ext cx="54864" cy="157062"/>
           </a:xfrm>
           <a:prstGeom prst="rect">
@@ -3028,45 +3067,6 @@
       </p:sp>
       <p:sp>
         <p:nvSpPr>
-          <p:cNvPr id="20" name="Text 18"/>
-          <p:cNvSpPr txBox="1"/>
-          <p:nvPr/>
-        </p:nvSpPr>
-        <p:spPr>
-          <a:xfrm>
-            <a:off x="5138928" y="1700784"/>
-            <a:ext cx="777240" cy="248502"/>
-          </a:xfrm>
-          <a:prstGeom prst="rect">
-            <a:avLst/>
-          </a:prstGeom>
-          <a:noFill/>
-          <a:ln/>
-        </p:spPr>
-        <p:txBody>
-          <a:bodyPr wrap="square" lIns="0" tIns="0" rIns="0" bIns="0" rtlCol="0" anchor="ctr"/>
-          <a:lstStyle/>
-          <a:p>
-            <a:pPr algn="r" indent="0" marL="0">
-              <a:buNone/>
-            </a:pPr>
-            <a:r>
-              <a:rPr lang="en-US" sz="1300" dirty="0">
-                <a:solidFill>
-                  <a:srgbClr val="595959"/>
-                </a:solidFill>
-                <a:latin typeface="Inter" pitchFamily="34" charset="0"/>
-                <a:ea typeface="Inter" pitchFamily="34" charset="-122"/>
-                <a:cs typeface="Inter" pitchFamily="34" charset="-120"/>
-              </a:rPr>
-              <a:t>0 of 4</a:t>
-            </a:r>
-            <a:endParaRPr lang="en-US" sz="1300" dirty="0"/>
-          </a:p>
-        </p:txBody>
-      </p:sp>
-      <p:sp>
-        <p:nvSpPr>
           <p:cNvPr id="21" name="Text 19"/>
           <p:cNvSpPr txBox="1"/>
           <p:nvPr/>
@@ -3211,6 +3211,45 @@
         <p:spPr>
           <a:xfrm>
             <a:off x="4270248" y="1949286"/>
+            <a:ext cx="777240" cy="248502"/>
+          </a:xfrm>
+          <a:prstGeom prst="rect">
+            <a:avLst/>
+          </a:prstGeom>
+          <a:noFill/>
+          <a:ln/>
+        </p:spPr>
+        <p:txBody>
+          <a:bodyPr wrap="square" lIns="0" tIns="0" rIns="0" bIns="0" rtlCol="0" anchor="ctr"/>
+          <a:lstStyle/>
+          <a:p>
+            <a:pPr algn="r" indent="0" marL="0">
+              <a:buNone/>
+            </a:pPr>
+            <a:r>
+              <a:rPr lang="en-US" sz="1300" dirty="0">
+                <a:solidFill>
+                  <a:srgbClr val="595959"/>
+                </a:solidFill>
+                <a:latin typeface="Inter" pitchFamily="34" charset="0"/>
+                <a:ea typeface="Inter" pitchFamily="34" charset="-122"/>
+                <a:cs typeface="Inter" pitchFamily="34" charset="-120"/>
+              </a:rPr>
+              <a:t>1 of 4</a:t>
+            </a:r>
+            <a:endParaRPr lang="en-US" sz="1300" dirty="0"/>
+          </a:p>
+        </p:txBody>
+      </p:sp>
+      <p:sp>
+        <p:nvSpPr>
+          <p:cNvPr id="26" name="Text 24"/>
+          <p:cNvSpPr txBox="1"/>
+          <p:nvPr/>
+        </p:nvSpPr>
+        <p:spPr>
+          <a:xfrm>
+            <a:off x="5047488" y="1949286"/>
             <a:ext cx="868680" cy="248502"/>
           </a:xfrm>
           <a:prstGeom prst="rect">
@@ -3243,13 +3282,13 @@
       </p:sp>
       <p:sp>
         <p:nvSpPr>
-          <p:cNvPr id="26" name="Shape 24"/>
+          <p:cNvPr id="27" name="Shape 25"/>
           <p:cNvSpPr/>
           <p:nvPr/>
         </p:nvSpPr>
         <p:spPr>
           <a:xfrm>
-            <a:off x="5193792" y="1995006"/>
+            <a:off x="5971032" y="1995006"/>
             <a:ext cx="54864" cy="157062"/>
           </a:xfrm>
           <a:prstGeom prst="rect">
@@ -3263,45 +3302,6 @@
       </p:sp>
       <p:sp>
         <p:nvSpPr>
-          <p:cNvPr id="27" name="Text 25"/>
-          <p:cNvSpPr txBox="1"/>
-          <p:nvPr/>
-        </p:nvSpPr>
-        <p:spPr>
-          <a:xfrm>
-            <a:off x="5138928" y="1949286"/>
-            <a:ext cx="777240" cy="248502"/>
-          </a:xfrm>
-          <a:prstGeom prst="rect">
-            <a:avLst/>
-          </a:prstGeom>
-          <a:noFill/>
-          <a:ln/>
-        </p:spPr>
-        <p:txBody>
-          <a:bodyPr wrap="square" lIns="0" tIns="0" rIns="0" bIns="0" rtlCol="0" anchor="ctr"/>
-          <a:lstStyle/>
-          <a:p>
-            <a:pPr algn="r" indent="0" marL="0">
-              <a:buNone/>
-            </a:pPr>
-            <a:r>
-              <a:rPr lang="en-US" sz="1300" dirty="0">
-                <a:solidFill>
-                  <a:srgbClr val="595959"/>
-                </a:solidFill>
-                <a:latin typeface="Inter" pitchFamily="34" charset="0"/>
-                <a:ea typeface="Inter" pitchFamily="34" charset="-122"/>
-                <a:cs typeface="Inter" pitchFamily="34" charset="-120"/>
-              </a:rPr>
-              <a:t>1 of 4</a:t>
-            </a:r>
-            <a:endParaRPr lang="en-US" sz="1300" dirty="0"/>
-          </a:p>
-        </p:txBody>
-      </p:sp>
-      <p:sp>
-        <p:nvSpPr>
           <p:cNvPr id="28" name="Text 26"/>
           <p:cNvSpPr txBox="1"/>
           <p:nvPr/>
@@ -3446,6 +3446,45 @@
         <p:spPr>
           <a:xfrm>
             <a:off x="4270248" y="2197787"/>
+            <a:ext cx="777240" cy="248502"/>
+          </a:xfrm>
+          <a:prstGeom prst="rect">
+            <a:avLst/>
+          </a:prstGeom>
+          <a:noFill/>
+          <a:ln/>
+        </p:spPr>
+        <p:txBody>
+          <a:bodyPr wrap="square" lIns="0" tIns="0" rIns="0" bIns="0" rtlCol="0" anchor="ctr"/>
+          <a:lstStyle/>
+          <a:p>
+            <a:pPr algn="r" indent="0" marL="0">
+              <a:buNone/>
+            </a:pPr>
+            <a:r>
+              <a:rPr lang="en-US" sz="1300" dirty="0">
+                <a:solidFill>
+                  <a:srgbClr val="595959"/>
+                </a:solidFill>
+                <a:latin typeface="Inter" pitchFamily="34" charset="0"/>
+                <a:ea typeface="Inter" pitchFamily="34" charset="-122"/>
+                <a:cs typeface="Inter" pitchFamily="34" charset="-120"/>
+              </a:rPr>
+              <a:t>1 of 4</a:t>
+            </a:r>
+            <a:endParaRPr lang="en-US" sz="1300" dirty="0"/>
+          </a:p>
+        </p:txBody>
+      </p:sp>
+      <p:sp>
+        <p:nvSpPr>
+          <p:cNvPr id="33" name="Text 31"/>
+          <p:cNvSpPr txBox="1"/>
+          <p:nvPr/>
+        </p:nvSpPr>
+        <p:spPr>
+          <a:xfrm>
+            <a:off x="5047488" y="2197787"/>
             <a:ext cx="868680" cy="248502"/>
           </a:xfrm>
           <a:prstGeom prst="rect">
@@ -3478,13 +3517,13 @@
       </p:sp>
       <p:sp>
         <p:nvSpPr>
-          <p:cNvPr id="33" name="Shape 31"/>
+          <p:cNvPr id="34" name="Shape 32"/>
           <p:cNvSpPr/>
           <p:nvPr/>
         </p:nvSpPr>
         <p:spPr>
           <a:xfrm>
-            <a:off x="5193792" y="2243507"/>
+            <a:off x="5971032" y="2243507"/>
             <a:ext cx="54864" cy="157062"/>
           </a:xfrm>
           <a:prstGeom prst="rect">
@@ -3498,45 +3537,6 @@
       </p:sp>
       <p:sp>
         <p:nvSpPr>
-          <p:cNvPr id="34" name="Text 32"/>
-          <p:cNvSpPr txBox="1"/>
-          <p:nvPr/>
-        </p:nvSpPr>
-        <p:spPr>
-          <a:xfrm>
-            <a:off x="5138928" y="2197787"/>
-            <a:ext cx="777240" cy="248502"/>
-          </a:xfrm>
-          <a:prstGeom prst="rect">
-            <a:avLst/>
-          </a:prstGeom>
-          <a:noFill/>
-          <a:ln/>
-        </p:spPr>
-        <p:txBody>
-          <a:bodyPr wrap="square" lIns="0" tIns="0" rIns="0" bIns="0" rtlCol="0" anchor="ctr"/>
-          <a:lstStyle/>
-          <a:p>
-            <a:pPr algn="r" indent="0" marL="0">
-              <a:buNone/>
-            </a:pPr>
-            <a:r>
-              <a:rPr lang="en-US" sz="1300" dirty="0">
-                <a:solidFill>
-                  <a:srgbClr val="595959"/>
-                </a:solidFill>
-                <a:latin typeface="Inter" pitchFamily="34" charset="0"/>
-                <a:ea typeface="Inter" pitchFamily="34" charset="-122"/>
-                <a:cs typeface="Inter" pitchFamily="34" charset="-120"/>
-              </a:rPr>
-              <a:t>1 of 4</a:t>
-            </a:r>
-            <a:endParaRPr lang="en-US" sz="1300" dirty="0"/>
-          </a:p>
-        </p:txBody>
-      </p:sp>
-      <p:sp>
-        <p:nvSpPr>
           <p:cNvPr id="35" name="Text 33"/>
           <p:cNvSpPr txBox="1"/>
           <p:nvPr/>
@@ -3681,6 +3681,45 @@
         <p:spPr>
           <a:xfrm>
             <a:off x="4270248" y="2446289"/>
+            <a:ext cx="777240" cy="248502"/>
+          </a:xfrm>
+          <a:prstGeom prst="rect">
+            <a:avLst/>
+          </a:prstGeom>
+          <a:noFill/>
+          <a:ln/>
+        </p:spPr>
+        <p:txBody>
+          <a:bodyPr wrap="square" lIns="0" tIns="0" rIns="0" bIns="0" rtlCol="0" anchor="ctr"/>
+          <a:lstStyle/>
+          <a:p>
+            <a:pPr algn="r" indent="0" marL="0">
+              <a:buNone/>
+            </a:pPr>
+            <a:r>
+              <a:rPr lang="en-US" sz="1300" dirty="0">
+                <a:solidFill>
+                  <a:srgbClr val="595959"/>
+                </a:solidFill>
+                <a:latin typeface="Inter" pitchFamily="34" charset="0"/>
+                <a:ea typeface="Inter" pitchFamily="34" charset="-122"/>
+                <a:cs typeface="Inter" pitchFamily="34" charset="-120"/>
+              </a:rPr>
+              <a:t>1 of 4</a:t>
+            </a:r>
+            <a:endParaRPr lang="en-US" sz="1300" dirty="0"/>
+          </a:p>
+        </p:txBody>
+      </p:sp>
+      <p:sp>
+        <p:nvSpPr>
+          <p:cNvPr id="40" name="Text 38"/>
+          <p:cNvSpPr txBox="1"/>
+          <p:nvPr/>
+        </p:nvSpPr>
+        <p:spPr>
+          <a:xfrm>
+            <a:off x="5047488" y="2446289"/>
             <a:ext cx="868680" cy="248502"/>
           </a:xfrm>
           <a:prstGeom prst="rect">
@@ -3706,45 +3745,6 @@
                 <a:cs typeface="Inter" pitchFamily="34" charset="-120"/>
               </a:rPr>
               <a:t>+70</a:t>
-            </a:r>
-            <a:endParaRPr lang="en-US" sz="1300" dirty="0"/>
-          </a:p>
-        </p:txBody>
-      </p:sp>
-      <p:sp>
-        <p:nvSpPr>
-          <p:cNvPr id="40" name="Text 38"/>
-          <p:cNvSpPr txBox="1"/>
-          <p:nvPr/>
-        </p:nvSpPr>
-        <p:spPr>
-          <a:xfrm>
-            <a:off x="5138928" y="2446289"/>
-            <a:ext cx="777240" cy="248502"/>
-          </a:xfrm>
-          <a:prstGeom prst="rect">
-            <a:avLst/>
-          </a:prstGeom>
-          <a:noFill/>
-          <a:ln/>
-        </p:spPr>
-        <p:txBody>
-          <a:bodyPr wrap="square" lIns="0" tIns="0" rIns="0" bIns="0" rtlCol="0" anchor="ctr"/>
-          <a:lstStyle/>
-          <a:p>
-            <a:pPr algn="r" indent="0" marL="0">
-              <a:buNone/>
-            </a:pPr>
-            <a:r>
-              <a:rPr lang="en-US" sz="1300" dirty="0">
-                <a:solidFill>
-                  <a:srgbClr val="595959"/>
-                </a:solidFill>
-                <a:latin typeface="Inter" pitchFamily="34" charset="0"/>
-                <a:ea typeface="Inter" pitchFamily="34" charset="-122"/>
-                <a:cs typeface="Inter" pitchFamily="34" charset="-120"/>
-              </a:rPr>
-              <a:t>1 of 4</a:t>
             </a:r>
             <a:endParaRPr lang="en-US" sz="1300" dirty="0"/>
           </a:p>
@@ -3896,6 +3896,45 @@
         <p:spPr>
           <a:xfrm>
             <a:off x="4270248" y="2694791"/>
+            <a:ext cx="777240" cy="248502"/>
+          </a:xfrm>
+          <a:prstGeom prst="rect">
+            <a:avLst/>
+          </a:prstGeom>
+          <a:noFill/>
+          <a:ln/>
+        </p:spPr>
+        <p:txBody>
+          <a:bodyPr wrap="square" lIns="0" tIns="0" rIns="0" bIns="0" rtlCol="0" anchor="ctr"/>
+          <a:lstStyle/>
+          <a:p>
+            <a:pPr algn="r" indent="0" marL="0">
+              <a:buNone/>
+            </a:pPr>
+            <a:r>
+              <a:rPr lang="en-US" sz="1300" dirty="0">
+                <a:solidFill>
+                  <a:srgbClr val="595959"/>
+                </a:solidFill>
+                <a:latin typeface="Inter" pitchFamily="34" charset="0"/>
+                <a:ea typeface="Inter" pitchFamily="34" charset="-122"/>
+                <a:cs typeface="Inter" pitchFamily="34" charset="-120"/>
+              </a:rPr>
+              <a:t>2 of 4</a:t>
+            </a:r>
+            <a:endParaRPr lang="en-US" sz="1300" dirty="0"/>
+          </a:p>
+        </p:txBody>
+      </p:sp>
+      <p:sp>
+        <p:nvSpPr>
+          <p:cNvPr id="46" name="Text 44"/>
+          <p:cNvSpPr txBox="1"/>
+          <p:nvPr/>
+        </p:nvSpPr>
+        <p:spPr>
+          <a:xfrm>
+            <a:off x="5047488" y="2694791"/>
             <a:ext cx="868680" cy="248502"/>
           </a:xfrm>
           <a:prstGeom prst="rect">
@@ -3921,45 +3960,6 @@
                 <a:cs typeface="Inter" pitchFamily="34" charset="-120"/>
               </a:rPr>
               <a:t>+24</a:t>
-            </a:r>
-            <a:endParaRPr lang="en-US" sz="1300" dirty="0"/>
-          </a:p>
-        </p:txBody>
-      </p:sp>
-      <p:sp>
-        <p:nvSpPr>
-          <p:cNvPr id="46" name="Text 44"/>
-          <p:cNvSpPr txBox="1"/>
-          <p:nvPr/>
-        </p:nvSpPr>
-        <p:spPr>
-          <a:xfrm>
-            <a:off x="5138928" y="2694791"/>
-            <a:ext cx="777240" cy="248502"/>
-          </a:xfrm>
-          <a:prstGeom prst="rect">
-            <a:avLst/>
-          </a:prstGeom>
-          <a:noFill/>
-          <a:ln/>
-        </p:spPr>
-        <p:txBody>
-          <a:bodyPr wrap="square" lIns="0" tIns="0" rIns="0" bIns="0" rtlCol="0" anchor="ctr"/>
-          <a:lstStyle/>
-          <a:p>
-            <a:pPr algn="r" indent="0" marL="0">
-              <a:buNone/>
-            </a:pPr>
-            <a:r>
-              <a:rPr lang="en-US" sz="1300" dirty="0">
-                <a:solidFill>
-                  <a:srgbClr val="595959"/>
-                </a:solidFill>
-                <a:latin typeface="Inter" pitchFamily="34" charset="0"/>
-                <a:ea typeface="Inter" pitchFamily="34" charset="-122"/>
-                <a:cs typeface="Inter" pitchFamily="34" charset="-120"/>
-              </a:rPr>
-              <a:t>2 of 4</a:t>
             </a:r>
             <a:endParaRPr lang="en-US" sz="1300" dirty="0"/>
           </a:p>
@@ -4111,6 +4111,45 @@
         <p:spPr>
           <a:xfrm>
             <a:off x="4270248" y="2943292"/>
+            <a:ext cx="777240" cy="248502"/>
+          </a:xfrm>
+          <a:prstGeom prst="rect">
+            <a:avLst/>
+          </a:prstGeom>
+          <a:noFill/>
+          <a:ln/>
+        </p:spPr>
+        <p:txBody>
+          <a:bodyPr wrap="square" lIns="0" tIns="0" rIns="0" bIns="0" rtlCol="0" anchor="ctr"/>
+          <a:lstStyle/>
+          <a:p>
+            <a:pPr algn="r" indent="0" marL="0">
+              <a:buNone/>
+            </a:pPr>
+            <a:r>
+              <a:rPr lang="en-US" sz="1300" dirty="0">
+                <a:solidFill>
+                  <a:srgbClr val="595959"/>
+                </a:solidFill>
+                <a:latin typeface="Inter" pitchFamily="34" charset="0"/>
+                <a:ea typeface="Inter" pitchFamily="34" charset="-122"/>
+                <a:cs typeface="Inter" pitchFamily="34" charset="-120"/>
+              </a:rPr>
+              <a:t>1 of 4</a:t>
+            </a:r>
+            <a:endParaRPr lang="en-US" sz="1300" dirty="0"/>
+          </a:p>
+        </p:txBody>
+      </p:sp>
+      <p:sp>
+        <p:nvSpPr>
+          <p:cNvPr id="52" name="Text 50"/>
+          <p:cNvSpPr txBox="1"/>
+          <p:nvPr/>
+        </p:nvSpPr>
+        <p:spPr>
+          <a:xfrm>
+            <a:off x="5047488" y="2943292"/>
             <a:ext cx="868680" cy="248502"/>
           </a:xfrm>
           <a:prstGeom prst="rect">
@@ -4136,45 +4175,6 @@
                 <a:cs typeface="Inter" pitchFamily="34" charset="-120"/>
               </a:rPr>
               <a:t>+228</a:t>
-            </a:r>
-            <a:endParaRPr lang="en-US" sz="1300" dirty="0"/>
-          </a:p>
-        </p:txBody>
-      </p:sp>
-      <p:sp>
-        <p:nvSpPr>
-          <p:cNvPr id="52" name="Text 50"/>
-          <p:cNvSpPr txBox="1"/>
-          <p:nvPr/>
-        </p:nvSpPr>
-        <p:spPr>
-          <a:xfrm>
-            <a:off x="5138928" y="2943292"/>
-            <a:ext cx="777240" cy="248502"/>
-          </a:xfrm>
-          <a:prstGeom prst="rect">
-            <a:avLst/>
-          </a:prstGeom>
-          <a:noFill/>
-          <a:ln/>
-        </p:spPr>
-        <p:txBody>
-          <a:bodyPr wrap="square" lIns="0" tIns="0" rIns="0" bIns="0" rtlCol="0" anchor="ctr"/>
-          <a:lstStyle/>
-          <a:p>
-            <a:pPr algn="r" indent="0" marL="0">
-              <a:buNone/>
-            </a:pPr>
-            <a:r>
-              <a:rPr lang="en-US" sz="1300" dirty="0">
-                <a:solidFill>
-                  <a:srgbClr val="595959"/>
-                </a:solidFill>
-                <a:latin typeface="Inter" pitchFamily="34" charset="0"/>
-                <a:ea typeface="Inter" pitchFamily="34" charset="-122"/>
-                <a:cs typeface="Inter" pitchFamily="34" charset="-120"/>
-              </a:rPr>
-              <a:t>1 of 4</a:t>
             </a:r>
             <a:endParaRPr lang="en-US" sz="1300" dirty="0"/>
           </a:p>
@@ -4326,6 +4326,45 @@
         <p:spPr>
           <a:xfrm>
             <a:off x="4270248" y="3191794"/>
+            <a:ext cx="777240" cy="248502"/>
+          </a:xfrm>
+          <a:prstGeom prst="rect">
+            <a:avLst/>
+          </a:prstGeom>
+          <a:noFill/>
+          <a:ln/>
+        </p:spPr>
+        <p:txBody>
+          <a:bodyPr wrap="square" lIns="0" tIns="0" rIns="0" bIns="0" rtlCol="0" anchor="ctr"/>
+          <a:lstStyle/>
+          <a:p>
+            <a:pPr algn="r" indent="0" marL="0">
+              <a:buNone/>
+            </a:pPr>
+            <a:r>
+              <a:rPr lang="en-US" sz="1300" dirty="0">
+                <a:solidFill>
+                  <a:srgbClr val="595959"/>
+                </a:solidFill>
+                <a:latin typeface="Inter" pitchFamily="34" charset="0"/>
+                <a:ea typeface="Inter" pitchFamily="34" charset="-122"/>
+                <a:cs typeface="Inter" pitchFamily="34" charset="-120"/>
+              </a:rPr>
+              <a:t>3 of 4</a:t>
+            </a:r>
+            <a:endParaRPr lang="en-US" sz="1300" dirty="0"/>
+          </a:p>
+        </p:txBody>
+      </p:sp>
+      <p:sp>
+        <p:nvSpPr>
+          <p:cNvPr id="58" name="Text 56"/>
+          <p:cNvSpPr txBox="1"/>
+          <p:nvPr/>
+        </p:nvSpPr>
+        <p:spPr>
+          <a:xfrm>
+            <a:off x="5047488" y="3191794"/>
             <a:ext cx="868680" cy="248502"/>
           </a:xfrm>
           <a:prstGeom prst="rect">
@@ -4351,45 +4390,6 @@
                 <a:cs typeface="Inter" pitchFamily="34" charset="-120"/>
               </a:rPr>
               <a:t>+97</a:t>
-            </a:r>
-            <a:endParaRPr lang="en-US" sz="1300" dirty="0"/>
-          </a:p>
-        </p:txBody>
-      </p:sp>
-      <p:sp>
-        <p:nvSpPr>
-          <p:cNvPr id="58" name="Text 56"/>
-          <p:cNvSpPr txBox="1"/>
-          <p:nvPr/>
-        </p:nvSpPr>
-        <p:spPr>
-          <a:xfrm>
-            <a:off x="5138928" y="3191794"/>
-            <a:ext cx="777240" cy="248502"/>
-          </a:xfrm>
-          <a:prstGeom prst="rect">
-            <a:avLst/>
-          </a:prstGeom>
-          <a:noFill/>
-          <a:ln/>
-        </p:spPr>
-        <p:txBody>
-          <a:bodyPr wrap="square" lIns="0" tIns="0" rIns="0" bIns="0" rtlCol="0" anchor="ctr"/>
-          <a:lstStyle/>
-          <a:p>
-            <a:pPr algn="r" indent="0" marL="0">
-              <a:buNone/>
-            </a:pPr>
-            <a:r>
-              <a:rPr lang="en-US" sz="1300" dirty="0">
-                <a:solidFill>
-                  <a:srgbClr val="595959"/>
-                </a:solidFill>
-                <a:latin typeface="Inter" pitchFamily="34" charset="0"/>
-                <a:ea typeface="Inter" pitchFamily="34" charset="-122"/>
-                <a:cs typeface="Inter" pitchFamily="34" charset="-120"/>
-              </a:rPr>
-              <a:t>3 of 4</a:t>
             </a:r>
             <a:endParaRPr lang="en-US" sz="1300" dirty="0"/>
           </a:p>
@@ -4541,6 +4541,45 @@
         <p:spPr>
           <a:xfrm>
             <a:off x="4270248" y="3440296"/>
+            <a:ext cx="777240" cy="248502"/>
+          </a:xfrm>
+          <a:prstGeom prst="rect">
+            <a:avLst/>
+          </a:prstGeom>
+          <a:noFill/>
+          <a:ln/>
+        </p:spPr>
+        <p:txBody>
+          <a:bodyPr wrap="square" lIns="0" tIns="0" rIns="0" bIns="0" rtlCol="0" anchor="ctr"/>
+          <a:lstStyle/>
+          <a:p>
+            <a:pPr algn="r" indent="0" marL="0">
+              <a:buNone/>
+            </a:pPr>
+            <a:r>
+              <a:rPr lang="en-US" sz="1300" dirty="0">
+                <a:solidFill>
+                  <a:srgbClr val="595959"/>
+                </a:solidFill>
+                <a:latin typeface="Inter" pitchFamily="34" charset="0"/>
+                <a:ea typeface="Inter" pitchFamily="34" charset="-122"/>
+                <a:cs typeface="Inter" pitchFamily="34" charset="-120"/>
+              </a:rPr>
+              <a:t>1 of 2</a:t>
+            </a:r>
+            <a:endParaRPr lang="en-US" sz="1300" dirty="0"/>
+          </a:p>
+        </p:txBody>
+      </p:sp>
+      <p:sp>
+        <p:nvSpPr>
+          <p:cNvPr id="64" name="Text 62"/>
+          <p:cNvSpPr txBox="1"/>
+          <p:nvPr/>
+        </p:nvSpPr>
+        <p:spPr>
+          <a:xfrm>
+            <a:off x="5047488" y="3440296"/>
             <a:ext cx="868680" cy="248502"/>
           </a:xfrm>
           <a:prstGeom prst="rect">
@@ -4566,45 +4605,6 @@
                 <a:cs typeface="Inter" pitchFamily="34" charset="-120"/>
               </a:rPr>
               <a:t>−661</a:t>
-            </a:r>
-            <a:endParaRPr lang="en-US" sz="1300" dirty="0"/>
-          </a:p>
-        </p:txBody>
-      </p:sp>
-      <p:sp>
-        <p:nvSpPr>
-          <p:cNvPr id="64" name="Text 62"/>
-          <p:cNvSpPr txBox="1"/>
-          <p:nvPr/>
-        </p:nvSpPr>
-        <p:spPr>
-          <a:xfrm>
-            <a:off x="5138928" y="3440296"/>
-            <a:ext cx="777240" cy="248502"/>
-          </a:xfrm>
-          <a:prstGeom prst="rect">
-            <a:avLst/>
-          </a:prstGeom>
-          <a:noFill/>
-          <a:ln/>
-        </p:spPr>
-        <p:txBody>
-          <a:bodyPr wrap="square" lIns="0" tIns="0" rIns="0" bIns="0" rtlCol="0" anchor="ctr"/>
-          <a:lstStyle/>
-          <a:p>
-            <a:pPr algn="r" indent="0" marL="0">
-              <a:buNone/>
-            </a:pPr>
-            <a:r>
-              <a:rPr lang="en-US" sz="1300" dirty="0">
-                <a:solidFill>
-                  <a:srgbClr val="595959"/>
-                </a:solidFill>
-                <a:latin typeface="Inter" pitchFamily="34" charset="0"/>
-                <a:ea typeface="Inter" pitchFamily="34" charset="-122"/>
-                <a:cs typeface="Inter" pitchFamily="34" charset="-120"/>
-              </a:rPr>
-              <a:t>1 of 2</a:t>
             </a:r>
             <a:endParaRPr lang="en-US" sz="1300" dirty="0"/>
           </a:p>
@@ -4756,6 +4756,45 @@
         <p:spPr>
           <a:xfrm>
             <a:off x="4270248" y="3688797"/>
+            <a:ext cx="777240" cy="248502"/>
+          </a:xfrm>
+          <a:prstGeom prst="rect">
+            <a:avLst/>
+          </a:prstGeom>
+          <a:noFill/>
+          <a:ln/>
+        </p:spPr>
+        <p:txBody>
+          <a:bodyPr wrap="square" lIns="0" tIns="0" rIns="0" bIns="0" rtlCol="0" anchor="ctr"/>
+          <a:lstStyle/>
+          <a:p>
+            <a:pPr algn="r" indent="0" marL="0">
+              <a:buNone/>
+            </a:pPr>
+            <a:r>
+              <a:rPr lang="en-US" sz="1300" dirty="0">
+                <a:solidFill>
+                  <a:srgbClr val="595959"/>
+                </a:solidFill>
+                <a:latin typeface="Inter" pitchFamily="34" charset="0"/>
+                <a:ea typeface="Inter" pitchFamily="34" charset="-122"/>
+                <a:cs typeface="Inter" pitchFamily="34" charset="-120"/>
+              </a:rPr>
+              <a:t>3 of 4</a:t>
+            </a:r>
+            <a:endParaRPr lang="en-US" sz="1300" dirty="0"/>
+          </a:p>
+        </p:txBody>
+      </p:sp>
+      <p:sp>
+        <p:nvSpPr>
+          <p:cNvPr id="70" name="Text 68"/>
+          <p:cNvSpPr txBox="1"/>
+          <p:nvPr/>
+        </p:nvSpPr>
+        <p:spPr>
+          <a:xfrm>
+            <a:off x="5047488" y="3688797"/>
             <a:ext cx="868680" cy="248502"/>
           </a:xfrm>
           <a:prstGeom prst="rect">
@@ -4781,45 +4820,6 @@
                 <a:cs typeface="Inter" pitchFamily="34" charset="-120"/>
               </a:rPr>
               <a:t>−223</a:t>
-            </a:r>
-            <a:endParaRPr lang="en-US" sz="1300" dirty="0"/>
-          </a:p>
-        </p:txBody>
-      </p:sp>
-      <p:sp>
-        <p:nvSpPr>
-          <p:cNvPr id="70" name="Text 68"/>
-          <p:cNvSpPr txBox="1"/>
-          <p:nvPr/>
-        </p:nvSpPr>
-        <p:spPr>
-          <a:xfrm>
-            <a:off x="5138928" y="3688797"/>
-            <a:ext cx="777240" cy="248502"/>
-          </a:xfrm>
-          <a:prstGeom prst="rect">
-            <a:avLst/>
-          </a:prstGeom>
-          <a:noFill/>
-          <a:ln/>
-        </p:spPr>
-        <p:txBody>
-          <a:bodyPr wrap="square" lIns="0" tIns="0" rIns="0" bIns="0" rtlCol="0" anchor="ctr"/>
-          <a:lstStyle/>
-          <a:p>
-            <a:pPr algn="r" indent="0" marL="0">
-              <a:buNone/>
-            </a:pPr>
-            <a:r>
-              <a:rPr lang="en-US" sz="1300" dirty="0">
-                <a:solidFill>
-                  <a:srgbClr val="595959"/>
-                </a:solidFill>
-                <a:latin typeface="Inter" pitchFamily="34" charset="0"/>
-                <a:ea typeface="Inter" pitchFamily="34" charset="-122"/>
-                <a:cs typeface="Inter" pitchFamily="34" charset="-120"/>
-              </a:rPr>
-              <a:t>3 of 4</a:t>
             </a:r>
             <a:endParaRPr lang="en-US" sz="1300" dirty="0"/>
           </a:p>
@@ -4971,6 +4971,45 @@
         <p:spPr>
           <a:xfrm>
             <a:off x="4270248" y="3937299"/>
+            <a:ext cx="777240" cy="248502"/>
+          </a:xfrm>
+          <a:prstGeom prst="rect">
+            <a:avLst/>
+          </a:prstGeom>
+          <a:noFill/>
+          <a:ln/>
+        </p:spPr>
+        <p:txBody>
+          <a:bodyPr wrap="square" lIns="0" tIns="0" rIns="0" bIns="0" rtlCol="0" anchor="ctr"/>
+          <a:lstStyle/>
+          <a:p>
+            <a:pPr algn="r" indent="0" marL="0">
+              <a:buNone/>
+            </a:pPr>
+            <a:r>
+              <a:rPr lang="en-US" sz="1300" dirty="0">
+                <a:solidFill>
+                  <a:srgbClr val="595959"/>
+                </a:solidFill>
+                <a:latin typeface="Inter" pitchFamily="34" charset="0"/>
+                <a:ea typeface="Inter" pitchFamily="34" charset="-122"/>
+                <a:cs typeface="Inter" pitchFamily="34" charset="-120"/>
+              </a:rPr>
+              <a:t>2 of 3</a:t>
+            </a:r>
+            <a:endParaRPr lang="en-US" sz="1300" dirty="0"/>
+          </a:p>
+        </p:txBody>
+      </p:sp>
+      <p:sp>
+        <p:nvSpPr>
+          <p:cNvPr id="76" name="Text 74"/>
+          <p:cNvSpPr txBox="1"/>
+          <p:nvPr/>
+        </p:nvSpPr>
+        <p:spPr>
+          <a:xfrm>
+            <a:off x="5047488" y="3937299"/>
             <a:ext cx="868680" cy="248502"/>
           </a:xfrm>
           <a:prstGeom prst="rect">
@@ -4996,45 +5035,6 @@
                 <a:cs typeface="Inter" pitchFamily="34" charset="-120"/>
               </a:rPr>
               <a:t>−340</a:t>
-            </a:r>
-            <a:endParaRPr lang="en-US" sz="1300" dirty="0"/>
-          </a:p>
-        </p:txBody>
-      </p:sp>
-      <p:sp>
-        <p:nvSpPr>
-          <p:cNvPr id="76" name="Text 74"/>
-          <p:cNvSpPr txBox="1"/>
-          <p:nvPr/>
-        </p:nvSpPr>
-        <p:spPr>
-          <a:xfrm>
-            <a:off x="5138928" y="3937299"/>
-            <a:ext cx="777240" cy="248502"/>
-          </a:xfrm>
-          <a:prstGeom prst="rect">
-            <a:avLst/>
-          </a:prstGeom>
-          <a:noFill/>
-          <a:ln/>
-        </p:spPr>
-        <p:txBody>
-          <a:bodyPr wrap="square" lIns="0" tIns="0" rIns="0" bIns="0" rtlCol="0" anchor="ctr"/>
-          <a:lstStyle/>
-          <a:p>
-            <a:pPr algn="r" indent="0" marL="0">
-              <a:buNone/>
-            </a:pPr>
-            <a:r>
-              <a:rPr lang="en-US" sz="1300" dirty="0">
-                <a:solidFill>
-                  <a:srgbClr val="595959"/>
-                </a:solidFill>
-                <a:latin typeface="Inter" pitchFamily="34" charset="0"/>
-                <a:ea typeface="Inter" pitchFamily="34" charset="-122"/>
-                <a:cs typeface="Inter" pitchFamily="34" charset="-120"/>
-              </a:rPr>
-              <a:t>2 of 3</a:t>
             </a:r>
             <a:endParaRPr lang="en-US" sz="1300" dirty="0"/>
           </a:p>
@@ -5186,6 +5186,45 @@
         <p:spPr>
           <a:xfrm>
             <a:off x="4270248" y="4185800"/>
+            <a:ext cx="777240" cy="248502"/>
+          </a:xfrm>
+          <a:prstGeom prst="rect">
+            <a:avLst/>
+          </a:prstGeom>
+          <a:noFill/>
+          <a:ln/>
+        </p:spPr>
+        <p:txBody>
+          <a:bodyPr wrap="square" lIns="0" tIns="0" rIns="0" bIns="0" rtlCol="0" anchor="ctr"/>
+          <a:lstStyle/>
+          <a:p>
+            <a:pPr algn="r" indent="0" marL="0">
+              <a:buNone/>
+            </a:pPr>
+            <a:r>
+              <a:rPr lang="en-US" sz="1300" dirty="0">
+                <a:solidFill>
+                  <a:srgbClr val="595959"/>
+                </a:solidFill>
+                <a:latin typeface="Inter" pitchFamily="34" charset="0"/>
+                <a:ea typeface="Inter" pitchFamily="34" charset="-122"/>
+                <a:cs typeface="Inter" pitchFamily="34" charset="-120"/>
+              </a:rPr>
+              <a:t>3 of 4</a:t>
+            </a:r>
+            <a:endParaRPr lang="en-US" sz="1300" dirty="0"/>
+          </a:p>
+        </p:txBody>
+      </p:sp>
+      <p:sp>
+        <p:nvSpPr>
+          <p:cNvPr id="82" name="Text 80"/>
+          <p:cNvSpPr txBox="1"/>
+          <p:nvPr/>
+        </p:nvSpPr>
+        <p:spPr>
+          <a:xfrm>
+            <a:off x="5047488" y="4185800"/>
             <a:ext cx="868680" cy="248502"/>
           </a:xfrm>
           <a:prstGeom prst="rect">
@@ -5211,45 +5250,6 @@
                 <a:cs typeface="Inter" pitchFamily="34" charset="-120"/>
               </a:rPr>
               <a:t>−83</a:t>
-            </a:r>
-            <a:endParaRPr lang="en-US" sz="1300" dirty="0"/>
-          </a:p>
-        </p:txBody>
-      </p:sp>
-      <p:sp>
-        <p:nvSpPr>
-          <p:cNvPr id="82" name="Text 80"/>
-          <p:cNvSpPr txBox="1"/>
-          <p:nvPr/>
-        </p:nvSpPr>
-        <p:spPr>
-          <a:xfrm>
-            <a:off x="5138928" y="4185800"/>
-            <a:ext cx="777240" cy="248502"/>
-          </a:xfrm>
-          <a:prstGeom prst="rect">
-            <a:avLst/>
-          </a:prstGeom>
-          <a:noFill/>
-          <a:ln/>
-        </p:spPr>
-        <p:txBody>
-          <a:bodyPr wrap="square" lIns="0" tIns="0" rIns="0" bIns="0" rtlCol="0" anchor="ctr"/>
-          <a:lstStyle/>
-          <a:p>
-            <a:pPr algn="r" indent="0" marL="0">
-              <a:buNone/>
-            </a:pPr>
-            <a:r>
-              <a:rPr lang="en-US" sz="1300" dirty="0">
-                <a:solidFill>
-                  <a:srgbClr val="595959"/>
-                </a:solidFill>
-                <a:latin typeface="Inter" pitchFamily="34" charset="0"/>
-                <a:ea typeface="Inter" pitchFamily="34" charset="-122"/>
-                <a:cs typeface="Inter" pitchFamily="34" charset="-120"/>
-              </a:rPr>
-              <a:t>3 of 4</a:t>
             </a:r>
             <a:endParaRPr lang="en-US" sz="1300" dirty="0"/>
           </a:p>
@@ -5401,6 +5401,45 @@
         <p:spPr>
           <a:xfrm>
             <a:off x="4270248" y="4434302"/>
+            <a:ext cx="777240" cy="248502"/>
+          </a:xfrm>
+          <a:prstGeom prst="rect">
+            <a:avLst/>
+          </a:prstGeom>
+          <a:noFill/>
+          <a:ln/>
+        </p:spPr>
+        <p:txBody>
+          <a:bodyPr wrap="square" lIns="0" tIns="0" rIns="0" bIns="0" rtlCol="0" anchor="ctr"/>
+          <a:lstStyle/>
+          <a:p>
+            <a:pPr algn="r" indent="0" marL="0">
+              <a:buNone/>
+            </a:pPr>
+            <a:r>
+              <a:rPr lang="en-US" sz="1300" dirty="0">
+                <a:solidFill>
+                  <a:srgbClr val="595959"/>
+                </a:solidFill>
+                <a:latin typeface="Inter" pitchFamily="34" charset="0"/>
+                <a:ea typeface="Inter" pitchFamily="34" charset="-122"/>
+                <a:cs typeface="Inter" pitchFamily="34" charset="-120"/>
+              </a:rPr>
+              <a:t>2 of 4</a:t>
+            </a:r>
+            <a:endParaRPr lang="en-US" sz="1300" dirty="0"/>
+          </a:p>
+        </p:txBody>
+      </p:sp>
+      <p:sp>
+        <p:nvSpPr>
+          <p:cNvPr id="88" name="Text 86"/>
+          <p:cNvSpPr txBox="1"/>
+          <p:nvPr/>
+        </p:nvSpPr>
+        <p:spPr>
+          <a:xfrm>
+            <a:off x="5047488" y="4434302"/>
             <a:ext cx="868680" cy="248502"/>
           </a:xfrm>
           <a:prstGeom prst="rect">
@@ -5426,45 +5465,6 @@
                 <a:cs typeface="Inter" pitchFamily="34" charset="-120"/>
               </a:rPr>
               <a:t>−452</a:t>
-            </a:r>
-            <a:endParaRPr lang="en-US" sz="1300" dirty="0"/>
-          </a:p>
-        </p:txBody>
-      </p:sp>
-      <p:sp>
-        <p:nvSpPr>
-          <p:cNvPr id="88" name="Text 86"/>
-          <p:cNvSpPr txBox="1"/>
-          <p:nvPr/>
-        </p:nvSpPr>
-        <p:spPr>
-          <a:xfrm>
-            <a:off x="5138928" y="4434302"/>
-            <a:ext cx="777240" cy="248502"/>
-          </a:xfrm>
-          <a:prstGeom prst="rect">
-            <a:avLst/>
-          </a:prstGeom>
-          <a:noFill/>
-          <a:ln/>
-        </p:spPr>
-        <p:txBody>
-          <a:bodyPr wrap="square" lIns="0" tIns="0" rIns="0" bIns="0" rtlCol="0" anchor="ctr"/>
-          <a:lstStyle/>
-          <a:p>
-            <a:pPr algn="r" indent="0" marL="0">
-              <a:buNone/>
-            </a:pPr>
-            <a:r>
-              <a:rPr lang="en-US" sz="1300" dirty="0">
-                <a:solidFill>
-                  <a:srgbClr val="595959"/>
-                </a:solidFill>
-                <a:latin typeface="Inter" pitchFamily="34" charset="0"/>
-                <a:ea typeface="Inter" pitchFamily="34" charset="-122"/>
-                <a:cs typeface="Inter" pitchFamily="34" charset="-120"/>
-              </a:rPr>
-              <a:t>2 of 4</a:t>
             </a:r>
             <a:endParaRPr lang="en-US" sz="1300" dirty="0"/>
           </a:p>
@@ -5616,6 +5616,45 @@
         <p:spPr>
           <a:xfrm>
             <a:off x="4270248" y="4682804"/>
+            <a:ext cx="777240" cy="248502"/>
+          </a:xfrm>
+          <a:prstGeom prst="rect">
+            <a:avLst/>
+          </a:prstGeom>
+          <a:noFill/>
+          <a:ln/>
+        </p:spPr>
+        <p:txBody>
+          <a:bodyPr wrap="square" lIns="0" tIns="0" rIns="0" bIns="0" rtlCol="0" anchor="ctr"/>
+          <a:lstStyle/>
+          <a:p>
+            <a:pPr algn="r" indent="0" marL="0">
+              <a:buNone/>
+            </a:pPr>
+            <a:r>
+              <a:rPr lang="en-US" sz="1300" dirty="0">
+                <a:solidFill>
+                  <a:srgbClr val="595959"/>
+                </a:solidFill>
+                <a:latin typeface="Inter" pitchFamily="34" charset="0"/>
+                <a:ea typeface="Inter" pitchFamily="34" charset="-122"/>
+                <a:cs typeface="Inter" pitchFamily="34" charset="-120"/>
+              </a:rPr>
+              <a:t>3 of 4</a:t>
+            </a:r>
+            <a:endParaRPr lang="en-US" sz="1300" dirty="0"/>
+          </a:p>
+        </p:txBody>
+      </p:sp>
+      <p:sp>
+        <p:nvSpPr>
+          <p:cNvPr id="94" name="Text 92"/>
+          <p:cNvSpPr txBox="1"/>
+          <p:nvPr/>
+        </p:nvSpPr>
+        <p:spPr>
+          <a:xfrm>
+            <a:off x="5047488" y="4682804"/>
             <a:ext cx="868680" cy="248502"/>
           </a:xfrm>
           <a:prstGeom prst="rect">
@@ -5641,45 +5680,6 @@
                 <a:cs typeface="Inter" pitchFamily="34" charset="-120"/>
               </a:rPr>
               <a:t>−569</a:t>
-            </a:r>
-            <a:endParaRPr lang="en-US" sz="1300" dirty="0"/>
-          </a:p>
-        </p:txBody>
-      </p:sp>
-      <p:sp>
-        <p:nvSpPr>
-          <p:cNvPr id="94" name="Text 92"/>
-          <p:cNvSpPr txBox="1"/>
-          <p:nvPr/>
-        </p:nvSpPr>
-        <p:spPr>
-          <a:xfrm>
-            <a:off x="5138928" y="4682804"/>
-            <a:ext cx="777240" cy="248502"/>
-          </a:xfrm>
-          <a:prstGeom prst="rect">
-            <a:avLst/>
-          </a:prstGeom>
-          <a:noFill/>
-          <a:ln/>
-        </p:spPr>
-        <p:txBody>
-          <a:bodyPr wrap="square" lIns="0" tIns="0" rIns="0" bIns="0" rtlCol="0" anchor="ctr"/>
-          <a:lstStyle/>
-          <a:p>
-            <a:pPr algn="r" indent="0" marL="0">
-              <a:buNone/>
-            </a:pPr>
-            <a:r>
-              <a:rPr lang="en-US" sz="1300" dirty="0">
-                <a:solidFill>
-                  <a:srgbClr val="595959"/>
-                </a:solidFill>
-                <a:latin typeface="Inter" pitchFamily="34" charset="0"/>
-                <a:ea typeface="Inter" pitchFamily="34" charset="-122"/>
-                <a:cs typeface="Inter" pitchFamily="34" charset="-120"/>
-              </a:rPr>
-              <a:t>3 of 4</a:t>
             </a:r>
             <a:endParaRPr lang="en-US" sz="1300" dirty="0"/>
           </a:p>
@@ -5831,6 +5831,45 @@
         <p:spPr>
           <a:xfrm>
             <a:off x="4270248" y="4931305"/>
+            <a:ext cx="777240" cy="248502"/>
+          </a:xfrm>
+          <a:prstGeom prst="rect">
+            <a:avLst/>
+          </a:prstGeom>
+          <a:noFill/>
+          <a:ln/>
+        </p:spPr>
+        <p:txBody>
+          <a:bodyPr wrap="square" lIns="0" tIns="0" rIns="0" bIns="0" rtlCol="0" anchor="ctr"/>
+          <a:lstStyle/>
+          <a:p>
+            <a:pPr algn="r" indent="0" marL="0">
+              <a:buNone/>
+            </a:pPr>
+            <a:r>
+              <a:rPr lang="en-US" sz="1300" dirty="0">
+                <a:solidFill>
+                  <a:srgbClr val="595959"/>
+                </a:solidFill>
+                <a:latin typeface="Inter" pitchFamily="34" charset="0"/>
+                <a:ea typeface="Inter" pitchFamily="34" charset="-122"/>
+                <a:cs typeface="Inter" pitchFamily="34" charset="-120"/>
+              </a:rPr>
+              <a:t>3 of 4</a:t>
+            </a:r>
+            <a:endParaRPr lang="en-US" sz="1300" dirty="0"/>
+          </a:p>
+        </p:txBody>
+      </p:sp>
+      <p:sp>
+        <p:nvSpPr>
+          <p:cNvPr id="100" name="Text 98"/>
+          <p:cNvSpPr txBox="1"/>
+          <p:nvPr/>
+        </p:nvSpPr>
+        <p:spPr>
+          <a:xfrm>
+            <a:off x="5047488" y="4931305"/>
             <a:ext cx="868680" cy="248502"/>
           </a:xfrm>
           <a:prstGeom prst="rect">
@@ -5856,45 +5895,6 @@
                 <a:cs typeface="Inter" pitchFamily="34" charset="-120"/>
               </a:rPr>
               <a:t>−660</a:t>
-            </a:r>
-            <a:endParaRPr lang="en-US" sz="1300" dirty="0"/>
-          </a:p>
-        </p:txBody>
-      </p:sp>
-      <p:sp>
-        <p:nvSpPr>
-          <p:cNvPr id="100" name="Text 98"/>
-          <p:cNvSpPr txBox="1"/>
-          <p:nvPr/>
-        </p:nvSpPr>
-        <p:spPr>
-          <a:xfrm>
-            <a:off x="5138928" y="4931305"/>
-            <a:ext cx="777240" cy="248502"/>
-          </a:xfrm>
-          <a:prstGeom prst="rect">
-            <a:avLst/>
-          </a:prstGeom>
-          <a:noFill/>
-          <a:ln/>
-        </p:spPr>
-        <p:txBody>
-          <a:bodyPr wrap="square" lIns="0" tIns="0" rIns="0" bIns="0" rtlCol="0" anchor="ctr"/>
-          <a:lstStyle/>
-          <a:p>
-            <a:pPr algn="r" indent="0" marL="0">
-              <a:buNone/>
-            </a:pPr>
-            <a:r>
-              <a:rPr lang="en-US" sz="1300" dirty="0">
-                <a:solidFill>
-                  <a:srgbClr val="595959"/>
-                </a:solidFill>
-                <a:latin typeface="Inter" pitchFamily="34" charset="0"/>
-                <a:ea typeface="Inter" pitchFamily="34" charset="-122"/>
-                <a:cs typeface="Inter" pitchFamily="34" charset="-120"/>
-              </a:rPr>
-              <a:t>3 of 4</a:t>
             </a:r>
             <a:endParaRPr lang="en-US" sz="1300" dirty="0"/>
           </a:p>
@@ -6046,6 +6046,45 @@
         <p:spPr>
           <a:xfrm>
             <a:off x="4270248" y="5179807"/>
+            <a:ext cx="777240" cy="248502"/>
+          </a:xfrm>
+          <a:prstGeom prst="rect">
+            <a:avLst/>
+          </a:prstGeom>
+          <a:noFill/>
+          <a:ln/>
+        </p:spPr>
+        <p:txBody>
+          <a:bodyPr wrap="square" lIns="0" tIns="0" rIns="0" bIns="0" rtlCol="0" anchor="ctr"/>
+          <a:lstStyle/>
+          <a:p>
+            <a:pPr algn="r" indent="0" marL="0">
+              <a:buNone/>
+            </a:pPr>
+            <a:r>
+              <a:rPr lang="en-US" sz="1300" dirty="0">
+                <a:solidFill>
+                  <a:srgbClr val="595959"/>
+                </a:solidFill>
+                <a:latin typeface="Inter" pitchFamily="34" charset="0"/>
+                <a:ea typeface="Inter" pitchFamily="34" charset="-122"/>
+                <a:cs typeface="Inter" pitchFamily="34" charset="-120"/>
+              </a:rPr>
+              <a:t>3 of 4</a:t>
+            </a:r>
+            <a:endParaRPr lang="en-US" sz="1300" dirty="0"/>
+          </a:p>
+        </p:txBody>
+      </p:sp>
+      <p:sp>
+        <p:nvSpPr>
+          <p:cNvPr id="106" name="Text 104"/>
+          <p:cNvSpPr txBox="1"/>
+          <p:nvPr/>
+        </p:nvSpPr>
+        <p:spPr>
+          <a:xfrm>
+            <a:off x="5047488" y="5179807"/>
             <a:ext cx="868680" cy="248502"/>
           </a:xfrm>
           <a:prstGeom prst="rect">
@@ -6071,45 +6110,6 @@
                 <a:cs typeface="Inter" pitchFamily="34" charset="-120"/>
               </a:rPr>
               <a:t>−783</a:t>
-            </a:r>
-            <a:endParaRPr lang="en-US" sz="1300" dirty="0"/>
-          </a:p>
-        </p:txBody>
-      </p:sp>
-      <p:sp>
-        <p:nvSpPr>
-          <p:cNvPr id="106" name="Text 104"/>
-          <p:cNvSpPr txBox="1"/>
-          <p:nvPr/>
-        </p:nvSpPr>
-        <p:spPr>
-          <a:xfrm>
-            <a:off x="5138928" y="5179807"/>
-            <a:ext cx="777240" cy="248502"/>
-          </a:xfrm>
-          <a:prstGeom prst="rect">
-            <a:avLst/>
-          </a:prstGeom>
-          <a:noFill/>
-          <a:ln/>
-        </p:spPr>
-        <p:txBody>
-          <a:bodyPr wrap="square" lIns="0" tIns="0" rIns="0" bIns="0" rtlCol="0" anchor="ctr"/>
-          <a:lstStyle/>
-          <a:p>
-            <a:pPr algn="r" indent="0" marL="0">
-              <a:buNone/>
-            </a:pPr>
-            <a:r>
-              <a:rPr lang="en-US" sz="1300" dirty="0">
-                <a:solidFill>
-                  <a:srgbClr val="595959"/>
-                </a:solidFill>
-                <a:latin typeface="Inter" pitchFamily="34" charset="0"/>
-                <a:ea typeface="Inter" pitchFamily="34" charset="-122"/>
-                <a:cs typeface="Inter" pitchFamily="34" charset="-120"/>
-              </a:rPr>
-              <a:t>3 of 4</a:t>
             </a:r>
             <a:endParaRPr lang="en-US" sz="1300" dirty="0"/>
           </a:p>
@@ -6261,6 +6261,45 @@
         <p:spPr>
           <a:xfrm>
             <a:off x="4270248" y="5428309"/>
+            <a:ext cx="777240" cy="248502"/>
+          </a:xfrm>
+          <a:prstGeom prst="rect">
+            <a:avLst/>
+          </a:prstGeom>
+          <a:noFill/>
+          <a:ln/>
+        </p:spPr>
+        <p:txBody>
+          <a:bodyPr wrap="square" lIns="0" tIns="0" rIns="0" bIns="0" rtlCol="0" anchor="ctr"/>
+          <a:lstStyle/>
+          <a:p>
+            <a:pPr algn="r" indent="0" marL="0">
+              <a:buNone/>
+            </a:pPr>
+            <a:r>
+              <a:rPr lang="en-US" sz="1300" dirty="0">
+                <a:solidFill>
+                  <a:srgbClr val="595959"/>
+                </a:solidFill>
+                <a:latin typeface="Inter" pitchFamily="34" charset="0"/>
+                <a:ea typeface="Inter" pitchFamily="34" charset="-122"/>
+                <a:cs typeface="Inter" pitchFamily="34" charset="-120"/>
+              </a:rPr>
+              <a:t>4 of 4</a:t>
+            </a:r>
+            <a:endParaRPr lang="en-US" sz="1300" dirty="0"/>
+          </a:p>
+        </p:txBody>
+      </p:sp>
+      <p:sp>
+        <p:nvSpPr>
+          <p:cNvPr id="112" name="Text 110"/>
+          <p:cNvSpPr txBox="1"/>
+          <p:nvPr/>
+        </p:nvSpPr>
+        <p:spPr>
+          <a:xfrm>
+            <a:off x="5047488" y="5428309"/>
             <a:ext cx="868680" cy="248502"/>
           </a:xfrm>
           <a:prstGeom prst="rect">
@@ -6286,45 +6325,6 @@
                 <a:cs typeface="Inter" pitchFamily="34" charset="-120"/>
               </a:rPr>
               <a:t>−568</a:t>
-            </a:r>
-            <a:endParaRPr lang="en-US" sz="1300" dirty="0"/>
-          </a:p>
-        </p:txBody>
-      </p:sp>
-      <p:sp>
-        <p:nvSpPr>
-          <p:cNvPr id="112" name="Text 110"/>
-          <p:cNvSpPr txBox="1"/>
-          <p:nvPr/>
-        </p:nvSpPr>
-        <p:spPr>
-          <a:xfrm>
-            <a:off x="5138928" y="5428309"/>
-            <a:ext cx="777240" cy="248502"/>
-          </a:xfrm>
-          <a:prstGeom prst="rect">
-            <a:avLst/>
-          </a:prstGeom>
-          <a:noFill/>
-          <a:ln/>
-        </p:spPr>
-        <p:txBody>
-          <a:bodyPr wrap="square" lIns="0" tIns="0" rIns="0" bIns="0" rtlCol="0" anchor="ctr"/>
-          <a:lstStyle/>
-          <a:p>
-            <a:pPr algn="r" indent="0" marL="0">
-              <a:buNone/>
-            </a:pPr>
-            <a:r>
-              <a:rPr lang="en-US" sz="1300" dirty="0">
-                <a:solidFill>
-                  <a:srgbClr val="595959"/>
-                </a:solidFill>
-                <a:latin typeface="Inter" pitchFamily="34" charset="0"/>
-                <a:ea typeface="Inter" pitchFamily="34" charset="-122"/>
-                <a:cs typeface="Inter" pitchFamily="34" charset="-120"/>
-              </a:rPr>
-              <a:t>4 of 4</a:t>
             </a:r>
             <a:endParaRPr lang="en-US" sz="1300" dirty="0"/>
           </a:p>
@@ -6476,6 +6476,45 @@
         <p:spPr>
           <a:xfrm>
             <a:off x="4270248" y="5676810"/>
+            <a:ext cx="777240" cy="248502"/>
+          </a:xfrm>
+          <a:prstGeom prst="rect">
+            <a:avLst/>
+          </a:prstGeom>
+          <a:noFill/>
+          <a:ln/>
+        </p:spPr>
+        <p:txBody>
+          <a:bodyPr wrap="square" lIns="0" tIns="0" rIns="0" bIns="0" rtlCol="0" anchor="ctr"/>
+          <a:lstStyle/>
+          <a:p>
+            <a:pPr algn="r" indent="0" marL="0">
+              <a:buNone/>
+            </a:pPr>
+            <a:r>
+              <a:rPr lang="en-US" sz="1300" dirty="0">
+                <a:solidFill>
+                  <a:srgbClr val="595959"/>
+                </a:solidFill>
+                <a:latin typeface="Inter" pitchFamily="34" charset="0"/>
+                <a:ea typeface="Inter" pitchFamily="34" charset="-122"/>
+                <a:cs typeface="Inter" pitchFamily="34" charset="-120"/>
+              </a:rPr>
+              <a:t>4 of 4</a:t>
+            </a:r>
+            <a:endParaRPr lang="en-US" sz="1300" dirty="0"/>
+          </a:p>
+        </p:txBody>
+      </p:sp>
+      <p:sp>
+        <p:nvSpPr>
+          <p:cNvPr id="118" name="Text 116"/>
+          <p:cNvSpPr txBox="1"/>
+          <p:nvPr/>
+        </p:nvSpPr>
+        <p:spPr>
+          <a:xfrm>
+            <a:off x="5047488" y="5676810"/>
             <a:ext cx="868680" cy="248502"/>
           </a:xfrm>
           <a:prstGeom prst="rect">
@@ -6501,45 +6540,6 @@
                 <a:cs typeface="Inter" pitchFamily="34" charset="-120"/>
               </a:rPr>
               <a:t>−697</a:t>
-            </a:r>
-            <a:endParaRPr lang="en-US" sz="1300" dirty="0"/>
-          </a:p>
-        </p:txBody>
-      </p:sp>
-      <p:sp>
-        <p:nvSpPr>
-          <p:cNvPr id="118" name="Text 116"/>
-          <p:cNvSpPr txBox="1"/>
-          <p:nvPr/>
-        </p:nvSpPr>
-        <p:spPr>
-          <a:xfrm>
-            <a:off x="5138928" y="5676810"/>
-            <a:ext cx="777240" cy="248502"/>
-          </a:xfrm>
-          <a:prstGeom prst="rect">
-            <a:avLst/>
-          </a:prstGeom>
-          <a:noFill/>
-          <a:ln/>
-        </p:spPr>
-        <p:txBody>
-          <a:bodyPr wrap="square" lIns="0" tIns="0" rIns="0" bIns="0" rtlCol="0" anchor="ctr"/>
-          <a:lstStyle/>
-          <a:p>
-            <a:pPr algn="r" indent="0" marL="0">
-              <a:buNone/>
-            </a:pPr>
-            <a:r>
-              <a:rPr lang="en-US" sz="1300" dirty="0">
-                <a:solidFill>
-                  <a:srgbClr val="595959"/>
-                </a:solidFill>
-                <a:latin typeface="Inter" pitchFamily="34" charset="0"/>
-                <a:ea typeface="Inter" pitchFamily="34" charset="-122"/>
-                <a:cs typeface="Inter" pitchFamily="34" charset="-120"/>
-              </a:rPr>
-              <a:t>4 of 4</a:t>
             </a:r>
             <a:endParaRPr lang="en-US" sz="1300" dirty="0"/>
           </a:p>
@@ -6691,6 +6691,45 @@
         <p:spPr>
           <a:xfrm>
             <a:off x="9820656" y="1700784"/>
+            <a:ext cx="777240" cy="248502"/>
+          </a:xfrm>
+          <a:prstGeom prst="rect">
+            <a:avLst/>
+          </a:prstGeom>
+          <a:noFill/>
+          <a:ln/>
+        </p:spPr>
+        <p:txBody>
+          <a:bodyPr wrap="square" lIns="0" tIns="0" rIns="0" bIns="0" rtlCol="0" anchor="ctr"/>
+          <a:lstStyle/>
+          <a:p>
+            <a:pPr algn="r" indent="0" marL="0">
+              <a:buNone/>
+            </a:pPr>
+            <a:r>
+              <a:rPr lang="en-US" sz="1300" dirty="0">
+                <a:solidFill>
+                  <a:srgbClr val="595959"/>
+                </a:solidFill>
+                <a:latin typeface="Inter" pitchFamily="34" charset="0"/>
+                <a:ea typeface="Inter" pitchFamily="34" charset="-122"/>
+                <a:cs typeface="Inter" pitchFamily="34" charset="-120"/>
+              </a:rPr>
+              <a:t>4 of 4</a:t>
+            </a:r>
+            <a:endParaRPr lang="en-US" sz="1300" dirty="0"/>
+          </a:p>
+        </p:txBody>
+      </p:sp>
+      <p:sp>
+        <p:nvSpPr>
+          <p:cNvPr id="124" name="Text 122"/>
+          <p:cNvSpPr txBox="1"/>
+          <p:nvPr/>
+        </p:nvSpPr>
+        <p:spPr>
+          <a:xfrm>
+            <a:off x="10597896" y="1700784"/>
             <a:ext cx="868680" cy="248502"/>
           </a:xfrm>
           <a:prstGeom prst="rect">
@@ -6716,45 +6755,6 @@
                 <a:cs typeface="Inter" pitchFamily="34" charset="-120"/>
               </a:rPr>
               <a:t>−640</a:t>
-            </a:r>
-            <a:endParaRPr lang="en-US" sz="1300" dirty="0"/>
-          </a:p>
-        </p:txBody>
-      </p:sp>
-      <p:sp>
-        <p:nvSpPr>
-          <p:cNvPr id="124" name="Text 122"/>
-          <p:cNvSpPr txBox="1"/>
-          <p:nvPr/>
-        </p:nvSpPr>
-        <p:spPr>
-          <a:xfrm>
-            <a:off x="10689336" y="1700784"/>
-            <a:ext cx="777240" cy="248502"/>
-          </a:xfrm>
-          <a:prstGeom prst="rect">
-            <a:avLst/>
-          </a:prstGeom>
-          <a:noFill/>
-          <a:ln/>
-        </p:spPr>
-        <p:txBody>
-          <a:bodyPr wrap="square" lIns="0" tIns="0" rIns="0" bIns="0" rtlCol="0" anchor="ctr"/>
-          <a:lstStyle/>
-          <a:p>
-            <a:pPr algn="r" indent="0" marL="0">
-              <a:buNone/>
-            </a:pPr>
-            <a:r>
-              <a:rPr lang="en-US" sz="1300" dirty="0">
-                <a:solidFill>
-                  <a:srgbClr val="595959"/>
-                </a:solidFill>
-                <a:latin typeface="Inter" pitchFamily="34" charset="0"/>
-                <a:ea typeface="Inter" pitchFamily="34" charset="-122"/>
-                <a:cs typeface="Inter" pitchFamily="34" charset="-120"/>
-              </a:rPr>
-              <a:t>4 of 4</a:t>
             </a:r>
             <a:endParaRPr lang="en-US" sz="1300" dirty="0"/>
           </a:p>
@@ -6906,6 +6906,45 @@
         <p:spPr>
           <a:xfrm>
             <a:off x="9820656" y="1949286"/>
+            <a:ext cx="777240" cy="248502"/>
+          </a:xfrm>
+          <a:prstGeom prst="rect">
+            <a:avLst/>
+          </a:prstGeom>
+          <a:noFill/>
+          <a:ln/>
+        </p:spPr>
+        <p:txBody>
+          <a:bodyPr wrap="square" lIns="0" tIns="0" rIns="0" bIns="0" rtlCol="0" anchor="ctr"/>
+          <a:lstStyle/>
+          <a:p>
+            <a:pPr algn="r" indent="0" marL="0">
+              <a:buNone/>
+            </a:pPr>
+            <a:r>
+              <a:rPr lang="en-US" sz="1300" dirty="0">
+                <a:solidFill>
+                  <a:srgbClr val="595959"/>
+                </a:solidFill>
+                <a:latin typeface="Inter" pitchFamily="34" charset="0"/>
+                <a:ea typeface="Inter" pitchFamily="34" charset="-122"/>
+                <a:cs typeface="Inter" pitchFamily="34" charset="-120"/>
+              </a:rPr>
+              <a:t>4 of 4</a:t>
+            </a:r>
+            <a:endParaRPr lang="en-US" sz="1300" dirty="0"/>
+          </a:p>
+        </p:txBody>
+      </p:sp>
+      <p:sp>
+        <p:nvSpPr>
+          <p:cNvPr id="130" name="Text 128"/>
+          <p:cNvSpPr txBox="1"/>
+          <p:nvPr/>
+        </p:nvSpPr>
+        <p:spPr>
+          <a:xfrm>
+            <a:off x="10597896" y="1949286"/>
             <a:ext cx="868680" cy="248502"/>
           </a:xfrm>
           <a:prstGeom prst="rect">
@@ -6931,45 +6970,6 @@
                 <a:cs typeface="Inter" pitchFamily="34" charset="-120"/>
               </a:rPr>
               <a:t>−954</a:t>
-            </a:r>
-            <a:endParaRPr lang="en-US" sz="1300" dirty="0"/>
-          </a:p>
-        </p:txBody>
-      </p:sp>
-      <p:sp>
-        <p:nvSpPr>
-          <p:cNvPr id="130" name="Text 128"/>
-          <p:cNvSpPr txBox="1"/>
-          <p:nvPr/>
-        </p:nvSpPr>
-        <p:spPr>
-          <a:xfrm>
-            <a:off x="10689336" y="1949286"/>
-            <a:ext cx="777240" cy="248502"/>
-          </a:xfrm>
-          <a:prstGeom prst="rect">
-            <a:avLst/>
-          </a:prstGeom>
-          <a:noFill/>
-          <a:ln/>
-        </p:spPr>
-        <p:txBody>
-          <a:bodyPr wrap="square" lIns="0" tIns="0" rIns="0" bIns="0" rtlCol="0" anchor="ctr"/>
-          <a:lstStyle/>
-          <a:p>
-            <a:pPr algn="r" indent="0" marL="0">
-              <a:buNone/>
-            </a:pPr>
-            <a:r>
-              <a:rPr lang="en-US" sz="1300" dirty="0">
-                <a:solidFill>
-                  <a:srgbClr val="595959"/>
-                </a:solidFill>
-                <a:latin typeface="Inter" pitchFamily="34" charset="0"/>
-                <a:ea typeface="Inter" pitchFamily="34" charset="-122"/>
-                <a:cs typeface="Inter" pitchFamily="34" charset="-120"/>
-              </a:rPr>
-              <a:t>4 of 4</a:t>
             </a:r>
             <a:endParaRPr lang="en-US" sz="1300" dirty="0"/>
           </a:p>
@@ -7121,6 +7121,45 @@
         <p:spPr>
           <a:xfrm>
             <a:off x="9820656" y="2197787"/>
+            <a:ext cx="777240" cy="248502"/>
+          </a:xfrm>
+          <a:prstGeom prst="rect">
+            <a:avLst/>
+          </a:prstGeom>
+          <a:noFill/>
+          <a:ln/>
+        </p:spPr>
+        <p:txBody>
+          <a:bodyPr wrap="square" lIns="0" tIns="0" rIns="0" bIns="0" rtlCol="0" anchor="ctr"/>
+          <a:lstStyle/>
+          <a:p>
+            <a:pPr algn="r" indent="0" marL="0">
+              <a:buNone/>
+            </a:pPr>
+            <a:r>
+              <a:rPr lang="en-US" sz="1300" dirty="0">
+                <a:solidFill>
+                  <a:srgbClr val="595959"/>
+                </a:solidFill>
+                <a:latin typeface="Inter" pitchFamily="34" charset="0"/>
+                <a:ea typeface="Inter" pitchFamily="34" charset="-122"/>
+                <a:cs typeface="Inter" pitchFamily="34" charset="-120"/>
+              </a:rPr>
+              <a:t>4 of 4</a:t>
+            </a:r>
+            <a:endParaRPr lang="en-US" sz="1300" dirty="0"/>
+          </a:p>
+        </p:txBody>
+      </p:sp>
+      <p:sp>
+        <p:nvSpPr>
+          <p:cNvPr id="136" name="Text 134"/>
+          <p:cNvSpPr txBox="1"/>
+          <p:nvPr/>
+        </p:nvSpPr>
+        <p:spPr>
+          <a:xfrm>
+            <a:off x="10597896" y="2197787"/>
             <a:ext cx="868680" cy="248502"/>
           </a:xfrm>
           <a:prstGeom prst="rect">
@@ -7146,45 +7185,6 @@
                 <a:cs typeface="Inter" pitchFamily="34" charset="-120"/>
               </a:rPr>
               <a:t>−1,100</a:t>
-            </a:r>
-            <a:endParaRPr lang="en-US" sz="1300" dirty="0"/>
-          </a:p>
-        </p:txBody>
-      </p:sp>
-      <p:sp>
-        <p:nvSpPr>
-          <p:cNvPr id="136" name="Text 134"/>
-          <p:cNvSpPr txBox="1"/>
-          <p:nvPr/>
-        </p:nvSpPr>
-        <p:spPr>
-          <a:xfrm>
-            <a:off x="10689336" y="2197787"/>
-            <a:ext cx="777240" cy="248502"/>
-          </a:xfrm>
-          <a:prstGeom prst="rect">
-            <a:avLst/>
-          </a:prstGeom>
-          <a:noFill/>
-          <a:ln/>
-        </p:spPr>
-        <p:txBody>
-          <a:bodyPr wrap="square" lIns="0" tIns="0" rIns="0" bIns="0" rtlCol="0" anchor="ctr"/>
-          <a:lstStyle/>
-          <a:p>
-            <a:pPr algn="r" indent="0" marL="0">
-              <a:buNone/>
-            </a:pPr>
-            <a:r>
-              <a:rPr lang="en-US" sz="1300" dirty="0">
-                <a:solidFill>
-                  <a:srgbClr val="595959"/>
-                </a:solidFill>
-                <a:latin typeface="Inter" pitchFamily="34" charset="0"/>
-                <a:ea typeface="Inter" pitchFamily="34" charset="-122"/>
-                <a:cs typeface="Inter" pitchFamily="34" charset="-120"/>
-              </a:rPr>
-              <a:t>4 of 4</a:t>
             </a:r>
             <a:endParaRPr lang="en-US" sz="1300" dirty="0"/>
           </a:p>
@@ -7336,6 +7336,45 @@
         <p:spPr>
           <a:xfrm>
             <a:off x="9820656" y="2446289"/>
+            <a:ext cx="777240" cy="248502"/>
+          </a:xfrm>
+          <a:prstGeom prst="rect">
+            <a:avLst/>
+          </a:prstGeom>
+          <a:noFill/>
+          <a:ln/>
+        </p:spPr>
+        <p:txBody>
+          <a:bodyPr wrap="square" lIns="0" tIns="0" rIns="0" bIns="0" rtlCol="0" anchor="ctr"/>
+          <a:lstStyle/>
+          <a:p>
+            <a:pPr algn="r" indent="0" marL="0">
+              <a:buNone/>
+            </a:pPr>
+            <a:r>
+              <a:rPr lang="en-US" sz="1300" dirty="0">
+                <a:solidFill>
+                  <a:srgbClr val="595959"/>
+                </a:solidFill>
+                <a:latin typeface="Inter" pitchFamily="34" charset="0"/>
+                <a:ea typeface="Inter" pitchFamily="34" charset="-122"/>
+                <a:cs typeface="Inter" pitchFamily="34" charset="-120"/>
+              </a:rPr>
+              <a:t>3 of 3</a:t>
+            </a:r>
+            <a:endParaRPr lang="en-US" sz="1300" dirty="0"/>
+          </a:p>
+        </p:txBody>
+      </p:sp>
+      <p:sp>
+        <p:nvSpPr>
+          <p:cNvPr id="142" name="Text 140"/>
+          <p:cNvSpPr txBox="1"/>
+          <p:nvPr/>
+        </p:nvSpPr>
+        <p:spPr>
+          <a:xfrm>
+            <a:off x="10597896" y="2446289"/>
             <a:ext cx="868680" cy="248502"/>
           </a:xfrm>
           <a:prstGeom prst="rect">
@@ -7361,45 +7400,6 @@
                 <a:cs typeface="Inter" pitchFamily="34" charset="-120"/>
               </a:rPr>
               <a:t>−827</a:t>
-            </a:r>
-            <a:endParaRPr lang="en-US" sz="1300" dirty="0"/>
-          </a:p>
-        </p:txBody>
-      </p:sp>
-      <p:sp>
-        <p:nvSpPr>
-          <p:cNvPr id="142" name="Text 140"/>
-          <p:cNvSpPr txBox="1"/>
-          <p:nvPr/>
-        </p:nvSpPr>
-        <p:spPr>
-          <a:xfrm>
-            <a:off x="10689336" y="2446289"/>
-            <a:ext cx="777240" cy="248502"/>
-          </a:xfrm>
-          <a:prstGeom prst="rect">
-            <a:avLst/>
-          </a:prstGeom>
-          <a:noFill/>
-          <a:ln/>
-        </p:spPr>
-        <p:txBody>
-          <a:bodyPr wrap="square" lIns="0" tIns="0" rIns="0" bIns="0" rtlCol="0" anchor="ctr"/>
-          <a:lstStyle/>
-          <a:p>
-            <a:pPr algn="r" indent="0" marL="0">
-              <a:buNone/>
-            </a:pPr>
-            <a:r>
-              <a:rPr lang="en-US" sz="1300" dirty="0">
-                <a:solidFill>
-                  <a:srgbClr val="595959"/>
-                </a:solidFill>
-                <a:latin typeface="Inter" pitchFamily="34" charset="0"/>
-                <a:ea typeface="Inter" pitchFamily="34" charset="-122"/>
-                <a:cs typeface="Inter" pitchFamily="34" charset="-120"/>
-              </a:rPr>
-              <a:t>3 of 3</a:t>
             </a:r>
             <a:endParaRPr lang="en-US" sz="1300" dirty="0"/>
           </a:p>
@@ -7551,6 +7551,45 @@
         <p:spPr>
           <a:xfrm>
             <a:off x="9820656" y="2694791"/>
+            <a:ext cx="777240" cy="248502"/>
+          </a:xfrm>
+          <a:prstGeom prst="rect">
+            <a:avLst/>
+          </a:prstGeom>
+          <a:noFill/>
+          <a:ln/>
+        </p:spPr>
+        <p:txBody>
+          <a:bodyPr wrap="square" lIns="0" tIns="0" rIns="0" bIns="0" rtlCol="0" anchor="ctr"/>
+          <a:lstStyle/>
+          <a:p>
+            <a:pPr algn="r" indent="0" marL="0">
+              <a:buNone/>
+            </a:pPr>
+            <a:r>
+              <a:rPr lang="en-US" sz="1300" dirty="0">
+                <a:solidFill>
+                  <a:srgbClr val="595959"/>
+                </a:solidFill>
+                <a:latin typeface="Inter" pitchFamily="34" charset="0"/>
+                <a:ea typeface="Inter" pitchFamily="34" charset="-122"/>
+                <a:cs typeface="Inter" pitchFamily="34" charset="-120"/>
+              </a:rPr>
+              <a:t>4 of 4</a:t>
+            </a:r>
+            <a:endParaRPr lang="en-US" sz="1300" dirty="0"/>
+          </a:p>
+        </p:txBody>
+      </p:sp>
+      <p:sp>
+        <p:nvSpPr>
+          <p:cNvPr id="148" name="Text 146"/>
+          <p:cNvSpPr txBox="1"/>
+          <p:nvPr/>
+        </p:nvSpPr>
+        <p:spPr>
+          <a:xfrm>
+            <a:off x="10597896" y="2694791"/>
             <a:ext cx="868680" cy="248502"/>
           </a:xfrm>
           <a:prstGeom prst="rect">
@@ -7576,45 +7615,6 @@
                 <a:cs typeface="Inter" pitchFamily="34" charset="-120"/>
               </a:rPr>
               <a:t>−1,068</a:t>
-            </a:r>
-            <a:endParaRPr lang="en-US" sz="1300" dirty="0"/>
-          </a:p>
-        </p:txBody>
-      </p:sp>
-      <p:sp>
-        <p:nvSpPr>
-          <p:cNvPr id="148" name="Text 146"/>
-          <p:cNvSpPr txBox="1"/>
-          <p:nvPr/>
-        </p:nvSpPr>
-        <p:spPr>
-          <a:xfrm>
-            <a:off x="10689336" y="2694791"/>
-            <a:ext cx="777240" cy="248502"/>
-          </a:xfrm>
-          <a:prstGeom prst="rect">
-            <a:avLst/>
-          </a:prstGeom>
-          <a:noFill/>
-          <a:ln/>
-        </p:spPr>
-        <p:txBody>
-          <a:bodyPr wrap="square" lIns="0" tIns="0" rIns="0" bIns="0" rtlCol="0" anchor="ctr"/>
-          <a:lstStyle/>
-          <a:p>
-            <a:pPr algn="r" indent="0" marL="0">
-              <a:buNone/>
-            </a:pPr>
-            <a:r>
-              <a:rPr lang="en-US" sz="1300" dirty="0">
-                <a:solidFill>
-                  <a:srgbClr val="595959"/>
-                </a:solidFill>
-                <a:latin typeface="Inter" pitchFamily="34" charset="0"/>
-                <a:ea typeface="Inter" pitchFamily="34" charset="-122"/>
-                <a:cs typeface="Inter" pitchFamily="34" charset="-120"/>
-              </a:rPr>
-              <a:t>4 of 4</a:t>
             </a:r>
             <a:endParaRPr lang="en-US" sz="1300" dirty="0"/>
           </a:p>
@@ -7766,6 +7766,45 @@
         <p:spPr>
           <a:xfrm>
             <a:off x="9820656" y="2943292"/>
+            <a:ext cx="777240" cy="248502"/>
+          </a:xfrm>
+          <a:prstGeom prst="rect">
+            <a:avLst/>
+          </a:prstGeom>
+          <a:noFill/>
+          <a:ln/>
+        </p:spPr>
+        <p:txBody>
+          <a:bodyPr wrap="square" lIns="0" tIns="0" rIns="0" bIns="0" rtlCol="0" anchor="ctr"/>
+          <a:lstStyle/>
+          <a:p>
+            <a:pPr algn="r" indent="0" marL="0">
+              <a:buNone/>
+            </a:pPr>
+            <a:r>
+              <a:rPr lang="en-US" sz="1300" dirty="0">
+                <a:solidFill>
+                  <a:srgbClr val="595959"/>
+                </a:solidFill>
+                <a:latin typeface="Inter" pitchFamily="34" charset="0"/>
+                <a:ea typeface="Inter" pitchFamily="34" charset="-122"/>
+                <a:cs typeface="Inter" pitchFamily="34" charset="-120"/>
+              </a:rPr>
+              <a:t>3 of 4</a:t>
+            </a:r>
+            <a:endParaRPr lang="en-US" sz="1300" dirty="0"/>
+          </a:p>
+        </p:txBody>
+      </p:sp>
+      <p:sp>
+        <p:nvSpPr>
+          <p:cNvPr id="154" name="Text 152"/>
+          <p:cNvSpPr txBox="1"/>
+          <p:nvPr/>
+        </p:nvSpPr>
+        <p:spPr>
+          <a:xfrm>
+            <a:off x="10597896" y="2943292"/>
             <a:ext cx="868680" cy="248502"/>
           </a:xfrm>
           <a:prstGeom prst="rect">
@@ -7791,45 +7830,6 @@
                 <a:cs typeface="Inter" pitchFamily="34" charset="-120"/>
               </a:rPr>
               <a:t>−1,717</a:t>
-            </a:r>
-            <a:endParaRPr lang="en-US" sz="1300" dirty="0"/>
-          </a:p>
-        </p:txBody>
-      </p:sp>
-      <p:sp>
-        <p:nvSpPr>
-          <p:cNvPr id="154" name="Text 152"/>
-          <p:cNvSpPr txBox="1"/>
-          <p:nvPr/>
-        </p:nvSpPr>
-        <p:spPr>
-          <a:xfrm>
-            <a:off x="10689336" y="2943292"/>
-            <a:ext cx="777240" cy="248502"/>
-          </a:xfrm>
-          <a:prstGeom prst="rect">
-            <a:avLst/>
-          </a:prstGeom>
-          <a:noFill/>
-          <a:ln/>
-        </p:spPr>
-        <p:txBody>
-          <a:bodyPr wrap="square" lIns="0" tIns="0" rIns="0" bIns="0" rtlCol="0" anchor="ctr"/>
-          <a:lstStyle/>
-          <a:p>
-            <a:pPr algn="r" indent="0" marL="0">
-              <a:buNone/>
-            </a:pPr>
-            <a:r>
-              <a:rPr lang="en-US" sz="1300" dirty="0">
-                <a:solidFill>
-                  <a:srgbClr val="595959"/>
-                </a:solidFill>
-                <a:latin typeface="Inter" pitchFamily="34" charset="0"/>
-                <a:ea typeface="Inter" pitchFamily="34" charset="-122"/>
-                <a:cs typeface="Inter" pitchFamily="34" charset="-120"/>
-              </a:rPr>
-              <a:t>3 of 4</a:t>
             </a:r>
             <a:endParaRPr lang="en-US" sz="1300" dirty="0"/>
           </a:p>
@@ -7981,6 +7981,45 @@
         <p:spPr>
           <a:xfrm>
             <a:off x="9820656" y="3191794"/>
+            <a:ext cx="777240" cy="248502"/>
+          </a:xfrm>
+          <a:prstGeom prst="rect">
+            <a:avLst/>
+          </a:prstGeom>
+          <a:noFill/>
+          <a:ln/>
+        </p:spPr>
+        <p:txBody>
+          <a:bodyPr wrap="square" lIns="0" tIns="0" rIns="0" bIns="0" rtlCol="0" anchor="ctr"/>
+          <a:lstStyle/>
+          <a:p>
+            <a:pPr algn="r" indent="0" marL="0">
+              <a:buNone/>
+            </a:pPr>
+            <a:r>
+              <a:rPr lang="en-US" sz="1300" dirty="0">
+                <a:solidFill>
+                  <a:srgbClr val="595959"/>
+                </a:solidFill>
+                <a:latin typeface="Inter" pitchFamily="34" charset="0"/>
+                <a:ea typeface="Inter" pitchFamily="34" charset="-122"/>
+                <a:cs typeface="Inter" pitchFamily="34" charset="-120"/>
+              </a:rPr>
+              <a:t>3 of 4</a:t>
+            </a:r>
+            <a:endParaRPr lang="en-US" sz="1300" dirty="0"/>
+          </a:p>
+        </p:txBody>
+      </p:sp>
+      <p:sp>
+        <p:nvSpPr>
+          <p:cNvPr id="160" name="Text 158"/>
+          <p:cNvSpPr txBox="1"/>
+          <p:nvPr/>
+        </p:nvSpPr>
+        <p:spPr>
+          <a:xfrm>
+            <a:off x="10597896" y="3191794"/>
             <a:ext cx="868680" cy="248502"/>
           </a:xfrm>
           <a:prstGeom prst="rect">
@@ -8006,45 +8045,6 @@
                 <a:cs typeface="Inter" pitchFamily="34" charset="-120"/>
               </a:rPr>
               <a:t>−1,613</a:t>
-            </a:r>
-            <a:endParaRPr lang="en-US" sz="1300" dirty="0"/>
-          </a:p>
-        </p:txBody>
-      </p:sp>
-      <p:sp>
-        <p:nvSpPr>
-          <p:cNvPr id="160" name="Text 158"/>
-          <p:cNvSpPr txBox="1"/>
-          <p:nvPr/>
-        </p:nvSpPr>
-        <p:spPr>
-          <a:xfrm>
-            <a:off x="10689336" y="3191794"/>
-            <a:ext cx="777240" cy="248502"/>
-          </a:xfrm>
-          <a:prstGeom prst="rect">
-            <a:avLst/>
-          </a:prstGeom>
-          <a:noFill/>
-          <a:ln/>
-        </p:spPr>
-        <p:txBody>
-          <a:bodyPr wrap="square" lIns="0" tIns="0" rIns="0" bIns="0" rtlCol="0" anchor="ctr"/>
-          <a:lstStyle/>
-          <a:p>
-            <a:pPr algn="r" indent="0" marL="0">
-              <a:buNone/>
-            </a:pPr>
-            <a:r>
-              <a:rPr lang="en-US" sz="1300" dirty="0">
-                <a:solidFill>
-                  <a:srgbClr val="595959"/>
-                </a:solidFill>
-                <a:latin typeface="Inter" pitchFamily="34" charset="0"/>
-                <a:ea typeface="Inter" pitchFamily="34" charset="-122"/>
-                <a:cs typeface="Inter" pitchFamily="34" charset="-120"/>
-              </a:rPr>
-              <a:t>3 of 4</a:t>
             </a:r>
             <a:endParaRPr lang="en-US" sz="1300" dirty="0"/>
           </a:p>
@@ -8196,6 +8196,45 @@
         <p:spPr>
           <a:xfrm>
             <a:off x="9820656" y="3440296"/>
+            <a:ext cx="777240" cy="248502"/>
+          </a:xfrm>
+          <a:prstGeom prst="rect">
+            <a:avLst/>
+          </a:prstGeom>
+          <a:noFill/>
+          <a:ln/>
+        </p:spPr>
+        <p:txBody>
+          <a:bodyPr wrap="square" lIns="0" tIns="0" rIns="0" bIns="0" rtlCol="0" anchor="ctr"/>
+          <a:lstStyle/>
+          <a:p>
+            <a:pPr algn="r" indent="0" marL="0">
+              <a:buNone/>
+            </a:pPr>
+            <a:r>
+              <a:rPr lang="en-US" sz="1300" dirty="0">
+                <a:solidFill>
+                  <a:srgbClr val="595959"/>
+                </a:solidFill>
+                <a:latin typeface="Inter" pitchFamily="34" charset="0"/>
+                <a:ea typeface="Inter" pitchFamily="34" charset="-122"/>
+                <a:cs typeface="Inter" pitchFamily="34" charset="-120"/>
+              </a:rPr>
+              <a:t>4 of 4</a:t>
+            </a:r>
+            <a:endParaRPr lang="en-US" sz="1300" dirty="0"/>
+          </a:p>
+        </p:txBody>
+      </p:sp>
+      <p:sp>
+        <p:nvSpPr>
+          <p:cNvPr id="166" name="Text 164"/>
+          <p:cNvSpPr txBox="1"/>
+          <p:nvPr/>
+        </p:nvSpPr>
+        <p:spPr>
+          <a:xfrm>
+            <a:off x="10597896" y="3440296"/>
             <a:ext cx="868680" cy="248502"/>
           </a:xfrm>
           <a:prstGeom prst="rect">
@@ -8221,45 +8260,6 @@
                 <a:cs typeface="Inter" pitchFamily="34" charset="-120"/>
               </a:rPr>
               <a:t>−1,257</a:t>
-            </a:r>
-            <a:endParaRPr lang="en-US" sz="1300" dirty="0"/>
-          </a:p>
-        </p:txBody>
-      </p:sp>
-      <p:sp>
-        <p:nvSpPr>
-          <p:cNvPr id="166" name="Text 164"/>
-          <p:cNvSpPr txBox="1"/>
-          <p:nvPr/>
-        </p:nvSpPr>
-        <p:spPr>
-          <a:xfrm>
-            <a:off x="10689336" y="3440296"/>
-            <a:ext cx="777240" cy="248502"/>
-          </a:xfrm>
-          <a:prstGeom prst="rect">
-            <a:avLst/>
-          </a:prstGeom>
-          <a:noFill/>
-          <a:ln/>
-        </p:spPr>
-        <p:txBody>
-          <a:bodyPr wrap="square" lIns="0" tIns="0" rIns="0" bIns="0" rtlCol="0" anchor="ctr"/>
-          <a:lstStyle/>
-          <a:p>
-            <a:pPr algn="r" indent="0" marL="0">
-              <a:buNone/>
-            </a:pPr>
-            <a:r>
-              <a:rPr lang="en-US" sz="1300" dirty="0">
-                <a:solidFill>
-                  <a:srgbClr val="595959"/>
-                </a:solidFill>
-                <a:latin typeface="Inter" pitchFamily="34" charset="0"/>
-                <a:ea typeface="Inter" pitchFamily="34" charset="-122"/>
-                <a:cs typeface="Inter" pitchFamily="34" charset="-120"/>
-              </a:rPr>
-              <a:t>4 of 4</a:t>
             </a:r>
             <a:endParaRPr lang="en-US" sz="1300" dirty="0"/>
           </a:p>
@@ -8411,6 +8411,45 @@
         <p:spPr>
           <a:xfrm>
             <a:off x="9820656" y="3688797"/>
+            <a:ext cx="777240" cy="248502"/>
+          </a:xfrm>
+          <a:prstGeom prst="rect">
+            <a:avLst/>
+          </a:prstGeom>
+          <a:noFill/>
+          <a:ln/>
+        </p:spPr>
+        <p:txBody>
+          <a:bodyPr wrap="square" lIns="0" tIns="0" rIns="0" bIns="0" rtlCol="0" anchor="ctr"/>
+          <a:lstStyle/>
+          <a:p>
+            <a:pPr algn="r" indent="0" marL="0">
+              <a:buNone/>
+            </a:pPr>
+            <a:r>
+              <a:rPr lang="en-US" sz="1300" dirty="0">
+                <a:solidFill>
+                  <a:srgbClr val="595959"/>
+                </a:solidFill>
+                <a:latin typeface="Inter" pitchFamily="34" charset="0"/>
+                <a:ea typeface="Inter" pitchFamily="34" charset="-122"/>
+                <a:cs typeface="Inter" pitchFamily="34" charset="-120"/>
+              </a:rPr>
+              <a:t>2 of 2</a:t>
+            </a:r>
+            <a:endParaRPr lang="en-US" sz="1300" dirty="0"/>
+          </a:p>
+        </p:txBody>
+      </p:sp>
+      <p:sp>
+        <p:nvSpPr>
+          <p:cNvPr id="172" name="Text 170"/>
+          <p:cNvSpPr txBox="1"/>
+          <p:nvPr/>
+        </p:nvSpPr>
+        <p:spPr>
+          <a:xfrm>
+            <a:off x="10597896" y="3688797"/>
             <a:ext cx="868680" cy="248502"/>
           </a:xfrm>
           <a:prstGeom prst="rect">
@@ -8436,45 +8475,6 @@
                 <a:cs typeface="Inter" pitchFamily="34" charset="-120"/>
               </a:rPr>
               <a:t>−1,152</a:t>
-            </a:r>
-            <a:endParaRPr lang="en-US" sz="1300" dirty="0"/>
-          </a:p>
-        </p:txBody>
-      </p:sp>
-      <p:sp>
-        <p:nvSpPr>
-          <p:cNvPr id="172" name="Text 170"/>
-          <p:cNvSpPr txBox="1"/>
-          <p:nvPr/>
-        </p:nvSpPr>
-        <p:spPr>
-          <a:xfrm>
-            <a:off x="10689336" y="3688797"/>
-            <a:ext cx="777240" cy="248502"/>
-          </a:xfrm>
-          <a:prstGeom prst="rect">
-            <a:avLst/>
-          </a:prstGeom>
-          <a:noFill/>
-          <a:ln/>
-        </p:spPr>
-        <p:txBody>
-          <a:bodyPr wrap="square" lIns="0" tIns="0" rIns="0" bIns="0" rtlCol="0" anchor="ctr"/>
-          <a:lstStyle/>
-          <a:p>
-            <a:pPr algn="r" indent="0" marL="0">
-              <a:buNone/>
-            </a:pPr>
-            <a:r>
-              <a:rPr lang="en-US" sz="1300" dirty="0">
-                <a:solidFill>
-                  <a:srgbClr val="595959"/>
-                </a:solidFill>
-                <a:latin typeface="Inter" pitchFamily="34" charset="0"/>
-                <a:ea typeface="Inter" pitchFamily="34" charset="-122"/>
-                <a:cs typeface="Inter" pitchFamily="34" charset="-120"/>
-              </a:rPr>
-              <a:t>2 of 2</a:t>
             </a:r>
             <a:endParaRPr lang="en-US" sz="1300" dirty="0"/>
           </a:p>
@@ -8626,6 +8626,45 @@
         <p:spPr>
           <a:xfrm>
             <a:off x="9820656" y="3937299"/>
+            <a:ext cx="777240" cy="248502"/>
+          </a:xfrm>
+          <a:prstGeom prst="rect">
+            <a:avLst/>
+          </a:prstGeom>
+          <a:noFill/>
+          <a:ln/>
+        </p:spPr>
+        <p:txBody>
+          <a:bodyPr wrap="square" lIns="0" tIns="0" rIns="0" bIns="0" rtlCol="0" anchor="ctr"/>
+          <a:lstStyle/>
+          <a:p>
+            <a:pPr algn="r" indent="0" marL="0">
+              <a:buNone/>
+            </a:pPr>
+            <a:r>
+              <a:rPr lang="en-US" sz="1300" dirty="0">
+                <a:solidFill>
+                  <a:srgbClr val="595959"/>
+                </a:solidFill>
+                <a:latin typeface="Inter" pitchFamily="34" charset="0"/>
+                <a:ea typeface="Inter" pitchFamily="34" charset="-122"/>
+                <a:cs typeface="Inter" pitchFamily="34" charset="-120"/>
+              </a:rPr>
+              <a:t>4 of 4</a:t>
+            </a:r>
+            <a:endParaRPr lang="en-US" sz="1300" dirty="0"/>
+          </a:p>
+        </p:txBody>
+      </p:sp>
+      <p:sp>
+        <p:nvSpPr>
+          <p:cNvPr id="178" name="Text 176"/>
+          <p:cNvSpPr txBox="1"/>
+          <p:nvPr/>
+        </p:nvSpPr>
+        <p:spPr>
+          <a:xfrm>
+            <a:off x="10597896" y="3937299"/>
             <a:ext cx="868680" cy="248502"/>
           </a:xfrm>
           <a:prstGeom prst="rect">
@@ -8651,45 +8690,6 @@
                 <a:cs typeface="Inter" pitchFamily="34" charset="-120"/>
               </a:rPr>
               <a:t>−1,906</a:t>
-            </a:r>
-            <a:endParaRPr lang="en-US" sz="1300" dirty="0"/>
-          </a:p>
-        </p:txBody>
-      </p:sp>
-      <p:sp>
-        <p:nvSpPr>
-          <p:cNvPr id="178" name="Text 176"/>
-          <p:cNvSpPr txBox="1"/>
-          <p:nvPr/>
-        </p:nvSpPr>
-        <p:spPr>
-          <a:xfrm>
-            <a:off x="10689336" y="3937299"/>
-            <a:ext cx="777240" cy="248502"/>
-          </a:xfrm>
-          <a:prstGeom prst="rect">
-            <a:avLst/>
-          </a:prstGeom>
-          <a:noFill/>
-          <a:ln/>
-        </p:spPr>
-        <p:txBody>
-          <a:bodyPr wrap="square" lIns="0" tIns="0" rIns="0" bIns="0" rtlCol="0" anchor="ctr"/>
-          <a:lstStyle/>
-          <a:p>
-            <a:pPr algn="r" indent="0" marL="0">
-              <a:buNone/>
-            </a:pPr>
-            <a:r>
-              <a:rPr lang="en-US" sz="1300" dirty="0">
-                <a:solidFill>
-                  <a:srgbClr val="595959"/>
-                </a:solidFill>
-                <a:latin typeface="Inter" pitchFamily="34" charset="0"/>
-                <a:ea typeface="Inter" pitchFamily="34" charset="-122"/>
-                <a:cs typeface="Inter" pitchFamily="34" charset="-120"/>
-              </a:rPr>
-              <a:t>4 of 4</a:t>
             </a:r>
             <a:endParaRPr lang="en-US" sz="1300" dirty="0"/>
           </a:p>
@@ -8841,6 +8841,45 @@
         <p:spPr>
           <a:xfrm>
             <a:off x="9820656" y="4185800"/>
+            <a:ext cx="777240" cy="248502"/>
+          </a:xfrm>
+          <a:prstGeom prst="rect">
+            <a:avLst/>
+          </a:prstGeom>
+          <a:noFill/>
+          <a:ln/>
+        </p:spPr>
+        <p:txBody>
+          <a:bodyPr wrap="square" lIns="0" tIns="0" rIns="0" bIns="0" rtlCol="0" anchor="ctr"/>
+          <a:lstStyle/>
+          <a:p>
+            <a:pPr algn="r" indent="0" marL="0">
+              <a:buNone/>
+            </a:pPr>
+            <a:r>
+              <a:rPr lang="en-US" sz="1300" dirty="0">
+                <a:solidFill>
+                  <a:srgbClr val="595959"/>
+                </a:solidFill>
+                <a:latin typeface="Inter" pitchFamily="34" charset="0"/>
+                <a:ea typeface="Inter" pitchFamily="34" charset="-122"/>
+                <a:cs typeface="Inter" pitchFamily="34" charset="-120"/>
+              </a:rPr>
+              <a:t>4 of 4</a:t>
+            </a:r>
+            <a:endParaRPr lang="en-US" sz="1300" dirty="0"/>
+          </a:p>
+        </p:txBody>
+      </p:sp>
+      <p:sp>
+        <p:nvSpPr>
+          <p:cNvPr id="184" name="Text 182"/>
+          <p:cNvSpPr txBox="1"/>
+          <p:nvPr/>
+        </p:nvSpPr>
+        <p:spPr>
+          <a:xfrm>
+            <a:off x="10597896" y="4185800"/>
             <a:ext cx="868680" cy="248502"/>
           </a:xfrm>
           <a:prstGeom prst="rect">
@@ -8866,45 +8905,6 @@
                 <a:cs typeface="Inter" pitchFamily="34" charset="-120"/>
               </a:rPr>
               <a:t>−1,863</a:t>
-            </a:r>
-            <a:endParaRPr lang="en-US" sz="1300" dirty="0"/>
-          </a:p>
-        </p:txBody>
-      </p:sp>
-      <p:sp>
-        <p:nvSpPr>
-          <p:cNvPr id="184" name="Text 182"/>
-          <p:cNvSpPr txBox="1"/>
-          <p:nvPr/>
-        </p:nvSpPr>
-        <p:spPr>
-          <a:xfrm>
-            <a:off x="10689336" y="4185800"/>
-            <a:ext cx="777240" cy="248502"/>
-          </a:xfrm>
-          <a:prstGeom prst="rect">
-            <a:avLst/>
-          </a:prstGeom>
-          <a:noFill/>
-          <a:ln/>
-        </p:spPr>
-        <p:txBody>
-          <a:bodyPr wrap="square" lIns="0" tIns="0" rIns="0" bIns="0" rtlCol="0" anchor="ctr"/>
-          <a:lstStyle/>
-          <a:p>
-            <a:pPr algn="r" indent="0" marL="0">
-              <a:buNone/>
-            </a:pPr>
-            <a:r>
-              <a:rPr lang="en-US" sz="1300" dirty="0">
-                <a:solidFill>
-                  <a:srgbClr val="595959"/>
-                </a:solidFill>
-                <a:latin typeface="Inter" pitchFamily="34" charset="0"/>
-                <a:ea typeface="Inter" pitchFamily="34" charset="-122"/>
-                <a:cs typeface="Inter" pitchFamily="34" charset="-120"/>
-              </a:rPr>
-              <a:t>4 of 4</a:t>
             </a:r>
             <a:endParaRPr lang="en-US" sz="1300" dirty="0"/>
           </a:p>
@@ -9056,6 +9056,45 @@
         <p:spPr>
           <a:xfrm>
             <a:off x="9820656" y="4434302"/>
+            <a:ext cx="777240" cy="248502"/>
+          </a:xfrm>
+          <a:prstGeom prst="rect">
+            <a:avLst/>
+          </a:prstGeom>
+          <a:noFill/>
+          <a:ln/>
+        </p:spPr>
+        <p:txBody>
+          <a:bodyPr wrap="square" lIns="0" tIns="0" rIns="0" bIns="0" rtlCol="0" anchor="ctr"/>
+          <a:lstStyle/>
+          <a:p>
+            <a:pPr algn="r" indent="0" marL="0">
+              <a:buNone/>
+            </a:pPr>
+            <a:r>
+              <a:rPr lang="en-US" sz="1300" dirty="0">
+                <a:solidFill>
+                  <a:srgbClr val="595959"/>
+                </a:solidFill>
+                <a:latin typeface="Inter" pitchFamily="34" charset="0"/>
+                <a:ea typeface="Inter" pitchFamily="34" charset="-122"/>
+                <a:cs typeface="Inter" pitchFamily="34" charset="-120"/>
+              </a:rPr>
+              <a:t>4 of 4</a:t>
+            </a:r>
+            <a:endParaRPr lang="en-US" sz="1300" dirty="0"/>
+          </a:p>
+        </p:txBody>
+      </p:sp>
+      <p:sp>
+        <p:nvSpPr>
+          <p:cNvPr id="190" name="Text 188"/>
+          <p:cNvSpPr txBox="1"/>
+          <p:nvPr/>
+        </p:nvSpPr>
+        <p:spPr>
+          <a:xfrm>
+            <a:off x="10597896" y="4434302"/>
             <a:ext cx="868680" cy="248502"/>
           </a:xfrm>
           <a:prstGeom prst="rect">
@@ -9081,45 +9120,6 @@
                 <a:cs typeface="Inter" pitchFamily="34" charset="-120"/>
               </a:rPr>
               <a:t>−1,708</a:t>
-            </a:r>
-            <a:endParaRPr lang="en-US" sz="1300" dirty="0"/>
-          </a:p>
-        </p:txBody>
-      </p:sp>
-      <p:sp>
-        <p:nvSpPr>
-          <p:cNvPr id="190" name="Text 188"/>
-          <p:cNvSpPr txBox="1"/>
-          <p:nvPr/>
-        </p:nvSpPr>
-        <p:spPr>
-          <a:xfrm>
-            <a:off x="10689336" y="4434302"/>
-            <a:ext cx="777240" cy="248502"/>
-          </a:xfrm>
-          <a:prstGeom prst="rect">
-            <a:avLst/>
-          </a:prstGeom>
-          <a:noFill/>
-          <a:ln/>
-        </p:spPr>
-        <p:txBody>
-          <a:bodyPr wrap="square" lIns="0" tIns="0" rIns="0" bIns="0" rtlCol="0" anchor="ctr"/>
-          <a:lstStyle/>
-          <a:p>
-            <a:pPr algn="r" indent="0" marL="0">
-              <a:buNone/>
-            </a:pPr>
-            <a:r>
-              <a:rPr lang="en-US" sz="1300" dirty="0">
-                <a:solidFill>
-                  <a:srgbClr val="595959"/>
-                </a:solidFill>
-                <a:latin typeface="Inter" pitchFamily="34" charset="0"/>
-                <a:ea typeface="Inter" pitchFamily="34" charset="-122"/>
-                <a:cs typeface="Inter" pitchFamily="34" charset="-120"/>
-              </a:rPr>
-              <a:t>4 of 4</a:t>
             </a:r>
             <a:endParaRPr lang="en-US" sz="1300" dirty="0"/>
           </a:p>
@@ -9271,6 +9271,45 @@
         <p:spPr>
           <a:xfrm>
             <a:off x="9820656" y="4682804"/>
+            <a:ext cx="777240" cy="248502"/>
+          </a:xfrm>
+          <a:prstGeom prst="rect">
+            <a:avLst/>
+          </a:prstGeom>
+          <a:noFill/>
+          <a:ln/>
+        </p:spPr>
+        <p:txBody>
+          <a:bodyPr wrap="square" lIns="0" tIns="0" rIns="0" bIns="0" rtlCol="0" anchor="ctr"/>
+          <a:lstStyle/>
+          <a:p>
+            <a:pPr algn="r" indent="0" marL="0">
+              <a:buNone/>
+            </a:pPr>
+            <a:r>
+              <a:rPr lang="en-US" sz="1300" dirty="0">
+                <a:solidFill>
+                  <a:srgbClr val="595959"/>
+                </a:solidFill>
+                <a:latin typeface="Inter" pitchFamily="34" charset="0"/>
+                <a:ea typeface="Inter" pitchFamily="34" charset="-122"/>
+                <a:cs typeface="Inter" pitchFamily="34" charset="-120"/>
+              </a:rPr>
+              <a:t>3 of 4</a:t>
+            </a:r>
+            <a:endParaRPr lang="en-US" sz="1300" dirty="0"/>
+          </a:p>
+        </p:txBody>
+      </p:sp>
+      <p:sp>
+        <p:nvSpPr>
+          <p:cNvPr id="196" name="Text 194"/>
+          <p:cNvSpPr txBox="1"/>
+          <p:nvPr/>
+        </p:nvSpPr>
+        <p:spPr>
+          <a:xfrm>
+            <a:off x="10597896" y="4682804"/>
             <a:ext cx="868680" cy="248502"/>
           </a:xfrm>
           <a:prstGeom prst="rect">
@@ -9296,45 +9335,6 @@
                 <a:cs typeface="Inter" pitchFamily="34" charset="-120"/>
               </a:rPr>
               <a:t>−3,005</a:t>
-            </a:r>
-            <a:endParaRPr lang="en-US" sz="1300" dirty="0"/>
-          </a:p>
-        </p:txBody>
-      </p:sp>
-      <p:sp>
-        <p:nvSpPr>
-          <p:cNvPr id="196" name="Text 194"/>
-          <p:cNvSpPr txBox="1"/>
-          <p:nvPr/>
-        </p:nvSpPr>
-        <p:spPr>
-          <a:xfrm>
-            <a:off x="10689336" y="4682804"/>
-            <a:ext cx="777240" cy="248502"/>
-          </a:xfrm>
-          <a:prstGeom prst="rect">
-            <a:avLst/>
-          </a:prstGeom>
-          <a:noFill/>
-          <a:ln/>
-        </p:spPr>
-        <p:txBody>
-          <a:bodyPr wrap="square" lIns="0" tIns="0" rIns="0" bIns="0" rtlCol="0" anchor="ctr"/>
-          <a:lstStyle/>
-          <a:p>
-            <a:pPr algn="r" indent="0" marL="0">
-              <a:buNone/>
-            </a:pPr>
-            <a:r>
-              <a:rPr lang="en-US" sz="1300" dirty="0">
-                <a:solidFill>
-                  <a:srgbClr val="595959"/>
-                </a:solidFill>
-                <a:latin typeface="Inter" pitchFamily="34" charset="0"/>
-                <a:ea typeface="Inter" pitchFamily="34" charset="-122"/>
-                <a:cs typeface="Inter" pitchFamily="34" charset="-120"/>
-              </a:rPr>
-              <a:t>3 of 4</a:t>
             </a:r>
             <a:endParaRPr lang="en-US" sz="1300" dirty="0"/>
           </a:p>
@@ -9486,6 +9486,45 @@
         <p:spPr>
           <a:xfrm>
             <a:off x="9820656" y="4931305"/>
+            <a:ext cx="777240" cy="248502"/>
+          </a:xfrm>
+          <a:prstGeom prst="rect">
+            <a:avLst/>
+          </a:prstGeom>
+          <a:noFill/>
+          <a:ln/>
+        </p:spPr>
+        <p:txBody>
+          <a:bodyPr wrap="square" lIns="0" tIns="0" rIns="0" bIns="0" rtlCol="0" anchor="ctr"/>
+          <a:lstStyle/>
+          <a:p>
+            <a:pPr algn="r" indent="0" marL="0">
+              <a:buNone/>
+            </a:pPr>
+            <a:r>
+              <a:rPr lang="en-US" sz="1300" dirty="0">
+                <a:solidFill>
+                  <a:srgbClr val="595959"/>
+                </a:solidFill>
+                <a:latin typeface="Inter" pitchFamily="34" charset="0"/>
+                <a:ea typeface="Inter" pitchFamily="34" charset="-122"/>
+                <a:cs typeface="Inter" pitchFamily="34" charset="-120"/>
+              </a:rPr>
+              <a:t>4 of 4</a:t>
+            </a:r>
+            <a:endParaRPr lang="en-US" sz="1300" dirty="0"/>
+          </a:p>
+        </p:txBody>
+      </p:sp>
+      <p:sp>
+        <p:nvSpPr>
+          <p:cNvPr id="202" name="Text 200"/>
+          <p:cNvSpPr txBox="1"/>
+          <p:nvPr/>
+        </p:nvSpPr>
+        <p:spPr>
+          <a:xfrm>
+            <a:off x="10597896" y="4931305"/>
             <a:ext cx="868680" cy="248502"/>
           </a:xfrm>
           <a:prstGeom prst="rect">
@@ -9518,13 +9557,13 @@
       </p:sp>
       <p:sp>
         <p:nvSpPr>
-          <p:cNvPr id="202" name="Shape 200"/>
+          <p:cNvPr id="203" name="Shape 201"/>
           <p:cNvSpPr/>
           <p:nvPr/>
         </p:nvSpPr>
         <p:spPr>
           <a:xfrm>
-            <a:off x="10744200" y="4977025"/>
+            <a:off x="11521440" y="4977025"/>
             <a:ext cx="54864" cy="157062"/>
           </a:xfrm>
           <a:prstGeom prst="rect">
@@ -9538,45 +9577,6 @@
       </p:sp>
       <p:sp>
         <p:nvSpPr>
-          <p:cNvPr id="203" name="Text 201"/>
-          <p:cNvSpPr txBox="1"/>
-          <p:nvPr/>
-        </p:nvSpPr>
-        <p:spPr>
-          <a:xfrm>
-            <a:off x="10689336" y="4931305"/>
-            <a:ext cx="777240" cy="248502"/>
-          </a:xfrm>
-          <a:prstGeom prst="rect">
-            <a:avLst/>
-          </a:prstGeom>
-          <a:noFill/>
-          <a:ln/>
-        </p:spPr>
-        <p:txBody>
-          <a:bodyPr wrap="square" lIns="0" tIns="0" rIns="0" bIns="0" rtlCol="0" anchor="ctr"/>
-          <a:lstStyle/>
-          <a:p>
-            <a:pPr algn="r" indent="0" marL="0">
-              <a:buNone/>
-            </a:pPr>
-            <a:r>
-              <a:rPr lang="en-US" sz="1300" dirty="0">
-                <a:solidFill>
-                  <a:srgbClr val="595959"/>
-                </a:solidFill>
-                <a:latin typeface="Inter" pitchFamily="34" charset="0"/>
-                <a:ea typeface="Inter" pitchFamily="34" charset="-122"/>
-                <a:cs typeface="Inter" pitchFamily="34" charset="-120"/>
-              </a:rPr>
-              <a:t>4 of 4</a:t>
-            </a:r>
-            <a:endParaRPr lang="en-US" sz="1300" dirty="0"/>
-          </a:p>
-        </p:txBody>
-      </p:sp>
-      <p:sp>
-        <p:nvSpPr>
           <p:cNvPr id="204" name="Text 202"/>
           <p:cNvSpPr txBox="1"/>
           <p:nvPr/>
@@ -9721,6 +9721,45 @@
         <p:spPr>
           <a:xfrm>
             <a:off x="9820656" y="5179807"/>
+            <a:ext cx="777240" cy="248502"/>
+          </a:xfrm>
+          <a:prstGeom prst="rect">
+            <a:avLst/>
+          </a:prstGeom>
+          <a:noFill/>
+          <a:ln/>
+        </p:spPr>
+        <p:txBody>
+          <a:bodyPr wrap="square" lIns="0" tIns="0" rIns="0" bIns="0" rtlCol="0" anchor="ctr"/>
+          <a:lstStyle/>
+          <a:p>
+            <a:pPr algn="r" indent="0" marL="0">
+              <a:buNone/>
+            </a:pPr>
+            <a:r>
+              <a:rPr lang="en-US" sz="1300" dirty="0">
+                <a:solidFill>
+                  <a:srgbClr val="595959"/>
+                </a:solidFill>
+                <a:latin typeface="Inter" pitchFamily="34" charset="0"/>
+                <a:ea typeface="Inter" pitchFamily="34" charset="-122"/>
+                <a:cs typeface="Inter" pitchFamily="34" charset="-120"/>
+              </a:rPr>
+              <a:t>4 of 4</a:t>
+            </a:r>
+            <a:endParaRPr lang="en-US" sz="1300" dirty="0"/>
+          </a:p>
+        </p:txBody>
+      </p:sp>
+      <p:sp>
+        <p:nvSpPr>
+          <p:cNvPr id="209" name="Text 207"/>
+          <p:cNvSpPr txBox="1"/>
+          <p:nvPr/>
+        </p:nvSpPr>
+        <p:spPr>
+          <a:xfrm>
+            <a:off x="10597896" y="5179807"/>
             <a:ext cx="868680" cy="248502"/>
           </a:xfrm>
           <a:prstGeom prst="rect">
@@ -9753,13 +9792,13 @@
       </p:sp>
       <p:sp>
         <p:nvSpPr>
-          <p:cNvPr id="209" name="Shape 207"/>
+          <p:cNvPr id="210" name="Shape 208"/>
           <p:cNvSpPr/>
           <p:nvPr/>
         </p:nvSpPr>
         <p:spPr>
           <a:xfrm>
-            <a:off x="10744200" y="5225527"/>
+            <a:off x="11521440" y="5225527"/>
             <a:ext cx="54864" cy="157062"/>
           </a:xfrm>
           <a:prstGeom prst="rect">
@@ -9773,45 +9812,6 @@
       </p:sp>
       <p:sp>
         <p:nvSpPr>
-          <p:cNvPr id="210" name="Text 208"/>
-          <p:cNvSpPr txBox="1"/>
-          <p:nvPr/>
-        </p:nvSpPr>
-        <p:spPr>
-          <a:xfrm>
-            <a:off x="10689336" y="5179807"/>
-            <a:ext cx="777240" cy="248502"/>
-          </a:xfrm>
-          <a:prstGeom prst="rect">
-            <a:avLst/>
-          </a:prstGeom>
-          <a:noFill/>
-          <a:ln/>
-        </p:spPr>
-        <p:txBody>
-          <a:bodyPr wrap="square" lIns="0" tIns="0" rIns="0" bIns="0" rtlCol="0" anchor="ctr"/>
-          <a:lstStyle/>
-          <a:p>
-            <a:pPr algn="r" indent="0" marL="0">
-              <a:buNone/>
-            </a:pPr>
-            <a:r>
-              <a:rPr lang="en-US" sz="1300" dirty="0">
-                <a:solidFill>
-                  <a:srgbClr val="595959"/>
-                </a:solidFill>
-                <a:latin typeface="Inter" pitchFamily="34" charset="0"/>
-                <a:ea typeface="Inter" pitchFamily="34" charset="-122"/>
-                <a:cs typeface="Inter" pitchFamily="34" charset="-120"/>
-              </a:rPr>
-              <a:t>4 of 4</a:t>
-            </a:r>
-            <a:endParaRPr lang="en-US" sz="1300" dirty="0"/>
-          </a:p>
-        </p:txBody>
-      </p:sp>
-      <p:sp>
-        <p:nvSpPr>
           <p:cNvPr id="211" name="Text 209"/>
           <p:cNvSpPr txBox="1"/>
           <p:nvPr/>
@@ -9956,6 +9956,45 @@
         <p:spPr>
           <a:xfrm>
             <a:off x="9820656" y="5428309"/>
+            <a:ext cx="777240" cy="248502"/>
+          </a:xfrm>
+          <a:prstGeom prst="rect">
+            <a:avLst/>
+          </a:prstGeom>
+          <a:noFill/>
+          <a:ln/>
+        </p:spPr>
+        <p:txBody>
+          <a:bodyPr wrap="square" lIns="0" tIns="0" rIns="0" bIns="0" rtlCol="0" anchor="ctr"/>
+          <a:lstStyle/>
+          <a:p>
+            <a:pPr algn="r" indent="0" marL="0">
+              <a:buNone/>
+            </a:pPr>
+            <a:r>
+              <a:rPr lang="en-US" sz="1300" dirty="0">
+                <a:solidFill>
+                  <a:srgbClr val="595959"/>
+                </a:solidFill>
+                <a:latin typeface="Inter" pitchFamily="34" charset="0"/>
+                <a:ea typeface="Inter" pitchFamily="34" charset="-122"/>
+                <a:cs typeface="Inter" pitchFamily="34" charset="-120"/>
+              </a:rPr>
+              <a:t>4 of 4</a:t>
+            </a:r>
+            <a:endParaRPr lang="en-US" sz="1300" dirty="0"/>
+          </a:p>
+        </p:txBody>
+      </p:sp>
+      <p:sp>
+        <p:nvSpPr>
+          <p:cNvPr id="216" name="Text 214"/>
+          <p:cNvSpPr txBox="1"/>
+          <p:nvPr/>
+        </p:nvSpPr>
+        <p:spPr>
+          <a:xfrm>
+            <a:off x="10597896" y="5428309"/>
             <a:ext cx="868680" cy="248502"/>
           </a:xfrm>
           <a:prstGeom prst="rect">
@@ -9988,13 +10027,13 @@
       </p:sp>
       <p:sp>
         <p:nvSpPr>
-          <p:cNvPr id="216" name="Shape 214"/>
+          <p:cNvPr id="217" name="Shape 215"/>
           <p:cNvSpPr/>
           <p:nvPr/>
         </p:nvSpPr>
         <p:spPr>
           <a:xfrm>
-            <a:off x="10744200" y="5474029"/>
+            <a:off x="11521440" y="5474029"/>
             <a:ext cx="54864" cy="157062"/>
           </a:xfrm>
           <a:prstGeom prst="rect">
@@ -10005,45 +10044,6 @@
           </a:solidFill>
           <a:ln/>
         </p:spPr>
-      </p:sp>
-      <p:sp>
-        <p:nvSpPr>
-          <p:cNvPr id="217" name="Text 215"/>
-          <p:cNvSpPr txBox="1"/>
-          <p:nvPr/>
-        </p:nvSpPr>
-        <p:spPr>
-          <a:xfrm>
-            <a:off x="10689336" y="5428309"/>
-            <a:ext cx="777240" cy="248502"/>
-          </a:xfrm>
-          <a:prstGeom prst="rect">
-            <a:avLst/>
-          </a:prstGeom>
-          <a:noFill/>
-          <a:ln/>
-        </p:spPr>
-        <p:txBody>
-          <a:bodyPr wrap="square" lIns="0" tIns="0" rIns="0" bIns="0" rtlCol="0" anchor="ctr"/>
-          <a:lstStyle/>
-          <a:p>
-            <a:pPr algn="r" indent="0" marL="0">
-              <a:buNone/>
-            </a:pPr>
-            <a:r>
-              <a:rPr lang="en-US" sz="1300" dirty="0">
-                <a:solidFill>
-                  <a:srgbClr val="595959"/>
-                </a:solidFill>
-                <a:latin typeface="Inter" pitchFamily="34" charset="0"/>
-                <a:ea typeface="Inter" pitchFamily="34" charset="-122"/>
-                <a:cs typeface="Inter" pitchFamily="34" charset="-120"/>
-              </a:rPr>
-              <a:t>4 of 4</a:t>
-            </a:r>
-            <a:endParaRPr lang="en-US" sz="1300" dirty="0"/>
-          </a:p>
-        </p:txBody>
       </p:sp>
       <p:sp>
         <p:nvSpPr>

</xml_diff>